<commit_message>
Acknowledge Sara McArdle and Zbigniew Mikulski (LJI) for the sample data
They provided the majority of the test and demonstration data behind almost
every exercise, so the credit is prominent rather than a footnote:

- New docs/acknowledgements.md leading with the data contribution
- Dedicated acknowledgements slide in the deck, plus a line on the closing slide
- Credit block on the landing page and in the README
- Site-wide footer credit on every page, and a note beside the dataset table
- Mentioned in the I2K form answers
- TODO: confirm with them re public redistribution and preferred wording
</commit_message>
<xml_diff>
--- a/I2K_2026_QuPath_Extensions.pptx
+++ b/I2K_2026_QuPath_Extensions.pptx
@@ -54,9 +54,10 @@
     <p:sldId id="302" r:id="rId48"/>
     <p:sldId id="303" r:id="rId49"/>
     <p:sldId id="304" r:id="rId50"/>
+    <p:sldId id="305" r:id="rId51"/>
   </p:sldIdLst>
   <p:notesMasterIdLst>
-    <p:notesMasterId r:id="rId51"/>
+    <p:notesMasterId r:id="rId52"/>
   </p:notesMasterIdLst>
   <p:sldSz cx="12192000" cy="6858000"/>
   <p:notesSz cx="6858000" cy="12192000"/>
@@ -4446,6 +4447,94 @@
             <a:fld id="{F7021451-1387-4CA6-816F-3879F97B5CBC}" type="slidenum">
               <a:rPr lang="en-US"/>
               <a:t>5</a:t>
+            </a:fld>
+            <a:endParaRPr lang="en-US"/>
+          </a:p>
+        </p:txBody>
+      </p:sp>
+    </p:spTree>
+    <p:extLst>
+      <p:ext uri="{BB962C8B-B14F-4D97-AF65-F5344CB8AC3E}">
+        <p14:creationId xmlns:p14="http://schemas.microsoft.com/office/powerpoint/2010/main" val="1024086991"/>
+      </p:ext>
+    </p:extLst>
+  </p:cSld>
+  <p:clrMapOvr>
+    <a:masterClrMapping/>
+  </p:clrMapOvr>
+</p:notes>
+</file>
+
+<file path=ppt/notesSlides/notesSlide50.xml><?xml version="1.0" encoding="utf-8"?>
+<p:notes xmlns:a="http://schemas.openxmlformats.org/drawingml/2006/main" xmlns:r="http://schemas.openxmlformats.org/officeDocument/2006/relationships" xmlns:p="http://schemas.openxmlformats.org/presentationml/2006/main">
+  <p:cSld>
+    <p:spTree>
+      <p:nvGrpSpPr>
+        <p:cNvPr id="1" name=""/>
+        <p:cNvGrpSpPr/>
+        <p:nvPr/>
+      </p:nvGrpSpPr>
+      <p:grpSpPr>
+        <a:xfrm>
+          <a:off x="0" y="0"/>
+          <a:ext cx="0" cy="0"/>
+          <a:chOff x="0" y="0"/>
+          <a:chExt cx="0" cy="0"/>
+        </a:xfrm>
+      </p:grpSpPr>
+      <p:sp>
+        <p:nvSpPr>
+          <p:cNvPr id="2" name="Slide Image Placeholder 1"/>
+          <p:cNvSpPr>
+            <a:spLocks noGrp="1" noRot="1" noChangeAspect="1"/>
+          </p:cNvSpPr>
+          <p:nvPr>
+            <p:ph type="sldImg"/>
+          </p:nvPr>
+        </p:nvSpPr>
+        <p:spPr/>
+      </p:sp>
+      <p:sp>
+        <p:nvSpPr>
+          <p:cNvPr id="3" name="Notes Placeholder 2"/>
+          <p:cNvSpPr>
+            <a:spLocks noGrp="1"/>
+          </p:cNvSpPr>
+          <p:nvPr>
+            <p:ph type="body" idx="1"/>
+          </p:nvPr>
+        </p:nvSpPr>
+        <p:spPr/>
+        <p:txBody>
+          <a:bodyPr/>
+          <a:lstStyle/>
+          <a:p>
+            <a:r>
+              <a:rPr lang="en-US" dirty="0"/>
+              <a:t/>
+            </a:r>
+            <a:endParaRPr lang="en-US" dirty="0"/>
+          </a:p>
+        </p:txBody>
+      </p:sp>
+      <p:sp>
+        <p:nvSpPr>
+          <p:cNvPr id="4" name="Slide Number Placeholder 3"/>
+          <p:cNvSpPr>
+            <a:spLocks noGrp="1"/>
+          </p:cNvSpPr>
+          <p:nvPr>
+            <p:ph type="sldNum" sz="quarter" idx="10"/>
+          </p:nvPr>
+        </p:nvSpPr>
+        <p:spPr/>
+        <p:txBody>
+          <a:bodyPr/>
+          <a:lstStyle/>
+          <a:p>
+            <a:fld id="{F7021451-1387-4CA6-816F-3879F97B5CBC}" type="slidenum">
+              <a:rPr lang="en-US"/>
+              <a:t>50</a:t>
             </a:fld>
             <a:endParaRPr lang="en-US"/>
           </a:p>
@@ -18747,14 +18836,53 @@
       </p:grpSpPr>
       <p:sp>
         <p:nvSpPr>
-          <p:cNvPr id="2" name="Shape 0"/>
-          <p:cNvSpPr/>
-          <p:nvPr/>
-        </p:nvSpPr>
-        <p:spPr>
-          <a:xfrm>
-            <a:off x="0" y="0"/>
-            <a:ext cx="274320" cy="6858000"/>
+          <p:cNvPr id="2" name="Text 0"/>
+          <p:cNvSpPr/>
+          <p:nvPr/>
+        </p:nvSpPr>
+        <p:spPr>
+          <a:xfrm>
+            <a:off x="566928" y="411480"/>
+            <a:ext cx="11055096" cy="685800"/>
+          </a:xfrm>
+          <a:prstGeom prst="rect">
+            <a:avLst/>
+          </a:prstGeom>
+          <a:noFill/>
+          <a:ln/>
+        </p:spPr>
+        <p:txBody>
+          <a:bodyPr wrap="square" rtlCol="0" anchor="ctr"/>
+          <a:lstStyle/>
+          <a:p>
+            <a:pPr indent="0" marL="0">
+              <a:buNone/>
+            </a:pPr>
+            <a:r>
+              <a:rPr lang="en-US" sz="3200" b="1" dirty="0">
+                <a:solidFill>
+                  <a:srgbClr val="1F4C86"/>
+                </a:solidFill>
+                <a:latin typeface="Trebuchet MS" pitchFamily="34" charset="0"/>
+                <a:ea typeface="Trebuchet MS" pitchFamily="34" charset="-122"/>
+                <a:cs typeface="Trebuchet MS" pitchFamily="34" charset="-120"/>
+              </a:rPr>
+              <a:t>Acknowledgements</a:t>
+            </a:r>
+            <a:endParaRPr lang="en-US" sz="3200" dirty="0"/>
+          </a:p>
+        </p:txBody>
+      </p:sp>
+      <p:sp>
+        <p:nvSpPr>
+          <p:cNvPr id="3" name="Shape 1"/>
+          <p:cNvSpPr/>
+          <p:nvPr/>
+        </p:nvSpPr>
+        <p:spPr>
+          <a:xfrm>
+            <a:off x="566928" y="1152144"/>
+            <a:ext cx="1920240" cy="50292"/>
           </a:xfrm>
           <a:prstGeom prst="rect">
             <a:avLst/>
@@ -18767,14 +18895,54 @@
       </p:sp>
       <p:sp>
         <p:nvSpPr>
-          <p:cNvPr id="3" name="Text 1"/>
-          <p:cNvSpPr/>
-          <p:nvPr/>
-        </p:nvSpPr>
-        <p:spPr>
-          <a:xfrm>
-            <a:off x="960120" y="777240"/>
-            <a:ext cx="10268712" cy="822960"/>
+          <p:cNvPr id="4" name="Shape 2"/>
+          <p:cNvSpPr/>
+          <p:nvPr/>
+        </p:nvSpPr>
+        <p:spPr>
+          <a:xfrm>
+            <a:off x="566928" y="1572768"/>
+            <a:ext cx="11055096" cy="2240280"/>
+          </a:xfrm>
+          <a:prstGeom prst="rect">
+            <a:avLst/>
+          </a:prstGeom>
+          <a:solidFill>
+            <a:srgbClr val="E8F0FA"/>
+          </a:solidFill>
+          <a:ln/>
+        </p:spPr>
+      </p:sp>
+      <p:sp>
+        <p:nvSpPr>
+          <p:cNvPr id="5" name="Shape 3"/>
+          <p:cNvSpPr/>
+          <p:nvPr/>
+        </p:nvSpPr>
+        <p:spPr>
+          <a:xfrm>
+            <a:off x="566928" y="1572768"/>
+            <a:ext cx="146304" cy="2240280"/>
+          </a:xfrm>
+          <a:prstGeom prst="rect">
+            <a:avLst/>
+          </a:prstGeom>
+          <a:solidFill>
+            <a:srgbClr val="3674C1"/>
+          </a:solidFill>
+          <a:ln/>
+        </p:spPr>
+      </p:sp>
+      <p:sp>
+        <p:nvSpPr>
+          <p:cNvPr id="6" name="Text 4"/>
+          <p:cNvSpPr/>
+          <p:nvPr/>
+        </p:nvSpPr>
+        <p:spPr>
+          <a:xfrm>
+            <a:off x="978408" y="1737360"/>
+            <a:ext cx="10232136" cy="365760"/>
           </a:xfrm>
           <a:prstGeom prst="rect">
             <a:avLst/>
@@ -18790,7 +18958,46 @@
               <a:buNone/>
             </a:pPr>
             <a:r>
-              <a:rPr lang="en-US" sz="4000" b="1" dirty="0">
+              <a:rPr lang="en-US" sz="1600" b="1" spc="150" kern="0" dirty="0">
+                <a:solidFill>
+                  <a:srgbClr val="3674C1"/>
+                </a:solidFill>
+                <a:latin typeface="Calibri" pitchFamily="34" charset="0"/>
+                <a:ea typeface="Calibri" pitchFamily="34" charset="-122"/>
+                <a:cs typeface="Calibri" pitchFamily="34" charset="-120"/>
+              </a:rPr>
+              <a:t>Sample data</a:t>
+            </a:r>
+            <a:endParaRPr lang="en-US" sz="1600" dirty="0"/>
+          </a:p>
+        </p:txBody>
+      </p:sp>
+      <p:sp>
+        <p:nvSpPr>
+          <p:cNvPr id="7" name="Text 5"/>
+          <p:cNvSpPr/>
+          <p:nvPr/>
+        </p:nvSpPr>
+        <p:spPr>
+          <a:xfrm>
+            <a:off x="978408" y="2103120"/>
+            <a:ext cx="10232136" cy="566928"/>
+          </a:xfrm>
+          <a:prstGeom prst="rect">
+            <a:avLst/>
+          </a:prstGeom>
+          <a:noFill/>
+          <a:ln/>
+        </p:spPr>
+        <p:txBody>
+          <a:bodyPr wrap="square" rtlCol="0" anchor="ctr"/>
+          <a:lstStyle/>
+          <a:p>
+            <a:pPr indent="0" marL="0">
+              <a:buNone/>
+            </a:pPr>
+            <a:r>
+              <a:rPr lang="en-US" sz="3200" b="1" dirty="0">
                 <a:solidFill>
                   <a:srgbClr val="1F4C86"/>
                 </a:solidFill>
@@ -18798,42 +19005,22 @@
                 <a:ea typeface="Trebuchet MS" pitchFamily="34" charset="-122"/>
                 <a:cs typeface="Trebuchet MS" pitchFamily="34" charset="-120"/>
               </a:rPr>
-              <a:t>Everything is here</a:t>
-            </a:r>
-            <a:endParaRPr lang="en-US" sz="4000" dirty="0"/>
-          </a:p>
-        </p:txBody>
-      </p:sp>
-      <p:sp>
-        <p:nvSpPr>
-          <p:cNvPr id="4" name="Shape 2"/>
-          <p:cNvSpPr/>
-          <p:nvPr/>
-        </p:nvSpPr>
-        <p:spPr>
-          <a:xfrm>
-            <a:off x="960120" y="1691640"/>
-            <a:ext cx="8686800" cy="713232"/>
-          </a:xfrm>
-          <a:prstGeom prst="rect">
-            <a:avLst/>
-          </a:prstGeom>
-          <a:solidFill>
-            <a:srgbClr val="E8F0FA"/>
-          </a:solidFill>
-          <a:ln/>
-        </p:spPr>
-      </p:sp>
-      <p:sp>
-        <p:nvSpPr>
-          <p:cNvPr id="5" name="Text 3"/>
-          <p:cNvSpPr/>
-          <p:nvPr/>
-        </p:nvSpPr>
-        <p:spPr>
-          <a:xfrm>
-            <a:off x="1188720" y="1691640"/>
-            <a:ext cx="8412480" cy="713232"/>
+              <a:t>Sara McArdle  ·  Zbigniew Mikulski</a:t>
+            </a:r>
+            <a:endParaRPr lang="en-US" sz="3200" dirty="0"/>
+          </a:p>
+        </p:txBody>
+      </p:sp>
+      <p:sp>
+        <p:nvSpPr>
+          <p:cNvPr id="8" name="Text 6"/>
+          <p:cNvSpPr/>
+          <p:nvPr/>
+        </p:nvSpPr>
+        <p:spPr>
+          <a:xfrm>
+            <a:off x="978408" y="2670048"/>
+            <a:ext cx="10232136" cy="384048"/>
           </a:xfrm>
           <a:prstGeom prst="rect">
             <a:avLst/>
@@ -18849,30 +19036,92 @@
               <a:buNone/>
             </a:pPr>
             <a:r>
-              <a:rPr lang="en-US" sz="2200" b="1" dirty="0">
-                <a:solidFill>
-                  <a:srgbClr val="1F4C86"/>
-                </a:solidFill>
-                <a:latin typeface="Calibri" pitchFamily="34" charset="0"/>
-                <a:ea typeface="Calibri" pitchFamily="34" charset="-122"/>
-                <a:cs typeface="Calibri" pitchFamily="34" charset="-120"/>
-              </a:rPr>
-              <a:t>michaelsnelson.github.io/BINA-I2K-2026-QuPath-Extensions</a:t>
-            </a:r>
-            <a:endParaRPr lang="en-US" sz="2200" dirty="0"/>
-          </a:p>
-        </p:txBody>
-      </p:sp>
-      <p:sp>
-        <p:nvSpPr>
-          <p:cNvPr id="6" name="Text 4"/>
-          <p:cNvSpPr/>
-          <p:nvPr/>
-        </p:nvSpPr>
-        <p:spPr>
-          <a:xfrm>
-            <a:off x="960120" y="2697480"/>
-            <a:ext cx="9811512" cy="2560320"/>
+              <a:rPr lang="en-US" sz="2100" dirty="0">
+                <a:solidFill>
+                  <a:srgbClr val="1F2933"/>
+                </a:solidFill>
+                <a:latin typeface="Calibri" pitchFamily="34" charset="0"/>
+                <a:ea typeface="Calibri" pitchFamily="34" charset="-122"/>
+                <a:cs typeface="Calibri" pitchFamily="34" charset="-120"/>
+              </a:rPr>
+              <a:t>La Jolla Institute for Immunology</a:t>
+            </a:r>
+            <a:endParaRPr lang="en-US" sz="2100" dirty="0"/>
+          </a:p>
+        </p:txBody>
+      </p:sp>
+      <p:sp>
+        <p:nvSpPr>
+          <p:cNvPr id="9" name="Text 7"/>
+          <p:cNvSpPr/>
+          <p:nvPr/>
+        </p:nvSpPr>
+        <p:spPr>
+          <a:xfrm>
+            <a:off x="978408" y="3054096"/>
+            <a:ext cx="10232136" cy="731520"/>
+          </a:xfrm>
+          <a:prstGeom prst="rect">
+            <a:avLst/>
+          </a:prstGeom>
+          <a:noFill/>
+          <a:ln/>
+        </p:spPr>
+        <p:txBody>
+          <a:bodyPr wrap="square" rtlCol="0" anchor="ctr"/>
+          <a:lstStyle/>
+          <a:p>
+            <a:pPr indent="0" marL="0">
+              <a:lnSpc>
+                <a:spcPct val="110000"/>
+              </a:lnSpc>
+              <a:buNone/>
+            </a:pPr>
+            <a:r>
+              <a:rPr lang="en-US" sz="1700" i="1" dirty="0">
+                <a:solidFill>
+                  <a:srgbClr val="5A6675"/>
+                </a:solidFill>
+                <a:latin typeface="Calibri" pitchFamily="34" charset="0"/>
+                <a:ea typeface="Calibri" pitchFamily="34" charset="-122"/>
+                <a:cs typeface="Calibri" pitchFamily="34" charset="-120"/>
+              </a:rPr>
+              <a:t>They provided the majority of the test and demonstration data behind almost every exercise you will see today.</a:t>
+            </a:r>
+            <a:endParaRPr lang="en-US" sz="1700" dirty="0"/>
+          </a:p>
+          <a:p>
+            <a:pPr indent="0" marL="0">
+              <a:lnSpc>
+                <a:spcPct val="110000"/>
+              </a:lnSpc>
+              <a:buNone/>
+            </a:pPr>
+            <a:r>
+              <a:rPr lang="en-US" sz="1700" i="1" dirty="0">
+                <a:solidFill>
+                  <a:srgbClr val="5A6675"/>
+                </a:solidFill>
+                <a:latin typeface="Calibri" pitchFamily="34" charset="0"/>
+                <a:ea typeface="Calibri" pitchFamily="34" charset="-122"/>
+                <a:cs typeface="Calibri" pitchFamily="34" charset="-120"/>
+              </a:rPr>
+              <a:t>These tools could not have been built, tested, or taught without it.</a:t>
+            </a:r>
+            <a:endParaRPr lang="en-US" sz="1700" dirty="0"/>
+          </a:p>
+        </p:txBody>
+      </p:sp>
+      <p:sp>
+        <p:nvSpPr>
+          <p:cNvPr id="10" name="Text 8"/>
+          <p:cNvSpPr/>
+          <p:nvPr/>
+        </p:nvSpPr>
+        <p:spPr>
+          <a:xfrm>
+            <a:off x="566928" y="3977640"/>
+            <a:ext cx="11055096" cy="2103120"/>
           </a:xfrm>
           <a:prstGeom prst="rect">
             <a:avLst/>
@@ -18891,7 +19140,7 @@
               <a:buNone/>
             </a:pPr>
             <a:r>
-              <a:rPr lang="en-US" sz="1900" dirty="0">
+              <a:rPr lang="en-US" sz="1700" dirty="0">
                 <a:solidFill>
                   <a:srgbClr val="1F2933"/>
                 </a:solidFill>
@@ -18899,17 +19148,17 @@
                 <a:ea typeface="Calibri" pitchFamily="34" charset="-122"/>
                 <a:cs typeface="Calibri" pitchFamily="34" charset="-120"/>
               </a:rPr>
-              <a:t>A written walkthrough and a video for every tool  ·  setup instructions  ·  sample data  ·  these slides
+              <a:t>Sara McArdle also shaped the software directly — two of these extensions began as her Groovy scripts, and her FS2K course was the model for how the workshop pages are written.
 </a:t>
             </a:r>
             <a:pPr indent="0" marL="0">
               <a:spcAft>
-                <a:spcPts val="600"/>
+                <a:spcPts val="1000"/>
               </a:spcAft>
               <a:buNone/>
             </a:pPr>
             <a:r>
-              <a:rPr lang="en-US" sz="1900" dirty="0">
+              <a:rPr lang="en-US" sz="1700" dirty="0">
                 <a:solidFill>
                   <a:srgbClr val="1F2933"/>
                 </a:solidFill>
@@ -18917,50 +19166,14 @@
                 <a:ea typeface="Calibri" pitchFamily="34" charset="-122"/>
                 <a:cs typeface="Calibri" pitchFamily="34" charset="-120"/>
               </a:rPr>
-              <a:t>Add the two catalogs in QuPath, install only what interests you, and restart:
-</a:t>
-            </a:r>
-            <a:pPr indent="0" marL="0">
-              <a:spcAft>
-                <a:spcPts val="400"/>
-              </a:spcAft>
-              <a:buNone/>
-            </a:pPr>
-            <a:r>
-              <a:rPr lang="en-US" sz="1800" b="1" dirty="0">
-                <a:solidFill>
-                  <a:srgbClr val="1F4C86"/>
-                </a:solidFill>
-                <a:latin typeface="Calibri" pitchFamily="34" charset="0"/>
-                <a:ea typeface="Calibri" pitchFamily="34" charset="-122"/>
-                <a:cs typeface="Calibri" pitchFamily="34" charset="-120"/>
-              </a:rPr>
-              <a:t>github.com/uw-loci/qupath-catalog-mikenelson
-</a:t>
-            </a:r>
-            <a:pPr indent="0" marL="0">
-              <a:spcAft>
-                <a:spcPts val="1400"/>
-              </a:spcAft>
-              <a:buNone/>
-            </a:pPr>
-            <a:r>
-              <a:rPr lang="en-US" sz="1800" b="1" dirty="0">
-                <a:solidFill>
-                  <a:srgbClr val="1F4C86"/>
-                </a:solidFill>
-                <a:latin typeface="Calibri" pitchFamily="34" charset="0"/>
-                <a:ea typeface="Calibri" pitchFamily="34" charset="-122"/>
-                <a:cs typeface="Calibri" pitchFamily="34" charset="-120"/>
-              </a:rPr>
-              <a:t>github.com/uw-loci/qupath-catalog-qpsc
+              <a:t>Pete Bankhead and the QuPath team.  ·  CT-FIRE, CurveAlign, TACS and TWOMBLI for the fibre work.  ·  CytoMAP and QuBaLab for bringing clustering into QuPath.  ·  QUAREP-LiMi for the reporting standards.  ·  The image.sc community, where several of these features were first requested.
 </a:t>
             </a:r>
             <a:pPr indent="0" marL="0">
               <a:buNone/>
             </a:pPr>
             <a:r>
-              <a:rPr lang="en-US" sz="1900" b="1" dirty="0">
+              <a:rPr lang="en-US" sz="1700" b="1" dirty="0">
                 <a:solidFill>
                   <a:srgbClr val="1F4C86"/>
                 </a:solidFill>
@@ -18968,54 +19181,15 @@
                 <a:ea typeface="Calibri" pitchFamily="34" charset="-122"/>
                 <a:cs typeface="Calibri" pitchFamily="34" charset="-120"/>
               </a:rPr>
-              <a:t>Whatever we did not reach today, the walkthrough and the video are waiting for you.</a:t>
-            </a:r>
-            <a:endParaRPr lang="en-US" sz="1900" dirty="0"/>
-          </a:p>
-        </p:txBody>
-      </p:sp>
-      <p:sp>
-        <p:nvSpPr>
-          <p:cNvPr id="7" name="Text 5"/>
-          <p:cNvSpPr/>
-          <p:nvPr/>
-        </p:nvSpPr>
-        <p:spPr>
-          <a:xfrm>
-            <a:off x="960120" y="5532120"/>
-            <a:ext cx="9811512" cy="457200"/>
-          </a:xfrm>
-          <a:prstGeom prst="rect">
-            <a:avLst/>
-          </a:prstGeom>
-          <a:noFill/>
-          <a:ln/>
-        </p:spPr>
-        <p:txBody>
-          <a:bodyPr wrap="square" rtlCol="0" anchor="ctr"/>
-          <a:lstStyle/>
-          <a:p>
-            <a:pPr indent="0" marL="0">
-              <a:buNone/>
-            </a:pPr>
-            <a:r>
-              <a:rPr lang="en-US" sz="1800" i="1" dirty="0">
-                <a:solidFill>
-                  <a:srgbClr val="5A6675"/>
-                </a:solidFill>
-                <a:latin typeface="Calibri" pitchFamily="34" charset="0"/>
-                <a:ea typeface="Calibri" pitchFamily="34" charset="-122"/>
-                <a:cs typeface="Calibri" pitchFamily="34" charset="-120"/>
-              </a:rPr>
-              <a:t>Questions welcome now, during the hands-on hour, or by email afterwards.</a:t>
-            </a:r>
-            <a:endParaRPr lang="en-US" sz="1800" dirty="0"/>
-          </a:p>
-        </p:txBody>
-      </p:sp>
-      <p:sp>
-        <p:nvSpPr>
-          <p:cNvPr id="8" name="Text 6"/>
+              <a:t>Full credits: michaelsnelson.github.io/BINA-I2K-2026-QuPath-Extensions/docs/acknowledgements.html</a:t>
+            </a:r>
+            <a:endParaRPr lang="en-US" sz="1700" dirty="0"/>
+          </a:p>
+        </p:txBody>
+      </p:sp>
+      <p:sp>
+        <p:nvSpPr>
+          <p:cNvPr id="11" name="Text 9"/>
           <p:cNvSpPr/>
           <p:nvPr/>
         </p:nvSpPr>
@@ -19398,6 +19572,384 @@
                 <a:cs typeface="Calibri" pitchFamily="34" charset="-120"/>
               </a:rPr>
               <a:t>5</a:t>
+            </a:r>
+            <a:endParaRPr lang="en-US" sz="1400" dirty="0"/>
+          </a:p>
+        </p:txBody>
+      </p:sp>
+    </p:spTree>
+  </p:cSld>
+  <p:clrMapOvr>
+    <a:masterClrMapping/>
+  </p:clrMapOvr>
+</p:sld>
+</file>
+
+<file path=ppt/slides/slide50.xml><?xml version="1.0" encoding="utf-8"?>
+<p:sld xmlns:a="http://schemas.openxmlformats.org/drawingml/2006/main" xmlns:r="http://schemas.openxmlformats.org/officeDocument/2006/relationships" xmlns:p="http://schemas.openxmlformats.org/presentationml/2006/main">
+  <p:cSld name="Slide 50">
+    <p:bg>
+      <p:bgPr>
+        <a:solidFill>
+          <a:srgbClr val="FFFFFF"/>
+        </a:solidFill>
+      </p:bgPr>
+    </p:bg>
+    <p:spTree>
+      <p:nvGrpSpPr>
+        <p:cNvPr id="1" name=""/>
+        <p:cNvGrpSpPr/>
+        <p:nvPr/>
+      </p:nvGrpSpPr>
+      <p:grpSpPr>
+        <a:xfrm>
+          <a:off x="0" y="0"/>
+          <a:ext cx="0" cy="0"/>
+          <a:chOff x="0" y="0"/>
+          <a:chExt cx="0" cy="0"/>
+        </a:xfrm>
+      </p:grpSpPr>
+      <p:sp>
+        <p:nvSpPr>
+          <p:cNvPr id="2" name="Shape 0"/>
+          <p:cNvSpPr/>
+          <p:nvPr/>
+        </p:nvSpPr>
+        <p:spPr>
+          <a:xfrm>
+            <a:off x="0" y="0"/>
+            <a:ext cx="274320" cy="6858000"/>
+          </a:xfrm>
+          <a:prstGeom prst="rect">
+            <a:avLst/>
+          </a:prstGeom>
+          <a:solidFill>
+            <a:srgbClr val="3674C1"/>
+          </a:solidFill>
+          <a:ln/>
+        </p:spPr>
+      </p:sp>
+      <p:sp>
+        <p:nvSpPr>
+          <p:cNvPr id="3" name="Text 1"/>
+          <p:cNvSpPr/>
+          <p:nvPr/>
+        </p:nvSpPr>
+        <p:spPr>
+          <a:xfrm>
+            <a:off x="960120" y="777240"/>
+            <a:ext cx="10268712" cy="822960"/>
+          </a:xfrm>
+          <a:prstGeom prst="rect">
+            <a:avLst/>
+          </a:prstGeom>
+          <a:noFill/>
+          <a:ln/>
+        </p:spPr>
+        <p:txBody>
+          <a:bodyPr wrap="square" rtlCol="0" anchor="ctr"/>
+          <a:lstStyle/>
+          <a:p>
+            <a:pPr indent="0" marL="0">
+              <a:buNone/>
+            </a:pPr>
+            <a:r>
+              <a:rPr lang="en-US" sz="4000" b="1" dirty="0">
+                <a:solidFill>
+                  <a:srgbClr val="1F4C86"/>
+                </a:solidFill>
+                <a:latin typeface="Trebuchet MS" pitchFamily="34" charset="0"/>
+                <a:ea typeface="Trebuchet MS" pitchFamily="34" charset="-122"/>
+                <a:cs typeface="Trebuchet MS" pitchFamily="34" charset="-120"/>
+              </a:rPr>
+              <a:t>Everything is here</a:t>
+            </a:r>
+            <a:endParaRPr lang="en-US" sz="4000" dirty="0"/>
+          </a:p>
+        </p:txBody>
+      </p:sp>
+      <p:sp>
+        <p:nvSpPr>
+          <p:cNvPr id="4" name="Shape 2"/>
+          <p:cNvSpPr/>
+          <p:nvPr/>
+        </p:nvSpPr>
+        <p:spPr>
+          <a:xfrm>
+            <a:off x="960120" y="1691640"/>
+            <a:ext cx="8686800" cy="713232"/>
+          </a:xfrm>
+          <a:prstGeom prst="rect">
+            <a:avLst/>
+          </a:prstGeom>
+          <a:solidFill>
+            <a:srgbClr val="E8F0FA"/>
+          </a:solidFill>
+          <a:ln/>
+        </p:spPr>
+      </p:sp>
+      <p:sp>
+        <p:nvSpPr>
+          <p:cNvPr id="5" name="Text 3"/>
+          <p:cNvSpPr/>
+          <p:nvPr/>
+        </p:nvSpPr>
+        <p:spPr>
+          <a:xfrm>
+            <a:off x="1188720" y="1691640"/>
+            <a:ext cx="8412480" cy="713232"/>
+          </a:xfrm>
+          <a:prstGeom prst="rect">
+            <a:avLst/>
+          </a:prstGeom>
+          <a:noFill/>
+          <a:ln/>
+        </p:spPr>
+        <p:txBody>
+          <a:bodyPr wrap="square" rtlCol="0" anchor="ctr"/>
+          <a:lstStyle/>
+          <a:p>
+            <a:pPr indent="0" marL="0">
+              <a:buNone/>
+            </a:pPr>
+            <a:r>
+              <a:rPr lang="en-US" sz="2200" b="1" dirty="0">
+                <a:solidFill>
+                  <a:srgbClr val="1F4C86"/>
+                </a:solidFill>
+                <a:latin typeface="Calibri" pitchFamily="34" charset="0"/>
+                <a:ea typeface="Calibri" pitchFamily="34" charset="-122"/>
+                <a:cs typeface="Calibri" pitchFamily="34" charset="-120"/>
+              </a:rPr>
+              <a:t>michaelsnelson.github.io/BINA-I2K-2026-QuPath-Extensions</a:t>
+            </a:r>
+            <a:endParaRPr lang="en-US" sz="2200" dirty="0"/>
+          </a:p>
+        </p:txBody>
+      </p:sp>
+      <p:sp>
+        <p:nvSpPr>
+          <p:cNvPr id="6" name="Text 4"/>
+          <p:cNvSpPr/>
+          <p:nvPr/>
+        </p:nvSpPr>
+        <p:spPr>
+          <a:xfrm>
+            <a:off x="960120" y="2697480"/>
+            <a:ext cx="9811512" cy="2560320"/>
+          </a:xfrm>
+          <a:prstGeom prst="rect">
+            <a:avLst/>
+          </a:prstGeom>
+          <a:noFill/>
+          <a:ln/>
+        </p:spPr>
+        <p:txBody>
+          <a:bodyPr wrap="square" rtlCol="0" anchor="t"/>
+          <a:lstStyle/>
+          <a:p>
+            <a:pPr indent="0" marL="0">
+              <a:spcAft>
+                <a:spcPts val="1000"/>
+              </a:spcAft>
+              <a:buNone/>
+            </a:pPr>
+            <a:r>
+              <a:rPr lang="en-US" sz="1900" dirty="0">
+                <a:solidFill>
+                  <a:srgbClr val="1F2933"/>
+                </a:solidFill>
+                <a:latin typeface="Calibri" pitchFamily="34" charset="0"/>
+                <a:ea typeface="Calibri" pitchFamily="34" charset="-122"/>
+                <a:cs typeface="Calibri" pitchFamily="34" charset="-120"/>
+              </a:rPr>
+              <a:t>A written walkthrough and a video for every tool  ·  setup instructions  ·  sample data  ·  these slides
+</a:t>
+            </a:r>
+            <a:pPr indent="0" marL="0">
+              <a:spcAft>
+                <a:spcPts val="600"/>
+              </a:spcAft>
+              <a:buNone/>
+            </a:pPr>
+            <a:r>
+              <a:rPr lang="en-US" sz="1900" dirty="0">
+                <a:solidFill>
+                  <a:srgbClr val="1F2933"/>
+                </a:solidFill>
+                <a:latin typeface="Calibri" pitchFamily="34" charset="0"/>
+                <a:ea typeface="Calibri" pitchFamily="34" charset="-122"/>
+                <a:cs typeface="Calibri" pitchFamily="34" charset="-120"/>
+              </a:rPr>
+              <a:t>Add the two catalogs in QuPath, install only what interests you, and restart:
+</a:t>
+            </a:r>
+            <a:pPr indent="0" marL="0">
+              <a:spcAft>
+                <a:spcPts val="400"/>
+              </a:spcAft>
+              <a:buNone/>
+            </a:pPr>
+            <a:r>
+              <a:rPr lang="en-US" sz="1800" b="1" dirty="0">
+                <a:solidFill>
+                  <a:srgbClr val="1F4C86"/>
+                </a:solidFill>
+                <a:latin typeface="Calibri" pitchFamily="34" charset="0"/>
+                <a:ea typeface="Calibri" pitchFamily="34" charset="-122"/>
+                <a:cs typeface="Calibri" pitchFamily="34" charset="-120"/>
+              </a:rPr>
+              <a:t>github.com/uw-loci/qupath-catalog-mikenelson
+</a:t>
+            </a:r>
+            <a:pPr indent="0" marL="0">
+              <a:spcAft>
+                <a:spcPts val="1400"/>
+              </a:spcAft>
+              <a:buNone/>
+            </a:pPr>
+            <a:r>
+              <a:rPr lang="en-US" sz="1800" b="1" dirty="0">
+                <a:solidFill>
+                  <a:srgbClr val="1F4C86"/>
+                </a:solidFill>
+                <a:latin typeface="Calibri" pitchFamily="34" charset="0"/>
+                <a:ea typeface="Calibri" pitchFamily="34" charset="-122"/>
+                <a:cs typeface="Calibri" pitchFamily="34" charset="-120"/>
+              </a:rPr>
+              <a:t>github.com/uw-loci/qupath-catalog-qpsc
+</a:t>
+            </a:r>
+            <a:pPr indent="0" marL="0">
+              <a:buNone/>
+            </a:pPr>
+            <a:r>
+              <a:rPr lang="en-US" sz="1900" b="1" dirty="0">
+                <a:solidFill>
+                  <a:srgbClr val="1F4C86"/>
+                </a:solidFill>
+                <a:latin typeface="Calibri" pitchFamily="34" charset="0"/>
+                <a:ea typeface="Calibri" pitchFamily="34" charset="-122"/>
+                <a:cs typeface="Calibri" pitchFamily="34" charset="-120"/>
+              </a:rPr>
+              <a:t>Whatever we did not reach today, the walkthrough and the video are waiting for you.</a:t>
+            </a:r>
+            <a:endParaRPr lang="en-US" sz="1900" dirty="0"/>
+          </a:p>
+        </p:txBody>
+      </p:sp>
+      <p:sp>
+        <p:nvSpPr>
+          <p:cNvPr id="7" name="Text 5"/>
+          <p:cNvSpPr/>
+          <p:nvPr/>
+        </p:nvSpPr>
+        <p:spPr>
+          <a:xfrm>
+            <a:off x="960120" y="5230368"/>
+            <a:ext cx="9811512" cy="365760"/>
+          </a:xfrm>
+          <a:prstGeom prst="rect">
+            <a:avLst/>
+          </a:prstGeom>
+          <a:noFill/>
+          <a:ln/>
+        </p:spPr>
+        <p:txBody>
+          <a:bodyPr wrap="square" rtlCol="0" anchor="ctr"/>
+          <a:lstStyle/>
+          <a:p>
+            <a:pPr indent="0" marL="0">
+              <a:buNone/>
+            </a:pPr>
+            <a:r>
+              <a:rPr lang="en-US" sz="1600" b="1" dirty="0">
+                <a:solidFill>
+                  <a:srgbClr val="1F4C86"/>
+                </a:solidFill>
+                <a:latin typeface="Calibri" pitchFamily="34" charset="0"/>
+                <a:ea typeface="Calibri" pitchFamily="34" charset="-122"/>
+                <a:cs typeface="Calibri" pitchFamily="34" charset="-120"/>
+              </a:rPr>
+              <a:t>Sample data courtesy of Sara McArdle and Zbigniew Mikulski, La Jolla Institute for Immunology.</a:t>
+            </a:r>
+            <a:endParaRPr lang="en-US" sz="1600" dirty="0"/>
+          </a:p>
+        </p:txBody>
+      </p:sp>
+      <p:sp>
+        <p:nvSpPr>
+          <p:cNvPr id="8" name="Text 6"/>
+          <p:cNvSpPr/>
+          <p:nvPr/>
+        </p:nvSpPr>
+        <p:spPr>
+          <a:xfrm>
+            <a:off x="960120" y="5532120"/>
+            <a:ext cx="9811512" cy="457200"/>
+          </a:xfrm>
+          <a:prstGeom prst="rect">
+            <a:avLst/>
+          </a:prstGeom>
+          <a:noFill/>
+          <a:ln/>
+        </p:spPr>
+        <p:txBody>
+          <a:bodyPr wrap="square" rtlCol="0" anchor="ctr"/>
+          <a:lstStyle/>
+          <a:p>
+            <a:pPr indent="0" marL="0">
+              <a:buNone/>
+            </a:pPr>
+            <a:r>
+              <a:rPr lang="en-US" sz="1800" i="1" dirty="0">
+                <a:solidFill>
+                  <a:srgbClr val="5A6675"/>
+                </a:solidFill>
+                <a:latin typeface="Calibri" pitchFamily="34" charset="0"/>
+                <a:ea typeface="Calibri" pitchFamily="34" charset="-122"/>
+                <a:cs typeface="Calibri" pitchFamily="34" charset="-120"/>
+              </a:rPr>
+              <a:t>Questions welcome now, during the hands-on hour, or by email afterwards.</a:t>
+            </a:r>
+            <a:endParaRPr lang="en-US" sz="1800" dirty="0"/>
+          </a:p>
+        </p:txBody>
+      </p:sp>
+      <p:sp>
+        <p:nvSpPr>
+          <p:cNvPr id="9" name="Text 7"/>
+          <p:cNvSpPr/>
+          <p:nvPr/>
+        </p:nvSpPr>
+        <p:spPr>
+          <a:xfrm>
+            <a:off x="11274552" y="6291072"/>
+            <a:ext cx="457200" cy="310896"/>
+          </a:xfrm>
+          <a:prstGeom prst="rect">
+            <a:avLst/>
+          </a:prstGeom>
+          <a:noFill/>
+          <a:ln/>
+        </p:spPr>
+        <p:txBody>
+          <a:bodyPr wrap="square" rtlCol="0" anchor="ctr"/>
+          <a:lstStyle/>
+          <a:p>
+            <a:pPr algn="r" indent="0" marL="0">
+              <a:buNone/>
+            </a:pPr>
+            <a:r>
+              <a:rPr lang="en-US" sz="1400" dirty="0">
+                <a:solidFill>
+                  <a:srgbClr val="A8B2BF"/>
+                </a:solidFill>
+                <a:latin typeface="Calibri" pitchFamily="34" charset="0"/>
+                <a:ea typeface="Calibri" pitchFamily="34" charset="-122"/>
+                <a:cs typeface="Calibri" pitchFamily="34" charset="-120"/>
+              </a:rPr>
+              <a:t>50</a:t>
             </a:r>
             <a:endParaRPr lang="en-US" sz="1400" dirty="0"/>
           </a:p>

</xml_diff>

<commit_message>
Credit Kristin Gallick as the Confusion Matrix author
Named on the extension's own page, in the acknowledgements, on the deck's
acknowledgements slide, and on its demo slide. GitHub handle kept in repo URLs.
</commit_message>
<xml_diff>
--- a/I2K_2026_QuPath_Extensions.pptx
+++ b/I2K_2026_QuPath_Extensions.pptx
@@ -13207,7 +13207,7 @@
                 <a:ea typeface="Calibri" pitchFamily="34" charset="-122"/>
                 <a:cs typeface="Calibri" pitchFamily="34" charset="-120"/>
               </a:rPr>
-              <a:t>Demo only: the repository is currently private, so there is no version for you to install.</a:t>
+              <a:t>Written by Kristin Gallick.  ·  Demo only: the repository is currently private, so there is no version for you to install.</a:t>
             </a:r>
             <a:endParaRPr lang="en-US" sz="1600" dirty="0"/>
           </a:p>
@@ -19166,7 +19166,7 @@
                 <a:ea typeface="Calibri" pitchFamily="34" charset="-122"/>
                 <a:cs typeface="Calibri" pitchFamily="34" charset="-120"/>
               </a:rPr>
-              <a:t>Pete Bankhead and the QuPath team.  ·  CT-FIRE, CurveAlign, TACS and TWOMBLI for the fibre work.  ·  CytoMAP and QuBaLab for bringing clustering into QuPath.  ·  QUAREP-LiMi for the reporting standards.  ·  The image.sc community, where several of these features were first requested.
+              <a:t>Kristin Gallick, who wrote the Confusion Matrix extension.  ·  Pete Bankhead and the QuPath team.  ·  CT-FIRE, CurveAlign, TACS and TWOMBLI for the fibre work.  ·  CytoMAP and QuBaLab for bringing clustering into QuPath.  ·  QUAREP-LiMi for the reporting standards.  ·  The image.sc community, where several of these features were first requested.
 </a:t>
             </a:r>
             <a:pPr indent="0" marL="0">

</xml_diff>

<commit_message>
Correct Confusion Matrix attribution
Kristin Gallick originated it - the initial concept and half of the scripts it
grew from - and it was built out into the extension at LOCI. Previously the
pages said she wrote it, which over-credits in one direction and under-credits
the development in the other. The repo sits under her account, which is why
the earlier reading was easy to make.
</commit_message>
<xml_diff>
--- a/I2K_2026_QuPath_Extensions.pptx
+++ b/I2K_2026_QuPath_Extensions.pptx
@@ -13207,7 +13207,7 @@
                 <a:ea typeface="Calibri" pitchFamily="34" charset="-122"/>
                 <a:cs typeface="Calibri" pitchFamily="34" charset="-120"/>
               </a:rPr>
-              <a:t>Written by Kristin Gallick.  ·  Demo only: the repository is currently private, so there is no version for you to install.</a:t>
+              <a:t>Originated by Kristin Gallick — concept and initial scripts; built out at LOCI.  ·  Demo only: the repository is currently private.</a:t>
             </a:r>
             <a:endParaRPr lang="en-US" sz="1600" dirty="0"/>
           </a:p>
@@ -19166,7 +19166,7 @@
                 <a:ea typeface="Calibri" pitchFamily="34" charset="-122"/>
                 <a:cs typeface="Calibri" pitchFamily="34" charset="-120"/>
               </a:rPr>
-              <a:t>Kristin Gallick, who wrote the Confusion Matrix extension.  ·  Pete Bankhead and the QuPath team.  ·  CT-FIRE, CurveAlign, TACS and TWOMBLI for the fibre work.  ·  CytoMAP and QuBaLab for bringing clustering into QuPath.  ·  QUAREP-LiMi for the reporting standards.  ·  The image.sc community, where several of these features were first requested.
+              <a:t>Kristin Gallick, whose concept and scripts the Confusion Matrix grew from.  ·  Pete Bankhead and the QuPath team.  ·  CT-FIRE, CurveAlign, TACS and TWOMBLI for the fibre work.  ·  CytoMAP and QuBaLab for bringing clustering into QuPath.  ·  QUAREP-LiMi for the reporting standards.  ·  The image.sc community, where several of these features were first requested.
 </a:t>
             </a:r>
             <a:pPr indent="0" marL="0">

</xml_diff>

<commit_message>
Sara's session runs first: point backwards to it, not forwards
Her session is 'Tips and tricks for maintaining sanity during hi-plex
classification in QuPath', earlier the same day. Every reference to the two
tools she demonstrates - Channel Names Viewer and Classify Object Subset -
now reads as a callback rather than a forward pointer.

Also makes the adjacency explicit: her session is how to keep a hi-plex
classification honest, ours picks up with what the classified cells tell you.
New deck slide sets that up before the QP-CAT run.

Deck: 50 -> 51 slides.

Claude-Session: https://claude.ai/code/session_01KwiACUr5MacuDvqp74c96o
</commit_message>
<xml_diff>
--- a/I2K_2026_QuPath_Extensions.pptx
+++ b/I2K_2026_QuPath_Extensions.pptx
@@ -55,9 +55,10 @@
     <p:sldId id="303" r:id="rId49"/>
     <p:sldId id="304" r:id="rId50"/>
     <p:sldId id="305" r:id="rId51"/>
+    <p:sldId id="306" r:id="rId52"/>
   </p:sldIdLst>
   <p:notesMasterIdLst>
-    <p:notesMasterId r:id="rId52"/>
+    <p:notesMasterId r:id="rId53"/>
   </p:notesMasterIdLst>
   <p:sldSz cx="12192000" cy="6858000"/>
   <p:notesSz cx="6858000" cy="12192000"/>
@@ -4535,6 +4536,94 @@
             <a:fld id="{F7021451-1387-4CA6-816F-3879F97B5CBC}" type="slidenum">
               <a:rPr lang="en-US"/>
               <a:t>50</a:t>
+            </a:fld>
+            <a:endParaRPr lang="en-US"/>
+          </a:p>
+        </p:txBody>
+      </p:sp>
+    </p:spTree>
+    <p:extLst>
+      <p:ext uri="{BB962C8B-B14F-4D97-AF65-F5344CB8AC3E}">
+        <p14:creationId xmlns:p14="http://schemas.microsoft.com/office/powerpoint/2010/main" val="1024086991"/>
+      </p:ext>
+    </p:extLst>
+  </p:cSld>
+  <p:clrMapOvr>
+    <a:masterClrMapping/>
+  </p:clrMapOvr>
+</p:notes>
+</file>
+
+<file path=ppt/notesSlides/notesSlide51.xml><?xml version="1.0" encoding="utf-8"?>
+<p:notes xmlns:a="http://schemas.openxmlformats.org/drawingml/2006/main" xmlns:r="http://schemas.openxmlformats.org/officeDocument/2006/relationships" xmlns:p="http://schemas.openxmlformats.org/presentationml/2006/main">
+  <p:cSld>
+    <p:spTree>
+      <p:nvGrpSpPr>
+        <p:cNvPr id="1" name=""/>
+        <p:cNvGrpSpPr/>
+        <p:nvPr/>
+      </p:nvGrpSpPr>
+      <p:grpSpPr>
+        <a:xfrm>
+          <a:off x="0" y="0"/>
+          <a:ext cx="0" cy="0"/>
+          <a:chOff x="0" y="0"/>
+          <a:chExt cx="0" cy="0"/>
+        </a:xfrm>
+      </p:grpSpPr>
+      <p:sp>
+        <p:nvSpPr>
+          <p:cNvPr id="2" name="Slide Image Placeholder 1"/>
+          <p:cNvSpPr>
+            <a:spLocks noGrp="1" noRot="1" noChangeAspect="1"/>
+          </p:cNvSpPr>
+          <p:nvPr>
+            <p:ph type="sldImg"/>
+          </p:nvPr>
+        </p:nvSpPr>
+        <p:spPr/>
+      </p:sp>
+      <p:sp>
+        <p:nvSpPr>
+          <p:cNvPr id="3" name="Notes Placeholder 2"/>
+          <p:cNvSpPr>
+            <a:spLocks noGrp="1"/>
+          </p:cNvSpPr>
+          <p:nvPr>
+            <p:ph type="body" idx="1"/>
+          </p:nvPr>
+        </p:nvSpPr>
+        <p:spPr/>
+        <p:txBody>
+          <a:bodyPr/>
+          <a:lstStyle/>
+          <a:p>
+            <a:r>
+              <a:rPr lang="en-US" dirty="0"/>
+              <a:t/>
+            </a:r>
+            <a:endParaRPr lang="en-US" dirty="0"/>
+          </a:p>
+        </p:txBody>
+      </p:sp>
+      <p:sp>
+        <p:nvSpPr>
+          <p:cNvPr id="4" name="Slide Number Placeholder 3"/>
+          <p:cNvSpPr>
+            <a:spLocks noGrp="1"/>
+          </p:cNvSpPr>
+          <p:nvPr>
+            <p:ph type="sldNum" sz="quarter" idx="10"/>
+          </p:nvPr>
+        </p:nvSpPr>
+        <p:spPr/>
+        <p:txBody>
+          <a:bodyPr/>
+          <a:lstStyle/>
+          <a:p>
+            <a:fld id="{F7021451-1387-4CA6-816F-3879F97B5CBC}" type="slidenum">
+              <a:rPr lang="en-US"/>
+              <a:t>51</a:t>
             </a:fld>
             <a:endParaRPr lang="en-US"/>
           </a:p>
@@ -7746,7 +7835,7 @@
                 <a:ea typeface="Trebuchet MS" pitchFamily="34" charset="-122"/>
                 <a:cs typeface="Trebuchet MS" pitchFamily="34" charset="-120"/>
               </a:rPr>
-              <a:t>Two you will see properly elsewhere</a:t>
+              <a:t>Two you already saw this morning</a:t>
             </a:r>
             <a:endParaRPr lang="en-US" sz="3000" dirty="0"/>
           </a:p>
@@ -7805,7 +7894,7 @@
                 <a:ea typeface="Calibri" pitchFamily="34" charset="-122"/>
                 <a:cs typeface="Calibri" pitchFamily="34" charset="-120"/>
               </a:rPr>
-              <a:t>Sara McArdle is covering these two — go and see them done by the person whose scripts they are.</a:t>
+              <a:t>From “Tips and tricks for maintaining sanity during hi-plex classification in QuPath”, earlier today.</a:t>
             </a:r>
             <a:endParaRPr lang="en-US" sz="1700" dirty="0"/>
           </a:p>
@@ -7899,7 +7988,7 @@
                 <a:ea typeface="Calibri" pitchFamily="34" charset="-122"/>
                 <a:cs typeface="Calibri" pitchFamily="34" charset="-120"/>
               </a:rPr>
-              <a:t>Both began as Sara McArdle’s Groovy scripts, and Sara is presenting them in her session</a:t>
+              <a:t>Both began as Sara McArdle’s Groovy scripts, and Sara demonstrated both in the session before this one</a:t>
             </a:r>
             <a:endParaRPr lang="en-US" sz="2000" dirty="0"/>
           </a:p>
@@ -7923,7 +8012,7 @@
                 <a:ea typeface="Calibri" pitchFamily="34" charset="-122"/>
                 <a:cs typeface="Calibri" pitchFamily="34" charset="-120"/>
               </a:rPr>
-              <a:t>So: a mention here rather than the same demo twice — but both install in seconds and both have a full walkthrough on the site</a:t>
+              <a:t>So: a pointer rather than the same demo twice — both install in seconds, and both have a full walkthrough on the site</a:t>
             </a:r>
             <a:endParaRPr lang="en-US" sz="2000" dirty="0"/>
           </a:p>
@@ -7987,7 +8076,7 @@
                 <a:ea typeface="Calibri" pitchFamily="34" charset="-122"/>
                 <a:cs typeface="Calibri" pitchFamily="34" charset="-120"/>
               </a:rPr>
-              <a:t>Nothing stops you installing them today. This is a division of labour, not a barrier.</a:t>
+              <a:t>Nothing stops you installing them. This is a division of labour, not a barrier.</a:t>
             </a:r>
             <a:endParaRPr lang="en-US" sz="1600" dirty="0"/>
           </a:p>
@@ -14552,7 +14641,7 @@
                 <a:ea typeface="Trebuchet MS" pitchFamily="34" charset="-122"/>
                 <a:cs typeface="Trebuchet MS" pitchFamily="34" charset="-120"/>
               </a:rPr>
-              <a:t>QP-CAT — multiplexed cell analysis</a:t>
+              <a:t>Where Sara’s session leads next</a:t>
             </a:r>
             <a:endParaRPr lang="en-US" sz="3000" dirty="0"/>
           </a:p>
@@ -14611,7 +14700,7 @@
                 <a:ea typeface="Calibri" pitchFamily="34" charset="-122"/>
                 <a:cs typeface="Calibri" pitchFamily="34" charset="-120"/>
               </a:rPr>
-              <a:t>The usual workflow loses the link back to the tissue. This keeps it.</a:t>
+              <a:t>Sara’s session and this one are two halves of the same workflow, in the right order.</a:t>
             </a:r>
             <a:endParaRPr lang="en-US" sz="1700" dirty="0"/>
           </a:p>
@@ -14657,7 +14746,7 @@
                 <a:ea typeface="Calibri" pitchFamily="34" charset="-122"/>
                 <a:cs typeface="Calibri" pitchFamily="34" charset="-120"/>
               </a:rPr>
-              <a:t>The full scientific Python stack embedded in QuPath. No environments to manage</a:t>
+              <a:t>Hi-plex classification, kept sane — that was this morning’s other QuPath session</a:t>
             </a:r>
             <a:endParaRPr lang="en-US" sz="2000" dirty="0"/>
           </a:p>
@@ -14681,7 +14770,7 @@
                 <a:ea typeface="Calibri" pitchFamily="34" charset="-122"/>
                 <a:cs typeface="Calibri" pitchFamily="34" charset="-120"/>
               </a:rPr>
-              <a:t>Clustering, marker gating with suggested thresholds, spatial statistics, batch correction</a:t>
+              <a:t>The next question is what the classified cells are actually telling you</a:t>
             </a:r>
             <a:endParaRPr lang="en-US" sz="2000" dirty="0"/>
           </a:p>
@@ -14705,7 +14794,7 @@
                 <a:ea typeface="Calibri" pitchFamily="34" charset="-122"/>
                 <a:cs typeface="Calibri" pitchFamily="34" charset="-120"/>
               </a:rPr>
-              <a:t>Label a small subset by hand and have the rest of the project labelled for you</a:t>
+              <a:t>Which populations group together, which sit next to which, and whether that differs between images</a:t>
             </a:r>
             <a:endParaRPr lang="en-US" sz="2000" dirty="0"/>
           </a:p>
@@ -14729,31 +14818,7 @@
                 <a:ea typeface="Calibri" pitchFamily="34" charset="-122"/>
                 <a:cs typeface="Calibri" pitchFamily="34" charset="-120"/>
               </a:rPr>
-              <a:t>Brush a region of the embedding and those cells highlight on the slide</a:t>
-            </a:r>
-            <a:endParaRPr lang="en-US" sz="2000" dirty="0"/>
-          </a:p>
-          <a:p>
-            <a:pPr marL="342900" indent="-342900">
-              <a:lnSpc>
-                <a:spcPct val="105000"/>
-              </a:lnSpc>
-              <a:spcAft>
-                <a:spcPts val="1200"/>
-              </a:spcAft>
-              <a:buSzPct val="100000"/>
-              <a:buChar char="•"/>
-            </a:pPr>
-            <a:r>
-              <a:rPr lang="en-US" sz="2000" dirty="0">
-                <a:solidFill>
-                  <a:srgbClr val="1F2933"/>
-                </a:solidFill>
-                <a:latin typeface="Calibri" pitchFamily="34" charset="0"/>
-                <a:ea typeface="Calibri" pitchFamily="34" charset="-122"/>
-                <a:cs typeface="Calibri" pitchFamily="34" charset="-120"/>
-              </a:rPr>
-              <a:t>Separate tissue stays separate — no spatial graph edge ever crosses two TMA cores</a:t>
+              <a:t>That is clustering, phenotyping and spatial statistics — and it is the rest of this section</a:t>
             </a:r>
             <a:endParaRPr lang="en-US" sz="2000" dirty="0"/>
           </a:p>
@@ -14817,7 +14882,7 @@
                 <a:ea typeface="Calibri" pitchFamily="34" charset="-122"/>
                 <a:cs typeface="Calibri" pitchFamily="34" charset="-120"/>
               </a:rPr>
-              <a:t>Author’s own warning: many features are lightly tested. Treat results as a starting point.</a:t>
+              <a:t>If you missed hers, the two extensions she demonstrated are documented on our site too.</a:t>
             </a:r>
             <a:endParaRPr lang="en-US" sz="1600" dirty="0"/>
           </a:p>
@@ -14927,7 +14992,7 @@
                 <a:ea typeface="Trebuchet MS" pitchFamily="34" charset="-122"/>
                 <a:cs typeface="Trebuchet MS" pitchFamily="34" charset="-120"/>
               </a:rPr>
-              <a:t>You can check the answer</a:t>
+              <a:t>QP-CAT — multiplexed cell analysis</a:t>
             </a:r>
             <a:endParaRPr lang="en-US" sz="3000" dirty="0"/>
           </a:p>
@@ -14986,7 +15051,7 @@
                 <a:ea typeface="Calibri" pitchFamily="34" charset="-122"/>
                 <a:cs typeface="Calibri" pitchFamily="34" charset="-120"/>
               </a:rPr>
-              <a:t>Learn what a correct result looks like, so you can recognise a wrong one later.</a:t>
+              <a:t>The usual workflow loses the link back to the tissue. This keeps it.</a:t>
             </a:r>
             <a:endParaRPr lang="en-US" sz="1700" dirty="0"/>
           </a:p>
@@ -15032,7 +15097,7 @@
                 <a:ea typeface="Calibri" pitchFamily="34" charset="-122"/>
                 <a:cs typeface="Calibri" pitchFamily="34" charset="-120"/>
               </a:rPr>
-              <a:t>Real multiplexed tissue has no ground truth — you never know which cell is really which type</a:t>
+              <a:t>The full scientific Python stack embedded in QuPath. No environments to manage</a:t>
             </a:r>
             <a:endParaRPr lang="en-US" sz="2000" dirty="0"/>
           </a:p>
@@ -15056,7 +15121,7 @@
                 <a:ea typeface="Calibri" pitchFamily="34" charset="-122"/>
                 <a:cs typeface="Calibri" pitchFamily="34" charset="-120"/>
               </a:rPr>
-              <a:t>So the exercise uses a synthetic tumour microenvironment where every cell is labelled</a:t>
+              <a:t>Clustering, marker gating with suggested thresholds, spatial statistics, batch correction</a:t>
             </a:r>
             <a:endParaRPr lang="en-US" sz="2000" dirty="0"/>
           </a:p>
@@ -15080,7 +15145,7 @@
                 <a:ea typeface="Calibri" pitchFamily="34" charset="-122"/>
                 <a:cs typeface="Calibri" pitchFamily="34" charset="-120"/>
               </a:rPr>
-              <a:t>Six cell types, tumour nests, an immune-infiltrated boundary, B-cell follicles, a proliferation gradient</a:t>
+              <a:t>Label a small subset by hand and have the rest of the project labelled for you</a:t>
             </a:r>
             <a:endParaRPr lang="en-US" sz="2000" dirty="0"/>
           </a:p>
@@ -15104,7 +15169,7 @@
                 <a:ea typeface="Calibri" pitchFamily="34" charset="-122"/>
                 <a:cs typeface="Calibri" pitchFamily="34" charset="-120"/>
               </a:rPr>
-              <a:t>Inflamed versus desert: one image is 55% lymphoid, another 14% with no follicles at all</a:t>
+              <a:t>Brush a region of the embedding and those cells highlight on the slide</a:t>
             </a:r>
             <a:endParaRPr lang="en-US" sz="2000" dirty="0"/>
           </a:p>
@@ -15128,7 +15193,7 @@
                 <a:ea typeface="Calibri" pitchFamily="34" charset="-122"/>
                 <a:cs typeface="Calibri" pitchFamily="34" charset="-120"/>
               </a:rPr>
-              <a:t>20 MB, public domain, and it downloads straight from GitHub</a:t>
+              <a:t>Separate tissue stays separate — no spatial graph edge ever crosses two TMA cores</a:t>
             </a:r>
             <a:endParaRPr lang="en-US" sz="2000" dirty="0"/>
           </a:p>
@@ -15192,7 +15257,7 @@
                 <a:ea typeface="Calibri" pitchFamily="34" charset="-122"/>
                 <a:cs typeface="Calibri" pitchFamily="34" charset="-120"/>
               </a:rPr>
-              <a:t>Cluster it, then click a boundary cell and find out whether the cluster was telling the truth.</a:t>
+              <a:t>Author’s own warning: many features are lightly tested. Treat results as a starting point.</a:t>
             </a:r>
             <a:endParaRPr lang="en-US" sz="1600" dirty="0"/>
           </a:p>
@@ -15302,7 +15367,7 @@
                 <a:ea typeface="Trebuchet MS" pitchFamily="34" charset="-122"/>
                 <a:cs typeface="Trebuchet MS" pitchFamily="34" charset="-120"/>
               </a:rPr>
-              <a:t>And getting back to the tissue</a:t>
+              <a:t>You can check the answer</a:t>
             </a:r>
             <a:endParaRPr lang="en-US" sz="3000" dirty="0"/>
           </a:p>
@@ -15361,7 +15426,7 @@
                 <a:ea typeface="Calibri" pitchFamily="34" charset="-122"/>
                 <a:cs typeface="Calibri" pitchFamily="34" charset="-120"/>
               </a:rPr>
-              <a:t>A mention rather than a demo — it is the navigation half of the clustering you just saw.</a:t>
+              <a:t>Learn what a correct result looks like, so you can recognise a wrong one later.</a:t>
             </a:r>
             <a:endParaRPr lang="en-US" sz="1700" dirty="0"/>
           </a:p>
@@ -15407,7 +15472,7 @@
                 <a:ea typeface="Calibri" pitchFamily="34" charset="-122"/>
                 <a:cs typeface="Calibri" pitchFamily="34" charset="-120"/>
               </a:rPr>
-              <a:t>Clustering answers "which cells group together". It does not answer "which cell is that"</a:t>
+              <a:t>Real multiplexed tissue has no ground truth — you never know which cell is really which type</a:t>
             </a:r>
             <a:endParaRPr lang="en-US" sz="2000" dirty="0"/>
           </a:p>
@@ -15431,7 +15496,7 @@
                 <a:ea typeface="Calibri" pitchFamily="34" charset="-122"/>
                 <a:cs typeface="Calibri" pitchFamily="34" charset="-120"/>
               </a:rPr>
-              <a:t>Cluster 3D Navigator: a rotatable point cloud, one point per cell, coloured by class</a:t>
+              <a:t>So the exercise uses a synthetic tumour microenvironment where every cell is labelled</a:t>
             </a:r>
             <a:endParaRPr lang="en-US" sz="2000" dirty="0"/>
           </a:p>
@@ -15455,7 +15520,7 @@
                 <a:ea typeface="Calibri" pitchFamily="34" charset="-122"/>
                 <a:cs typeface="Calibri" pitchFamily="34" charset="-120"/>
               </a:rPr>
-              <a:t>Click a point in cluster space and land on that cell in the viewer</a:t>
+              <a:t>Six cell types, tumour nests, an immune-infiltrated boundary, B-cell follicles, a proliferation gradient</a:t>
             </a:r>
             <a:endParaRPr lang="en-US" sz="2000" dirty="0"/>
           </a:p>
@@ -15479,7 +15544,31 @@
                 <a:ea typeface="Calibri" pitchFamily="34" charset="-122"/>
                 <a:cs typeface="Calibri" pitchFamily="34" charset="-120"/>
               </a:rPr>
-              <a:t>Boundary cells are where classification errors live — this makes them one click away</a:t>
+              <a:t>Inflamed versus desert: one image is 55% lymphoid, another 14% with no follicles at all</a:t>
+            </a:r>
+            <a:endParaRPr lang="en-US" sz="2000" dirty="0"/>
+          </a:p>
+          <a:p>
+            <a:pPr marL="342900" indent="-342900">
+              <a:lnSpc>
+                <a:spcPct val="105000"/>
+              </a:lnSpc>
+              <a:spcAft>
+                <a:spcPts val="1200"/>
+              </a:spcAft>
+              <a:buSzPct val="100000"/>
+              <a:buChar char="•"/>
+            </a:pPr>
+            <a:r>
+              <a:rPr lang="en-US" sz="2000" dirty="0">
+                <a:solidFill>
+                  <a:srgbClr val="1F2933"/>
+                </a:solidFill>
+                <a:latin typeface="Calibri" pitchFamily="34" charset="0"/>
+                <a:ea typeface="Calibri" pitchFamily="34" charset="-122"/>
+                <a:cs typeface="Calibri" pitchFamily="34" charset="-120"/>
+              </a:rPr>
+              <a:t>20 MB, public domain, and it downloads straight from GitHub</a:t>
             </a:r>
             <a:endParaRPr lang="en-US" sz="2000" dirty="0"/>
           </a:p>
@@ -15543,7 +15632,7 @@
                 <a:ea typeface="Calibri" pitchFamily="34" charset="-122"/>
                 <a:cs typeface="Calibri" pitchFamily="34" charset="-120"/>
               </a:rPr>
-              <a:t>Works with any clustering tool’s output, not just QP-CAT’s. It only reads; it writes nothing.</a:t>
+              <a:t>Cluster it, then click a boundary cell and find out whether the cluster was telling the truth.</a:t>
             </a:r>
             <a:endParaRPr lang="en-US" sz="1600" dirty="0"/>
           </a:p>
@@ -15622,23 +15711,42 @@
       </p:grpSpPr>
       <p:sp>
         <p:nvSpPr>
-          <p:cNvPr id="2" name="Shape 0"/>
-          <p:cNvSpPr/>
-          <p:nvPr/>
-        </p:nvSpPr>
-        <p:spPr>
-          <a:xfrm>
-            <a:off x="0" y="1417320"/>
-            <a:ext cx="12188952" cy="3108960"/>
-          </a:xfrm>
-          <a:prstGeom prst="rect">
-            <a:avLst/>
-          </a:prstGeom>
-          <a:solidFill>
-            <a:srgbClr val="E8F0FA"/>
-          </a:solidFill>
-          <a:ln/>
-        </p:spPr>
+          <p:cNvPr id="2" name="Text 0"/>
+          <p:cNvSpPr/>
+          <p:nvPr/>
+        </p:nvSpPr>
+        <p:spPr>
+          <a:xfrm>
+            <a:off x="566928" y="384048"/>
+            <a:ext cx="11055096" cy="658368"/>
+          </a:xfrm>
+          <a:prstGeom prst="rect">
+            <a:avLst/>
+          </a:prstGeom>
+          <a:noFill/>
+          <a:ln/>
+        </p:spPr>
+        <p:txBody>
+          <a:bodyPr wrap="square" rtlCol="0" anchor="ctr"/>
+          <a:lstStyle/>
+          <a:p>
+            <a:pPr indent="0" marL="0">
+              <a:buNone/>
+            </a:pPr>
+            <a:r>
+              <a:rPr lang="en-US" sz="3000" b="1" dirty="0">
+                <a:solidFill>
+                  <a:srgbClr val="1F4C86"/>
+                </a:solidFill>
+                <a:latin typeface="Trebuchet MS" pitchFamily="34" charset="0"/>
+                <a:ea typeface="Trebuchet MS" pitchFamily="34" charset="-122"/>
+                <a:cs typeface="Trebuchet MS" pitchFamily="34" charset="-120"/>
+              </a:rPr>
+              <a:t>And getting back to the tissue</a:t>
+            </a:r>
+            <a:endParaRPr lang="en-US" sz="3000" dirty="0"/>
+          </a:p>
+        </p:txBody>
       </p:sp>
       <p:sp>
         <p:nvSpPr>
@@ -15648,8 +15756,8 @@
         </p:nvSpPr>
         <p:spPr>
           <a:xfrm>
-            <a:off x="0" y="1417320"/>
-            <a:ext cx="201168" cy="3108960"/>
+            <a:off x="566928" y="1097280"/>
+            <a:ext cx="1920240" cy="50292"/>
           </a:xfrm>
           <a:prstGeom prst="rect">
             <a:avLst/>
@@ -15668,8 +15776,8 @@
         </p:nvSpPr>
         <p:spPr>
           <a:xfrm>
-            <a:off x="566928" y="1691640"/>
-            <a:ext cx="1828800" cy="914400"/>
+            <a:off x="566928" y="1243584"/>
+            <a:ext cx="11055096" cy="384048"/>
           </a:xfrm>
           <a:prstGeom prst="rect">
             <a:avLst/>
@@ -15685,17 +15793,17 @@
               <a:buNone/>
             </a:pPr>
             <a:r>
-              <a:rPr lang="en-US" sz="5400" b="1" dirty="0">
-                <a:solidFill>
-                  <a:srgbClr val="3674C1"/>
-                </a:solidFill>
-                <a:latin typeface="Trebuchet MS" pitchFamily="34" charset="0"/>
-                <a:ea typeface="Trebuchet MS" pitchFamily="34" charset="-122"/>
-                <a:cs typeface="Trebuchet MS" pitchFamily="34" charset="-120"/>
-              </a:rPr>
-              <a:t>07</a:t>
-            </a:r>
-            <a:endParaRPr lang="en-US" sz="5400" dirty="0"/>
+              <a:rPr lang="en-US" sz="1700" i="1" dirty="0">
+                <a:solidFill>
+                  <a:srgbClr val="5A6675"/>
+                </a:solidFill>
+                <a:latin typeface="Calibri" pitchFamily="34" charset="0"/>
+                <a:ea typeface="Calibri" pitchFamily="34" charset="-122"/>
+                <a:cs typeface="Calibri" pitchFamily="34" charset="-120"/>
+              </a:rPr>
+              <a:t>A mention rather than a demo — it is the navigation half of the clustering you just saw.</a:t>
+            </a:r>
+            <a:endParaRPr lang="en-US" sz="1700" dirty="0"/>
           </a:p>
         </p:txBody>
       </p:sp>
@@ -15707,8 +15815,151 @@
         </p:nvSpPr>
         <p:spPr>
           <a:xfrm>
-            <a:off x="566928" y="2606040"/>
-            <a:ext cx="11055096" cy="868680"/>
+            <a:off x="640080" y="1755648"/>
+            <a:ext cx="10963656" cy="4279392"/>
+          </a:xfrm>
+          <a:prstGeom prst="rect">
+            <a:avLst/>
+          </a:prstGeom>
+          <a:noFill/>
+          <a:ln/>
+        </p:spPr>
+        <p:txBody>
+          <a:bodyPr wrap="square" rtlCol="0" anchor="t"/>
+          <a:lstStyle/>
+          <a:p>
+            <a:pPr marL="342900" indent="-342900">
+              <a:lnSpc>
+                <a:spcPct val="105000"/>
+              </a:lnSpc>
+              <a:spcAft>
+                <a:spcPts val="1200"/>
+              </a:spcAft>
+              <a:buSzPct val="100000"/>
+              <a:buChar char="•"/>
+            </a:pPr>
+            <a:r>
+              <a:rPr lang="en-US" sz="2000" dirty="0">
+                <a:solidFill>
+                  <a:srgbClr val="1F2933"/>
+                </a:solidFill>
+                <a:latin typeface="Calibri" pitchFamily="34" charset="0"/>
+                <a:ea typeface="Calibri" pitchFamily="34" charset="-122"/>
+                <a:cs typeface="Calibri" pitchFamily="34" charset="-120"/>
+              </a:rPr>
+              <a:t>Clustering answers "which cells group together". It does not answer "which cell is that"</a:t>
+            </a:r>
+            <a:endParaRPr lang="en-US" sz="2000" dirty="0"/>
+          </a:p>
+          <a:p>
+            <a:pPr marL="342900" indent="-342900">
+              <a:lnSpc>
+                <a:spcPct val="105000"/>
+              </a:lnSpc>
+              <a:spcAft>
+                <a:spcPts val="1200"/>
+              </a:spcAft>
+              <a:buSzPct val="100000"/>
+              <a:buChar char="•"/>
+            </a:pPr>
+            <a:r>
+              <a:rPr lang="en-US" sz="2000" dirty="0">
+                <a:solidFill>
+                  <a:srgbClr val="1F2933"/>
+                </a:solidFill>
+                <a:latin typeface="Calibri" pitchFamily="34" charset="0"/>
+                <a:ea typeface="Calibri" pitchFamily="34" charset="-122"/>
+                <a:cs typeface="Calibri" pitchFamily="34" charset="-120"/>
+              </a:rPr>
+              <a:t>Cluster 3D Navigator: a rotatable point cloud, one point per cell, coloured by class</a:t>
+            </a:r>
+            <a:endParaRPr lang="en-US" sz="2000" dirty="0"/>
+          </a:p>
+          <a:p>
+            <a:pPr marL="342900" indent="-342900">
+              <a:lnSpc>
+                <a:spcPct val="105000"/>
+              </a:lnSpc>
+              <a:spcAft>
+                <a:spcPts val="1200"/>
+              </a:spcAft>
+              <a:buSzPct val="100000"/>
+              <a:buChar char="•"/>
+            </a:pPr>
+            <a:r>
+              <a:rPr lang="en-US" sz="2000" dirty="0">
+                <a:solidFill>
+                  <a:srgbClr val="1F2933"/>
+                </a:solidFill>
+                <a:latin typeface="Calibri" pitchFamily="34" charset="0"/>
+                <a:ea typeface="Calibri" pitchFamily="34" charset="-122"/>
+                <a:cs typeface="Calibri" pitchFamily="34" charset="-120"/>
+              </a:rPr>
+              <a:t>Click a point in cluster space and land on that cell in the viewer</a:t>
+            </a:r>
+            <a:endParaRPr lang="en-US" sz="2000" dirty="0"/>
+          </a:p>
+          <a:p>
+            <a:pPr marL="342900" indent="-342900">
+              <a:lnSpc>
+                <a:spcPct val="105000"/>
+              </a:lnSpc>
+              <a:spcAft>
+                <a:spcPts val="1200"/>
+              </a:spcAft>
+              <a:buSzPct val="100000"/>
+              <a:buChar char="•"/>
+            </a:pPr>
+            <a:r>
+              <a:rPr lang="en-US" sz="2000" dirty="0">
+                <a:solidFill>
+                  <a:srgbClr val="1F2933"/>
+                </a:solidFill>
+                <a:latin typeface="Calibri" pitchFamily="34" charset="0"/>
+                <a:ea typeface="Calibri" pitchFamily="34" charset="-122"/>
+                <a:cs typeface="Calibri" pitchFamily="34" charset="-120"/>
+              </a:rPr>
+              <a:t>Boundary cells are where classification errors live — this makes them one click away</a:t>
+            </a:r>
+            <a:endParaRPr lang="en-US" sz="2000" dirty="0"/>
+          </a:p>
+        </p:txBody>
+      </p:sp>
+      <p:sp>
+        <p:nvSpPr>
+          <p:cNvPr id="6" name="Shape 4"/>
+          <p:cNvSpPr/>
+          <p:nvPr/>
+        </p:nvSpPr>
+        <p:spPr>
+          <a:xfrm>
+            <a:off x="566928" y="5650992"/>
+            <a:ext cx="11055096" cy="566928"/>
+          </a:xfrm>
+          <a:prstGeom prst="rect">
+            <a:avLst/>
+          </a:prstGeom>
+          <a:solidFill>
+            <a:srgbClr val="F4F8FD"/>
+          </a:solidFill>
+          <a:ln w="9525">
+            <a:solidFill>
+              <a:srgbClr val="3674C1"/>
+            </a:solidFill>
+            <a:prstDash val="solid"/>
+          </a:ln>
+        </p:spPr>
+      </p:sp>
+      <p:sp>
+        <p:nvSpPr>
+          <p:cNvPr id="7" name="Text 5"/>
+          <p:cNvSpPr/>
+          <p:nvPr/>
+        </p:nvSpPr>
+        <p:spPr>
+          <a:xfrm>
+            <a:off x="768096" y="5650992"/>
+            <a:ext cx="10652760" cy="566928"/>
           </a:xfrm>
           <a:prstGeom prst="rect">
             <a:avLst/>
@@ -15724,95 +15975,17 @@
               <a:buNone/>
             </a:pPr>
             <a:r>
-              <a:rPr lang="en-US" sz="4000" b="1" dirty="0">
+              <a:rPr lang="en-US" sz="1600" b="1" dirty="0">
                 <a:solidFill>
                   <a:srgbClr val="1F4C86"/>
                 </a:solidFill>
-                <a:latin typeface="Trebuchet MS" pitchFamily="34" charset="0"/>
-                <a:ea typeface="Trebuchet MS" pitchFamily="34" charset="-122"/>
-                <a:cs typeface="Trebuchet MS" pitchFamily="34" charset="-120"/>
-              </a:rPr>
-              <a:t>Collagen fibre and texture</a:t>
-            </a:r>
-            <a:endParaRPr lang="en-US" sz="4000" dirty="0"/>
-          </a:p>
-        </p:txBody>
-      </p:sp>
-      <p:sp>
-        <p:nvSpPr>
-          <p:cNvPr id="6" name="Text 4"/>
-          <p:cNvSpPr/>
-          <p:nvPr/>
-        </p:nvSpPr>
-        <p:spPr>
-          <a:xfrm>
-            <a:off x="566928" y="3456432"/>
-            <a:ext cx="10140696" cy="731520"/>
-          </a:xfrm>
-          <a:prstGeom prst="rect">
-            <a:avLst/>
-          </a:prstGeom>
-          <a:noFill/>
-          <a:ln/>
-        </p:spPr>
-        <p:txBody>
-          <a:bodyPr wrap="square" rtlCol="0" anchor="t"/>
-          <a:lstStyle/>
-          <a:p>
-            <a:pPr indent="0" marL="0">
-              <a:buNone/>
-            </a:pPr>
-            <a:r>
-              <a:rPr lang="en-US" sz="1900" dirty="0">
-                <a:solidFill>
-                  <a:srgbClr val="5A6675"/>
-                </a:solidFill>
-                <a:latin typeface="Calibri" pitchFamily="34" charset="0"/>
-                <a:ea typeface="Calibri" pitchFamily="34" charset="-122"/>
-                <a:cs typeface="Calibri" pitchFamily="34" charset="-120"/>
-              </a:rPr>
-              <a:t>Architecture, not just presence</a:t>
-            </a:r>
-            <a:endParaRPr lang="en-US" sz="1900" dirty="0"/>
-          </a:p>
-        </p:txBody>
-      </p:sp>
-      <p:sp>
-        <p:nvSpPr>
-          <p:cNvPr id="7" name="Text 5"/>
-          <p:cNvSpPr/>
-          <p:nvPr/>
-        </p:nvSpPr>
-        <p:spPr>
-          <a:xfrm>
-            <a:off x="566928" y="6199632"/>
-            <a:ext cx="8229600" cy="365760"/>
-          </a:xfrm>
-          <a:prstGeom prst="rect">
-            <a:avLst/>
-          </a:prstGeom>
-          <a:noFill/>
-          <a:ln/>
-        </p:spPr>
-        <p:txBody>
-          <a:bodyPr wrap="square" rtlCol="0" anchor="ctr"/>
-          <a:lstStyle/>
-          <a:p>
-            <a:pPr indent="0" marL="0">
-              <a:buNone/>
-            </a:pPr>
-            <a:r>
-              <a:rPr lang="en-US" sz="1400" dirty="0">
-                <a:solidFill>
-                  <a:srgbClr val="A8B2BF"/>
-                </a:solidFill>
-                <a:latin typeface="Calibri" pitchFamily="34" charset="0"/>
-                <a:ea typeface="Calibri" pitchFamily="34" charset="-122"/>
-                <a:cs typeface="Calibri" pitchFamily="34" charset="-120"/>
-              </a:rPr>
-              <a:t>michaelsnelson.github.io/BINA-I2K-2026-QuPath-Extensions</a:t>
-            </a:r>
-            <a:endParaRPr lang="en-US" sz="1400" dirty="0"/>
+                <a:latin typeface="Calibri" pitchFamily="34" charset="0"/>
+                <a:ea typeface="Calibri" pitchFamily="34" charset="-122"/>
+                <a:cs typeface="Calibri" pitchFamily="34" charset="-120"/>
+              </a:rPr>
+              <a:t>Works with any clustering tool’s output, not just QP-CAT’s. It only reads; it writes nothing.</a:t>
+            </a:r>
+            <a:endParaRPr lang="en-US" sz="1600" dirty="0"/>
           </a:p>
         </p:txBody>
       </p:sp>
@@ -16201,14 +16374,54 @@
       </p:grpSpPr>
       <p:sp>
         <p:nvSpPr>
-          <p:cNvPr id="2" name="Text 0"/>
-          <p:cNvSpPr/>
-          <p:nvPr/>
-        </p:nvSpPr>
-        <p:spPr>
-          <a:xfrm>
-            <a:off x="566928" y="384048"/>
-            <a:ext cx="11055096" cy="658368"/>
+          <p:cNvPr id="2" name="Shape 0"/>
+          <p:cNvSpPr/>
+          <p:nvPr/>
+        </p:nvSpPr>
+        <p:spPr>
+          <a:xfrm>
+            <a:off x="0" y="1417320"/>
+            <a:ext cx="12188952" cy="3108960"/>
+          </a:xfrm>
+          <a:prstGeom prst="rect">
+            <a:avLst/>
+          </a:prstGeom>
+          <a:solidFill>
+            <a:srgbClr val="E8F0FA"/>
+          </a:solidFill>
+          <a:ln/>
+        </p:spPr>
+      </p:sp>
+      <p:sp>
+        <p:nvSpPr>
+          <p:cNvPr id="3" name="Shape 1"/>
+          <p:cNvSpPr/>
+          <p:nvPr/>
+        </p:nvSpPr>
+        <p:spPr>
+          <a:xfrm>
+            <a:off x="0" y="1417320"/>
+            <a:ext cx="201168" cy="3108960"/>
+          </a:xfrm>
+          <a:prstGeom prst="rect">
+            <a:avLst/>
+          </a:prstGeom>
+          <a:solidFill>
+            <a:srgbClr val="3674C1"/>
+          </a:solidFill>
+          <a:ln/>
+        </p:spPr>
+      </p:sp>
+      <p:sp>
+        <p:nvSpPr>
+          <p:cNvPr id="4" name="Text 2"/>
+          <p:cNvSpPr/>
+          <p:nvPr/>
+        </p:nvSpPr>
+        <p:spPr>
+          <a:xfrm>
+            <a:off x="566928" y="1691640"/>
+            <a:ext cx="1828800" cy="914400"/>
           </a:xfrm>
           <a:prstGeom prst="rect">
             <a:avLst/>
@@ -16224,50 +16437,30 @@
               <a:buNone/>
             </a:pPr>
             <a:r>
-              <a:rPr lang="en-US" sz="3000" b="1" dirty="0">
-                <a:solidFill>
-                  <a:srgbClr val="1F4C86"/>
+              <a:rPr lang="en-US" sz="5400" b="1" dirty="0">
+                <a:solidFill>
+                  <a:srgbClr val="3674C1"/>
                 </a:solidFill>
                 <a:latin typeface="Trebuchet MS" pitchFamily="34" charset="0"/>
                 <a:ea typeface="Trebuchet MS" pitchFamily="34" charset="-122"/>
                 <a:cs typeface="Trebuchet MS" pitchFamily="34" charset="-120"/>
               </a:rPr>
-              <a:t>Why fibre architecture</a:t>
-            </a:r>
-            <a:endParaRPr lang="en-US" sz="3000" dirty="0"/>
-          </a:p>
-        </p:txBody>
-      </p:sp>
-      <p:sp>
-        <p:nvSpPr>
-          <p:cNvPr id="3" name="Shape 1"/>
-          <p:cNvSpPr/>
-          <p:nvPr/>
-        </p:nvSpPr>
-        <p:spPr>
-          <a:xfrm>
-            <a:off x="566928" y="1097280"/>
-            <a:ext cx="1920240" cy="50292"/>
-          </a:xfrm>
-          <a:prstGeom prst="rect">
-            <a:avLst/>
-          </a:prstGeom>
-          <a:solidFill>
-            <a:srgbClr val="3674C1"/>
-          </a:solidFill>
-          <a:ln/>
-        </p:spPr>
-      </p:sp>
-      <p:sp>
-        <p:nvSpPr>
-          <p:cNvPr id="4" name="Text 2"/>
-          <p:cNvSpPr/>
-          <p:nvPr/>
-        </p:nvSpPr>
-        <p:spPr>
-          <a:xfrm>
-            <a:off x="566928" y="1243584"/>
-            <a:ext cx="11055096" cy="384048"/>
+              <a:t>07</a:t>
+            </a:r>
+            <a:endParaRPr lang="en-US" sz="5400" dirty="0"/>
+          </a:p>
+        </p:txBody>
+      </p:sp>
+      <p:sp>
+        <p:nvSpPr>
+          <p:cNvPr id="5" name="Text 3"/>
+          <p:cNvSpPr/>
+          <p:nvPr/>
+        </p:nvSpPr>
+        <p:spPr>
+          <a:xfrm>
+            <a:off x="566928" y="2606040"/>
+            <a:ext cx="11055096" cy="868680"/>
           </a:xfrm>
           <a:prstGeom prst="rect">
             <a:avLst/>
@@ -16283,30 +16476,30 @@
               <a:buNone/>
             </a:pPr>
             <a:r>
-              <a:rPr lang="en-US" sz="1700" i="1" dirty="0">
-                <a:solidFill>
-                  <a:srgbClr val="5A6675"/>
-                </a:solidFill>
-                <a:latin typeface="Calibri" pitchFamily="34" charset="0"/>
-                <a:ea typeface="Calibri" pitchFamily="34" charset="-122"/>
-                <a:cs typeface="Calibri" pitchFamily="34" charset="-120"/>
-              </a:rPr>
-              <a:t>Conklin et al. 2011, American Journal of Pathology 178:1221.</a:t>
-            </a:r>
-            <a:endParaRPr lang="en-US" sz="1700" dirty="0"/>
-          </a:p>
-        </p:txBody>
-      </p:sp>
-      <p:sp>
-        <p:nvSpPr>
-          <p:cNvPr id="5" name="Text 3"/>
-          <p:cNvSpPr/>
-          <p:nvPr/>
-        </p:nvSpPr>
-        <p:spPr>
-          <a:xfrm>
-            <a:off x="640080" y="1755648"/>
-            <a:ext cx="10963656" cy="4279392"/>
+              <a:rPr lang="en-US" sz="4000" b="1" dirty="0">
+                <a:solidFill>
+                  <a:srgbClr val="1F4C86"/>
+                </a:solidFill>
+                <a:latin typeface="Trebuchet MS" pitchFamily="34" charset="0"/>
+                <a:ea typeface="Trebuchet MS" pitchFamily="34" charset="-122"/>
+                <a:cs typeface="Trebuchet MS" pitchFamily="34" charset="-120"/>
+              </a:rPr>
+              <a:t>Collagen fibre and texture</a:t>
+            </a:r>
+            <a:endParaRPr lang="en-US" sz="4000" dirty="0"/>
+          </a:p>
+        </p:txBody>
+      </p:sp>
+      <p:sp>
+        <p:nvSpPr>
+          <p:cNvPr id="6" name="Text 4"/>
+          <p:cNvSpPr/>
+          <p:nvPr/>
+        </p:nvSpPr>
+        <p:spPr>
+          <a:xfrm>
+            <a:off x="566928" y="3456432"/>
+            <a:ext cx="10140696" cy="731520"/>
           </a:xfrm>
           <a:prstGeom prst="rect">
             <a:avLst/>
@@ -16316,166 +16509,62 @@
         </p:spPr>
         <p:txBody>
           <a:bodyPr wrap="square" rtlCol="0" anchor="t"/>
-          <a:lstStyle/>
-          <a:p>
-            <a:pPr marL="342900" indent="-342900">
-              <a:lnSpc>
-                <a:spcPct val="105000"/>
-              </a:lnSpc>
-              <a:spcAft>
-                <a:spcPts val="1200"/>
-              </a:spcAft>
-              <a:buSzPct val="100000"/>
-              <a:buChar char="•"/>
-            </a:pPr>
-            <a:r>
-              <a:rPr lang="en-US" sz="2000" dirty="0">
-                <a:solidFill>
-                  <a:srgbClr val="1F2933"/>
-                </a:solidFill>
-                <a:latin typeface="Calibri" pitchFamily="34" charset="0"/>
-                <a:ea typeface="Calibri" pitchFamily="34" charset="-122"/>
-                <a:cs typeface="Calibri" pitchFamily="34" charset="-120"/>
-              </a:rPr>
-              <a:t>Collagen is not simply present or absent — the arrangement carries the biology</a:t>
-            </a:r>
-            <a:endParaRPr lang="en-US" sz="2000" dirty="0"/>
-          </a:p>
-          <a:p>
-            <a:pPr marL="342900" indent="-342900">
-              <a:lnSpc>
-                <a:spcPct val="105000"/>
-              </a:lnSpc>
-              <a:spcAft>
-                <a:spcPts val="1200"/>
-              </a:spcAft>
-              <a:buSzPct val="100000"/>
-              <a:buChar char="•"/>
-            </a:pPr>
-            <a:r>
-              <a:rPr lang="en-US" sz="2000" dirty="0">
-                <a:solidFill>
-                  <a:srgbClr val="1F2933"/>
-                </a:solidFill>
-                <a:latin typeface="Calibri" pitchFamily="34" charset="0"/>
-                <a:ea typeface="Calibri" pitchFamily="34" charset="-122"/>
-                <a:cs typeface="Calibri" pitchFamily="34" charset="-120"/>
-              </a:rPr>
-              <a:t>Wavy versus straightened; aligned versus isotropic; and how that changes at a boundary</a:t>
-            </a:r>
-            <a:endParaRPr lang="en-US" sz="2000" dirty="0"/>
-          </a:p>
-          <a:p>
-            <a:pPr marL="342900" indent="-342900">
-              <a:lnSpc>
-                <a:spcPct val="105000"/>
-              </a:lnSpc>
-              <a:spcAft>
-                <a:spcPts val="1200"/>
-              </a:spcAft>
-              <a:buSzPct val="100000"/>
-              <a:buChar char="•"/>
-            </a:pPr>
-            <a:r>
-              <a:rPr lang="en-US" sz="2000" dirty="0">
-                <a:solidFill>
-                  <a:srgbClr val="1F2933"/>
-                </a:solidFill>
-                <a:latin typeface="Calibri" pitchFamily="34" charset="0"/>
-                <a:ea typeface="Calibri" pitchFamily="34" charset="-122"/>
-                <a:cs typeface="Calibri" pitchFamily="34" charset="-120"/>
-              </a:rPr>
-              <a:t>In breast pathology, straightened fibres running perpendicular to the tumour boundary act as tracks for invading cells</a:t>
-            </a:r>
-            <a:endParaRPr lang="en-US" sz="2000" dirty="0"/>
-          </a:p>
-          <a:p>
-            <a:pPr marL="342900" indent="-342900">
-              <a:lnSpc>
-                <a:spcPct val="105000"/>
-              </a:lnSpc>
-              <a:spcAft>
-                <a:spcPts val="1200"/>
-              </a:spcAft>
-              <a:buSzPct val="100000"/>
-              <a:buChar char="•"/>
-            </a:pPr>
-            <a:r>
-              <a:rPr lang="en-US" sz="2000" dirty="0">
-                <a:solidFill>
-                  <a:srgbClr val="1F2933"/>
-                </a:solidFill>
-                <a:latin typeface="Calibri" pitchFamily="34" charset="0"/>
-                <a:ea typeface="Calibri" pitchFamily="34" charset="-122"/>
-                <a:cs typeface="Calibri" pitchFamily="34" charset="-120"/>
-              </a:rPr>
-              <a:t>Hazard ratio 3.0–3.9 for disease-free survival, independent of grade, size and receptor status</a:t>
-            </a:r>
-            <a:endParaRPr lang="en-US" sz="2000" dirty="0"/>
-          </a:p>
-        </p:txBody>
-      </p:sp>
-      <p:sp>
-        <p:nvSpPr>
-          <p:cNvPr id="6" name="Shape 4"/>
-          <p:cNvSpPr/>
-          <p:nvPr/>
-        </p:nvSpPr>
-        <p:spPr>
-          <a:xfrm>
-            <a:off x="566928" y="5650992"/>
-            <a:ext cx="11055096" cy="566928"/>
-          </a:xfrm>
-          <a:prstGeom prst="rect">
-            <a:avLst/>
-          </a:prstGeom>
-          <a:solidFill>
-            <a:srgbClr val="F4F8FD"/>
-          </a:solidFill>
-          <a:ln w="9525">
-            <a:solidFill>
-              <a:srgbClr val="3674C1"/>
-            </a:solidFill>
-            <a:prstDash val="solid"/>
-          </a:ln>
-        </p:spPr>
-      </p:sp>
-      <p:sp>
-        <p:nvSpPr>
-          <p:cNvPr id="7" name="Text 5"/>
-          <p:cNvSpPr/>
-          <p:nvPr/>
-        </p:nvSpPr>
-        <p:spPr>
-          <a:xfrm>
-            <a:off x="768096" y="5650992"/>
-            <a:ext cx="10652760" cy="566928"/>
-          </a:xfrm>
-          <a:prstGeom prst="rect">
-            <a:avLst/>
-          </a:prstGeom>
-          <a:noFill/>
-          <a:ln/>
-        </p:spPr>
-        <p:txBody>
-          <a:bodyPr wrap="square" rtlCol="0" anchor="ctr"/>
           <a:lstStyle/>
           <a:p>
             <a:pPr indent="0" marL="0">
               <a:buNone/>
             </a:pPr>
             <a:r>
-              <a:rPr lang="en-US" sz="1600" b="1" dirty="0">
-                <a:solidFill>
-                  <a:srgbClr val="1F4C86"/>
-                </a:solidFill>
-                <a:latin typeface="Calibri" pitchFamily="34" charset="0"/>
-                <a:ea typeface="Calibri" pitchFamily="34" charset="-122"/>
-                <a:cs typeface="Calibri" pitchFamily="34" charset="-120"/>
-              </a:rPr>
-              <a:t>The same wavy-to-straight axis recurs in arterial adventitia, sclera, alveolar wall, and cardiac fibrosis.</a:t>
-            </a:r>
-            <a:endParaRPr lang="en-US" sz="1600" dirty="0"/>
+              <a:rPr lang="en-US" sz="1900" dirty="0">
+                <a:solidFill>
+                  <a:srgbClr val="5A6675"/>
+                </a:solidFill>
+                <a:latin typeface="Calibri" pitchFamily="34" charset="0"/>
+                <a:ea typeface="Calibri" pitchFamily="34" charset="-122"/>
+                <a:cs typeface="Calibri" pitchFamily="34" charset="-120"/>
+              </a:rPr>
+              <a:t>Architecture, not just presence</a:t>
+            </a:r>
+            <a:endParaRPr lang="en-US" sz="1900" dirty="0"/>
+          </a:p>
+        </p:txBody>
+      </p:sp>
+      <p:sp>
+        <p:nvSpPr>
+          <p:cNvPr id="7" name="Text 5"/>
+          <p:cNvSpPr/>
+          <p:nvPr/>
+        </p:nvSpPr>
+        <p:spPr>
+          <a:xfrm>
+            <a:off x="566928" y="6199632"/>
+            <a:ext cx="8229600" cy="365760"/>
+          </a:xfrm>
+          <a:prstGeom prst="rect">
+            <a:avLst/>
+          </a:prstGeom>
+          <a:noFill/>
+          <a:ln/>
+        </p:spPr>
+        <p:txBody>
+          <a:bodyPr wrap="square" rtlCol="0" anchor="ctr"/>
+          <a:lstStyle/>
+          <a:p>
+            <a:pPr indent="0" marL="0">
+              <a:buNone/>
+            </a:pPr>
+            <a:r>
+              <a:rPr lang="en-US" sz="1400" dirty="0">
+                <a:solidFill>
+                  <a:srgbClr val="A8B2BF"/>
+                </a:solidFill>
+                <a:latin typeface="Calibri" pitchFamily="34" charset="0"/>
+                <a:ea typeface="Calibri" pitchFamily="34" charset="-122"/>
+                <a:cs typeface="Calibri" pitchFamily="34" charset="-120"/>
+              </a:rPr>
+              <a:t>michaelsnelson.github.io/BINA-I2K-2026-QuPath-Extensions</a:t>
+            </a:r>
+            <a:endParaRPr lang="en-US" sz="1400" dirty="0"/>
           </a:p>
         </p:txBody>
       </p:sp>
@@ -16583,7 +16672,7 @@
                 <a:ea typeface="Trebuchet MS" pitchFamily="34" charset="-122"/>
                 <a:cs typeface="Trebuchet MS" pitchFamily="34" charset="-120"/>
               </a:rPr>
-              <a:t>Two complementary tools</a:t>
+              <a:t>Why fibre architecture</a:t>
             </a:r>
             <a:endParaRPr lang="en-US" sz="3000" dirty="0"/>
           </a:p>
@@ -16611,34 +16700,14 @@
       </p:sp>
       <p:sp>
         <p:nvSpPr>
-          <p:cNvPr id="4" name="Shape 2"/>
-          <p:cNvSpPr/>
-          <p:nvPr/>
-        </p:nvSpPr>
-        <p:spPr>
-          <a:xfrm>
-            <a:off x="566928" y="1554480"/>
-            <a:ext cx="5298948" cy="530352"/>
-          </a:xfrm>
-          <a:prstGeom prst="rect">
-            <a:avLst/>
-          </a:prstGeom>
-          <a:solidFill>
-            <a:srgbClr val="E8F0FA"/>
-          </a:solidFill>
-          <a:ln/>
-        </p:spPr>
-      </p:sp>
-      <p:sp>
-        <p:nvSpPr>
-          <p:cNvPr id="5" name="Text 3"/>
-          <p:cNvSpPr/>
-          <p:nvPr/>
-        </p:nvSpPr>
-        <p:spPr>
-          <a:xfrm>
-            <a:off x="731520" y="1554480"/>
-            <a:ext cx="4969764" cy="530352"/>
+          <p:cNvPr id="4" name="Text 2"/>
+          <p:cNvSpPr/>
+          <p:nvPr/>
+        </p:nvSpPr>
+        <p:spPr>
+          <a:xfrm>
+            <a:off x="566928" y="1243584"/>
+            <a:ext cx="11055096" cy="384048"/>
           </a:xfrm>
           <a:prstGeom prst="rect">
             <a:avLst/>
@@ -16654,30 +16723,30 @@
               <a:buNone/>
             </a:pPr>
             <a:r>
-              <a:rPr lang="en-US" sz="2000" b="1" dirty="0">
-                <a:solidFill>
-                  <a:srgbClr val="1F4C86"/>
-                </a:solidFill>
-                <a:latin typeface="Trebuchet MS" pitchFamily="34" charset="0"/>
-                <a:ea typeface="Trebuchet MS" pitchFamily="34" charset="-122"/>
-                <a:cs typeface="Trebuchet MS" pitchFamily="34" charset="-120"/>
-              </a:rPr>
-              <a:t>Fiber Analysis — measure a zone</a:t>
-            </a:r>
-            <a:endParaRPr lang="en-US" sz="2000" dirty="0"/>
-          </a:p>
-        </p:txBody>
-      </p:sp>
-      <p:sp>
-        <p:nvSpPr>
-          <p:cNvPr id="6" name="Text 4"/>
-          <p:cNvSpPr/>
-          <p:nvPr/>
-        </p:nvSpPr>
-        <p:spPr>
-          <a:xfrm>
-            <a:off x="658368" y="2240280"/>
-            <a:ext cx="5116068" cy="3566160"/>
+              <a:rPr lang="en-US" sz="1700" i="1" dirty="0">
+                <a:solidFill>
+                  <a:srgbClr val="5A6675"/>
+                </a:solidFill>
+                <a:latin typeface="Calibri" pitchFamily="34" charset="0"/>
+                <a:ea typeface="Calibri" pitchFamily="34" charset="-122"/>
+                <a:cs typeface="Calibri" pitchFamily="34" charset="-120"/>
+              </a:rPr>
+              <a:t>Conklin et al. 2011, American Journal of Pathology 178:1221.</a:t>
+            </a:r>
+            <a:endParaRPr lang="en-US" sz="1700" dirty="0"/>
+          </a:p>
+        </p:txBody>
+      </p:sp>
+      <p:sp>
+        <p:nvSpPr>
+          <p:cNvPr id="5" name="Text 3"/>
+          <p:cNvSpPr/>
+          <p:nvPr/>
+        </p:nvSpPr>
+        <p:spPr>
+          <a:xfrm>
+            <a:off x="640080" y="1755648"/>
+            <a:ext cx="10963656" cy="4279392"/>
           </a:xfrm>
           <a:prstGeom prst="rect">
             <a:avLst/>
@@ -16690,14 +16759,17 @@
           <a:lstStyle/>
           <a:p>
             <a:pPr marL="342900" indent="-342900">
+              <a:lnSpc>
+                <a:spcPct val="105000"/>
+              </a:lnSpc>
               <a:spcAft>
-                <a:spcPts val="1100"/>
+                <a:spcPts val="1200"/>
               </a:spcAft>
               <a:buSzPct val="100000"/>
               <a:buChar char="•"/>
             </a:pPr>
             <a:r>
-              <a:rPr lang="en-US" sz="1800" dirty="0">
+              <a:rPr lang="en-US" sz="2000" dirty="0">
                 <a:solidFill>
                   <a:srgbClr val="1F2933"/>
                 </a:solidFill>
@@ -16705,20 +16777,23 @@
                 <a:ea typeface="Calibri" pitchFamily="34" charset="-122"/>
                 <a:cs typeface="Calibri" pitchFamily="34" charset="-120"/>
               </a:rPr>
-              <a:t>A band of chosen width inside, outside, or across an annotation boundary</a:t>
-            </a:r>
-            <a:endParaRPr lang="en-US" sz="1800" dirty="0"/>
+              <a:t>Collagen is not simply present or absent — the arrangement carries the biology</a:t>
+            </a:r>
+            <a:endParaRPr lang="en-US" sz="2000" dirty="0"/>
           </a:p>
           <a:p>
             <a:pPr marL="342900" indent="-342900">
+              <a:lnSpc>
+                <a:spcPct val="105000"/>
+              </a:lnSpc>
               <a:spcAft>
-                <a:spcPts val="1100"/>
+                <a:spcPts val="1200"/>
               </a:spcAft>
               <a:buSzPct val="100000"/>
               <a:buChar char="•"/>
             </a:pPr>
             <a:r>
-              <a:rPr lang="en-US" sz="1800" dirty="0">
+              <a:rPr lang="en-US" sz="2000" dirty="0">
                 <a:solidFill>
                   <a:srgbClr val="1F2933"/>
                 </a:solidFill>
@@ -16726,20 +16801,23 @@
                 <a:ea typeface="Calibri" pitchFamily="34" charset="-122"/>
                 <a:cs typeface="Calibri" pitchFamily="34" charset="-120"/>
               </a:rPr>
-              <a:t>Straightness and persistence: wavy versus straightened fibres</a:t>
-            </a:r>
-            <a:endParaRPr lang="en-US" sz="1800" dirty="0"/>
+              <a:t>Wavy versus straightened; aligned versus isotropic; and how that changes at a boundary</a:t>
+            </a:r>
+            <a:endParaRPr lang="en-US" sz="2000" dirty="0"/>
           </a:p>
           <a:p>
             <a:pPr marL="342900" indent="-342900">
+              <a:lnSpc>
+                <a:spcPct val="105000"/>
+              </a:lnSpc>
               <a:spcAft>
-                <a:spcPts val="1100"/>
+                <a:spcPts val="1200"/>
               </a:spcAft>
               <a:buSzPct val="100000"/>
               <a:buChar char="•"/>
             </a:pPr>
             <a:r>
-              <a:rPr lang="en-US" sz="1800" dirty="0">
+              <a:rPr lang="en-US" sz="2000" dirty="0">
                 <a:solidFill>
                   <a:srgbClr val="1F2933"/>
                 </a:solidFill>
@@ -16747,20 +16825,23 @@
                 <a:ea typeface="Calibri" pitchFamily="34" charset="-122"/>
                 <a:cs typeface="Calibri" pitchFamily="34" charset="-120"/>
               </a:rPr>
-              <a:t>Morphometrics: coverage, length, branching, fractal dimension, gaps</a:t>
-            </a:r>
-            <a:endParaRPr lang="en-US" sz="1800" dirty="0"/>
+              <a:t>In breast pathology, straightened fibres running perpendicular to the tumour boundary act as tracks for invading cells</a:t>
+            </a:r>
+            <a:endParaRPr lang="en-US" sz="2000" dirty="0"/>
           </a:p>
           <a:p>
             <a:pPr marL="342900" indent="-342900">
+              <a:lnSpc>
+                <a:spcPct val="105000"/>
+              </a:lnSpc>
               <a:spcAft>
-                <a:spcPts val="1100"/>
+                <a:spcPts val="1200"/>
               </a:spcAft>
               <a:buSzPct val="100000"/>
               <a:buChar char="•"/>
             </a:pPr>
             <a:r>
-              <a:rPr lang="en-US" sz="1800" dirty="0">
+              <a:rPr lang="en-US" sz="2000" dirty="0">
                 <a:solidFill>
                   <a:srgbClr val="1F2933"/>
                 </a:solidFill>
@@ -16768,42 +16849,47 @@
                 <a:ea typeface="Calibri" pitchFamily="34" charset="-122"/>
                 <a:cs typeface="Calibri" pitchFamily="34" charset="-120"/>
               </a:rPr>
-              <a:t>Texture: the information fibre-tracing misses entirely</a:t>
-            </a:r>
-            <a:endParaRPr lang="en-US" sz="1800" dirty="0"/>
-          </a:p>
-        </p:txBody>
-      </p:sp>
-      <p:sp>
-        <p:nvSpPr>
-          <p:cNvPr id="7" name="Shape 5"/>
-          <p:cNvSpPr/>
-          <p:nvPr/>
-        </p:nvSpPr>
-        <p:spPr>
-          <a:xfrm>
-            <a:off x="6323076" y="1554480"/>
-            <a:ext cx="5298948" cy="530352"/>
+              <a:t>Hazard ratio 3.0–3.9 for disease-free survival, independent of grade, size and receptor status</a:t>
+            </a:r>
+            <a:endParaRPr lang="en-US" sz="2000" dirty="0"/>
+          </a:p>
+        </p:txBody>
+      </p:sp>
+      <p:sp>
+        <p:nvSpPr>
+          <p:cNvPr id="6" name="Shape 4"/>
+          <p:cNvSpPr/>
+          <p:nvPr/>
+        </p:nvSpPr>
+        <p:spPr>
+          <a:xfrm>
+            <a:off x="566928" y="5650992"/>
+            <a:ext cx="11055096" cy="566928"/>
           </a:xfrm>
           <a:prstGeom prst="rect">
             <a:avLst/>
           </a:prstGeom>
           <a:solidFill>
-            <a:srgbClr val="E8F0FA"/>
+            <a:srgbClr val="F4F8FD"/>
           </a:solidFill>
-          <a:ln/>
-        </p:spPr>
-      </p:sp>
-      <p:sp>
-        <p:nvSpPr>
-          <p:cNvPr id="8" name="Text 6"/>
-          <p:cNvSpPr/>
-          <p:nvPr/>
-        </p:nvSpPr>
-        <p:spPr>
-          <a:xfrm>
-            <a:off x="6487668" y="1554480"/>
-            <a:ext cx="4969764" cy="530352"/>
+          <a:ln w="9525">
+            <a:solidFill>
+              <a:srgbClr val="3674C1"/>
+            </a:solidFill>
+            <a:prstDash val="solid"/>
+          </a:ln>
+        </p:spPr>
+      </p:sp>
+      <p:sp>
+        <p:nvSpPr>
+          <p:cNvPr id="7" name="Text 5"/>
+          <p:cNvSpPr/>
+          <p:nvPr/>
+        </p:nvSpPr>
+        <p:spPr>
+          <a:xfrm>
+            <a:off x="768096" y="5650992"/>
+            <a:ext cx="10652760" cy="566928"/>
           </a:xfrm>
           <a:prstGeom prst="rect">
             <a:avLst/>
@@ -16819,129 +16905,23 @@
               <a:buNone/>
             </a:pPr>
             <a:r>
-              <a:rPr lang="en-US" sz="2000" b="1" dirty="0">
-                <a:solidFill>
-                  <a:srgbClr val="B26A00"/>
-                </a:solidFill>
-                <a:latin typeface="Trebuchet MS" pitchFamily="34" charset="0"/>
-                <a:ea typeface="Trebuchet MS" pitchFamily="34" charset="-122"/>
-                <a:cs typeface="Trebuchet MS" pitchFamily="34" charset="-120"/>
-              </a:rPr>
-              <a:t>TME-Quant — trace the fibres</a:t>
-            </a:r>
-            <a:endParaRPr lang="en-US" sz="2000" dirty="0"/>
-          </a:p>
-        </p:txBody>
-      </p:sp>
-      <p:sp>
-        <p:nvSpPr>
-          <p:cNvPr id="9" name="Text 7"/>
-          <p:cNvSpPr/>
-          <p:nvPr/>
-        </p:nvSpPr>
-        <p:spPr>
-          <a:xfrm>
-            <a:off x="6414516" y="2240280"/>
-            <a:ext cx="5116068" cy="3566160"/>
-          </a:xfrm>
-          <a:prstGeom prst="rect">
-            <a:avLst/>
-          </a:prstGeom>
-          <a:noFill/>
-          <a:ln/>
-        </p:spPr>
-        <p:txBody>
-          <a:bodyPr wrap="square" rtlCol="0" anchor="t"/>
-          <a:lstStyle/>
-          <a:p>
-            <a:pPr marL="342900" indent="-342900">
-              <a:spcAft>
-                <a:spcPts val="1100"/>
-              </a:spcAft>
-              <a:buSzPct val="100000"/>
-              <a:buChar char="•"/>
-            </a:pPr>
-            <a:r>
-              <a:rPr lang="en-US" sz="1800" dirty="0">
-                <a:solidFill>
-                  <a:srgbClr val="1F2933"/>
-                </a:solidFill>
-                <a:latin typeface="Calibri" pitchFamily="34" charset="0"/>
-                <a:ea typeface="Calibri" pitchFamily="34" charset="-122"/>
-                <a:cs typeface="Calibri" pitchFamily="34" charset="-120"/>
-              </a:rPr>
-              <a:t>Individual fibres extracted and committed back as objects</a:t>
-            </a:r>
-            <a:endParaRPr lang="en-US" sz="1800" dirty="0"/>
-          </a:p>
-          <a:p>
-            <a:pPr marL="342900" indent="-342900">
-              <a:spcAft>
-                <a:spcPts val="1100"/>
-              </a:spcAft>
-              <a:buSzPct val="100000"/>
-              <a:buChar char="•"/>
-            </a:pPr>
-            <a:r>
-              <a:rPr lang="en-US" sz="1800" dirty="0">
-                <a:solidFill>
-                  <a:srgbClr val="1F2933"/>
-                </a:solidFill>
-                <a:latin typeface="Calibri" pitchFamily="34" charset="0"/>
-                <a:ea typeface="Calibri" pitchFamily="34" charset="-122"/>
-                <a:cs typeface="Calibri" pitchFamily="34" charset="-120"/>
-              </a:rPr>
-              <a:t>Set the threshold by eye, with the mask shown before you commit</a:t>
-            </a:r>
-            <a:endParaRPr lang="en-US" sz="1800" dirty="0"/>
-          </a:p>
-          <a:p>
-            <a:pPr marL="342900" indent="-342900">
-              <a:spcAft>
-                <a:spcPts val="1100"/>
-              </a:spcAft>
-              <a:buSzPct val="100000"/>
-              <a:buChar char="•"/>
-            </a:pPr>
-            <a:r>
-              <a:rPr lang="en-US" sz="1800" dirty="0">
-                <a:solidFill>
-                  <a:srgbClr val="1F2933"/>
-                </a:solidFill>
-                <a:latin typeface="Calibri" pitchFamily="34" charset="0"/>
-                <a:ea typeface="Calibri" pitchFamily="34" charset="-122"/>
-                <a:cs typeface="Calibri" pitchFamily="34" charset="-120"/>
-              </a:rPr>
-              <a:t>Trace a few real fibres yourself, and it tunes its own parameters to match</a:t>
-            </a:r>
-            <a:endParaRPr lang="en-US" sz="1800" dirty="0"/>
-          </a:p>
-          <a:p>
-            <a:pPr marL="342900" indent="-342900">
-              <a:spcAft>
-                <a:spcPts val="1100"/>
-              </a:spcAft>
-              <a:buSzPct val="100000"/>
-              <a:buChar char="•"/>
-            </a:pPr>
-            <a:r>
-              <a:rPr lang="en-US" sz="1800" dirty="0">
-                <a:solidFill>
-                  <a:srgbClr val="1F2933"/>
-                </a:solidFill>
-                <a:latin typeface="Calibri" pitchFamily="34" charset="0"/>
-                <a:ea typeface="Calibri" pitchFamily="34" charset="-122"/>
-                <a:cs typeface="Calibri" pitchFamily="34" charset="-120"/>
-              </a:rPr>
-              <a:t>Fibres classified by orientation relative to a tumour boundary</a:t>
-            </a:r>
-            <a:endParaRPr lang="en-US" sz="1800" dirty="0"/>
-          </a:p>
-        </p:txBody>
-      </p:sp>
-      <p:sp>
-        <p:nvSpPr>
-          <p:cNvPr id="10" name="Text 8"/>
+              <a:rPr lang="en-US" sz="1600" b="1" dirty="0">
+                <a:solidFill>
+                  <a:srgbClr val="1F4C86"/>
+                </a:solidFill>
+                <a:latin typeface="Calibri" pitchFamily="34" charset="0"/>
+                <a:ea typeface="Calibri" pitchFamily="34" charset="-122"/>
+                <a:cs typeface="Calibri" pitchFamily="34" charset="-120"/>
+              </a:rPr>
+              <a:t>The same wavy-to-straight axis recurs in arterial adventitia, sclera, alveolar wall, and cardiac fibrosis.</a:t>
+            </a:r>
+            <a:endParaRPr lang="en-US" sz="1600" dirty="0"/>
+          </a:p>
+        </p:txBody>
+      </p:sp>
+      <p:sp>
+        <p:nvSpPr>
+          <p:cNvPr id="8" name="Text 6"/>
           <p:cNvSpPr/>
           <p:nvPr/>
         </p:nvSpPr>
@@ -17043,7 +17023,7 @@
                 <a:ea typeface="Trebuchet MS" pitchFamily="34" charset="-122"/>
                 <a:cs typeface="Trebuchet MS" pitchFamily="34" charset="-120"/>
               </a:rPr>
-              <a:t>A dense mat and a sparse clump</a:t>
+              <a:t>Two complementary tools</a:t>
             </a:r>
             <a:endParaRPr lang="en-US" sz="3000" dirty="0"/>
           </a:p>
@@ -17071,14 +17051,73 @@
       </p:sp>
       <p:sp>
         <p:nvSpPr>
-          <p:cNvPr id="4" name="Text 2"/>
-          <p:cNvSpPr/>
-          <p:nvPr/>
-        </p:nvSpPr>
-        <p:spPr>
-          <a:xfrm>
-            <a:off x="640080" y="1481328"/>
-            <a:ext cx="10963656" cy="4553712"/>
+          <p:cNvPr id="4" name="Shape 2"/>
+          <p:cNvSpPr/>
+          <p:nvPr/>
+        </p:nvSpPr>
+        <p:spPr>
+          <a:xfrm>
+            <a:off x="566928" y="1554480"/>
+            <a:ext cx="5298948" cy="530352"/>
+          </a:xfrm>
+          <a:prstGeom prst="rect">
+            <a:avLst/>
+          </a:prstGeom>
+          <a:solidFill>
+            <a:srgbClr val="E8F0FA"/>
+          </a:solidFill>
+          <a:ln/>
+        </p:spPr>
+      </p:sp>
+      <p:sp>
+        <p:nvSpPr>
+          <p:cNvPr id="5" name="Text 3"/>
+          <p:cNvSpPr/>
+          <p:nvPr/>
+        </p:nvSpPr>
+        <p:spPr>
+          <a:xfrm>
+            <a:off x="731520" y="1554480"/>
+            <a:ext cx="4969764" cy="530352"/>
+          </a:xfrm>
+          <a:prstGeom prst="rect">
+            <a:avLst/>
+          </a:prstGeom>
+          <a:noFill/>
+          <a:ln/>
+        </p:spPr>
+        <p:txBody>
+          <a:bodyPr wrap="square" rtlCol="0" anchor="ctr"/>
+          <a:lstStyle/>
+          <a:p>
+            <a:pPr indent="0" marL="0">
+              <a:buNone/>
+            </a:pPr>
+            <a:r>
+              <a:rPr lang="en-US" sz="2000" b="1" dirty="0">
+                <a:solidFill>
+                  <a:srgbClr val="1F4C86"/>
+                </a:solidFill>
+                <a:latin typeface="Trebuchet MS" pitchFamily="34" charset="0"/>
+                <a:ea typeface="Trebuchet MS" pitchFamily="34" charset="-122"/>
+                <a:cs typeface="Trebuchet MS" pitchFamily="34" charset="-120"/>
+              </a:rPr>
+              <a:t>Fiber Analysis — measure a zone</a:t>
+            </a:r>
+            <a:endParaRPr lang="en-US" sz="2000" dirty="0"/>
+          </a:p>
+        </p:txBody>
+      </p:sp>
+      <p:sp>
+        <p:nvSpPr>
+          <p:cNvPr id="6" name="Text 4"/>
+          <p:cNvSpPr/>
+          <p:nvPr/>
+        </p:nvSpPr>
+        <p:spPr>
+          <a:xfrm>
+            <a:off x="658368" y="2240280"/>
+            <a:ext cx="5116068" cy="3566160"/>
           </a:xfrm>
           <a:prstGeom prst="rect">
             <a:avLst/>
@@ -17091,17 +17130,14 @@
           <a:lstStyle/>
           <a:p>
             <a:pPr marL="342900" indent="-342900">
-              <a:lnSpc>
-                <a:spcPct val="105000"/>
-              </a:lnSpc>
               <a:spcAft>
-                <a:spcPts val="1200"/>
+                <a:spcPts val="1100"/>
               </a:spcAft>
               <a:buSzPct val="100000"/>
               <a:buChar char="•"/>
             </a:pPr>
             <a:r>
-              <a:rPr lang="en-US" sz="2000" dirty="0">
+              <a:rPr lang="en-US" sz="1800" dirty="0">
                 <a:solidFill>
                   <a:srgbClr val="1F2933"/>
                 </a:solidFill>
@@ -17109,23 +17145,20 @@
                 <a:ea typeface="Calibri" pitchFamily="34" charset="-122"/>
                 <a:cs typeface="Calibri" pitchFamily="34" charset="-120"/>
               </a:rPr>
-              <a:t>Two fields can share the same mean fibre alignment and be completely different tissue</a:t>
-            </a:r>
-            <a:endParaRPr lang="en-US" sz="2000" dirty="0"/>
+              <a:t>A band of chosen width inside, outside, or across an annotation boundary</a:t>
+            </a:r>
+            <a:endParaRPr lang="en-US" sz="1800" dirty="0"/>
           </a:p>
           <a:p>
             <a:pPr marL="342900" indent="-342900">
-              <a:lnSpc>
-                <a:spcPct val="105000"/>
-              </a:lnSpc>
               <a:spcAft>
-                <a:spcPts val="1200"/>
+                <a:spcPts val="1100"/>
               </a:spcAft>
               <a:buSzPct val="100000"/>
               <a:buChar char="•"/>
             </a:pPr>
             <a:r>
-              <a:rPr lang="en-US" sz="2000" dirty="0">
+              <a:rPr lang="en-US" sz="1800" dirty="0">
                 <a:solidFill>
                   <a:srgbClr val="1F2933"/>
                 </a:solidFill>
@@ -17133,23 +17166,20 @@
                 <a:ea typeface="Calibri" pitchFamily="34" charset="-122"/>
                 <a:cs typeface="Calibri" pitchFamily="34" charset="-120"/>
               </a:rPr>
-              <a:t>Texture measures the spatial heterogeneity that alignment averages away</a:t>
-            </a:r>
-            <a:endParaRPr lang="en-US" sz="2000" dirty="0"/>
+              <a:t>Straightness and persistence: wavy versus straightened fibres</a:t>
+            </a:r>
+            <a:endParaRPr lang="en-US" sz="1800" dirty="0"/>
           </a:p>
           <a:p>
             <a:pPr marL="342900" indent="-342900">
-              <a:lnSpc>
-                <a:spcPct val="105000"/>
-              </a:lnSpc>
               <a:spcAft>
-                <a:spcPts val="1200"/>
+                <a:spcPts val="1100"/>
               </a:spcAft>
               <a:buSzPct val="100000"/>
               <a:buChar char="•"/>
             </a:pPr>
             <a:r>
-              <a:rPr lang="en-US" sz="2000" dirty="0">
+              <a:rPr lang="en-US" sz="1800" dirty="0">
                 <a:solidFill>
                   <a:srgbClr val="1F2933"/>
                 </a:solidFill>
@@ -17157,47 +17187,63 @@
                 <a:ea typeface="Calibri" pitchFamily="34" charset="-122"/>
                 <a:cs typeface="Calibri" pitchFamily="34" charset="-120"/>
               </a:rPr>
-              <a:t>Which is why both tools are worth running, on the same region</a:t>
-            </a:r>
-            <a:endParaRPr lang="en-US" sz="2000" dirty="0"/>
-          </a:p>
-        </p:txBody>
-      </p:sp>
-      <p:sp>
-        <p:nvSpPr>
-          <p:cNvPr id="5" name="Shape 3"/>
-          <p:cNvSpPr/>
-          <p:nvPr/>
-        </p:nvSpPr>
-        <p:spPr>
-          <a:xfrm>
-            <a:off x="566928" y="5650992"/>
-            <a:ext cx="11055096" cy="566928"/>
+              <a:t>Morphometrics: coverage, length, branching, fractal dimension, gaps</a:t>
+            </a:r>
+            <a:endParaRPr lang="en-US" sz="1800" dirty="0"/>
+          </a:p>
+          <a:p>
+            <a:pPr marL="342900" indent="-342900">
+              <a:spcAft>
+                <a:spcPts val="1100"/>
+              </a:spcAft>
+              <a:buSzPct val="100000"/>
+              <a:buChar char="•"/>
+            </a:pPr>
+            <a:r>
+              <a:rPr lang="en-US" sz="1800" dirty="0">
+                <a:solidFill>
+                  <a:srgbClr val="1F2933"/>
+                </a:solidFill>
+                <a:latin typeface="Calibri" pitchFamily="34" charset="0"/>
+                <a:ea typeface="Calibri" pitchFamily="34" charset="-122"/>
+                <a:cs typeface="Calibri" pitchFamily="34" charset="-120"/>
+              </a:rPr>
+              <a:t>Texture: the information fibre-tracing misses entirely</a:t>
+            </a:r>
+            <a:endParaRPr lang="en-US" sz="1800" dirty="0"/>
+          </a:p>
+        </p:txBody>
+      </p:sp>
+      <p:sp>
+        <p:nvSpPr>
+          <p:cNvPr id="7" name="Shape 5"/>
+          <p:cNvSpPr/>
+          <p:nvPr/>
+        </p:nvSpPr>
+        <p:spPr>
+          <a:xfrm>
+            <a:off x="6323076" y="1554480"/>
+            <a:ext cx="5298948" cy="530352"/>
           </a:xfrm>
           <a:prstGeom prst="rect">
             <a:avLst/>
           </a:prstGeom>
           <a:solidFill>
-            <a:srgbClr val="F4F8FD"/>
+            <a:srgbClr val="E8F0FA"/>
           </a:solidFill>
-          <a:ln w="9525">
-            <a:solidFill>
-              <a:srgbClr val="3674C1"/>
-            </a:solidFill>
-            <a:prstDash val="solid"/>
-          </a:ln>
-        </p:spPr>
-      </p:sp>
-      <p:sp>
-        <p:nvSpPr>
-          <p:cNvPr id="6" name="Text 4"/>
-          <p:cNvSpPr/>
-          <p:nvPr/>
-        </p:nvSpPr>
-        <p:spPr>
-          <a:xfrm>
-            <a:off x="768096" y="5650992"/>
-            <a:ext cx="10652760" cy="566928"/>
+          <a:ln/>
+        </p:spPr>
+      </p:sp>
+      <p:sp>
+        <p:nvSpPr>
+          <p:cNvPr id="8" name="Text 6"/>
+          <p:cNvSpPr/>
+          <p:nvPr/>
+        </p:nvSpPr>
+        <p:spPr>
+          <a:xfrm>
+            <a:off x="6487668" y="1554480"/>
+            <a:ext cx="4969764" cy="530352"/>
           </a:xfrm>
           <a:prstGeom prst="rect">
             <a:avLst/>
@@ -17213,23 +17259,129 @@
               <a:buNone/>
             </a:pPr>
             <a:r>
-              <a:rPr lang="en-US" sz="1600" b="1" dirty="0">
-                <a:solidFill>
-                  <a:srgbClr val="1F4C86"/>
-                </a:solidFill>
-                <a:latin typeface="Calibri" pitchFamily="34" charset="0"/>
-                <a:ea typeface="Calibri" pitchFamily="34" charset="-122"/>
-                <a:cs typeface="Calibri" pitchFamily="34" charset="-120"/>
-              </a:rPr>
-              <a:t>Demo only today: one needs a long environment build, the other a dedicated analysis server.</a:t>
-            </a:r>
-            <a:endParaRPr lang="en-US" sz="1600" dirty="0"/>
-          </a:p>
-        </p:txBody>
-      </p:sp>
-      <p:sp>
-        <p:nvSpPr>
-          <p:cNvPr id="7" name="Text 5"/>
+              <a:rPr lang="en-US" sz="2000" b="1" dirty="0">
+                <a:solidFill>
+                  <a:srgbClr val="B26A00"/>
+                </a:solidFill>
+                <a:latin typeface="Trebuchet MS" pitchFamily="34" charset="0"/>
+                <a:ea typeface="Trebuchet MS" pitchFamily="34" charset="-122"/>
+                <a:cs typeface="Trebuchet MS" pitchFamily="34" charset="-120"/>
+              </a:rPr>
+              <a:t>TME-Quant — trace the fibres</a:t>
+            </a:r>
+            <a:endParaRPr lang="en-US" sz="2000" dirty="0"/>
+          </a:p>
+        </p:txBody>
+      </p:sp>
+      <p:sp>
+        <p:nvSpPr>
+          <p:cNvPr id="9" name="Text 7"/>
+          <p:cNvSpPr/>
+          <p:nvPr/>
+        </p:nvSpPr>
+        <p:spPr>
+          <a:xfrm>
+            <a:off x="6414516" y="2240280"/>
+            <a:ext cx="5116068" cy="3566160"/>
+          </a:xfrm>
+          <a:prstGeom prst="rect">
+            <a:avLst/>
+          </a:prstGeom>
+          <a:noFill/>
+          <a:ln/>
+        </p:spPr>
+        <p:txBody>
+          <a:bodyPr wrap="square" rtlCol="0" anchor="t"/>
+          <a:lstStyle/>
+          <a:p>
+            <a:pPr marL="342900" indent="-342900">
+              <a:spcAft>
+                <a:spcPts val="1100"/>
+              </a:spcAft>
+              <a:buSzPct val="100000"/>
+              <a:buChar char="•"/>
+            </a:pPr>
+            <a:r>
+              <a:rPr lang="en-US" sz="1800" dirty="0">
+                <a:solidFill>
+                  <a:srgbClr val="1F2933"/>
+                </a:solidFill>
+                <a:latin typeface="Calibri" pitchFamily="34" charset="0"/>
+                <a:ea typeface="Calibri" pitchFamily="34" charset="-122"/>
+                <a:cs typeface="Calibri" pitchFamily="34" charset="-120"/>
+              </a:rPr>
+              <a:t>Individual fibres extracted and committed back as objects</a:t>
+            </a:r>
+            <a:endParaRPr lang="en-US" sz="1800" dirty="0"/>
+          </a:p>
+          <a:p>
+            <a:pPr marL="342900" indent="-342900">
+              <a:spcAft>
+                <a:spcPts val="1100"/>
+              </a:spcAft>
+              <a:buSzPct val="100000"/>
+              <a:buChar char="•"/>
+            </a:pPr>
+            <a:r>
+              <a:rPr lang="en-US" sz="1800" dirty="0">
+                <a:solidFill>
+                  <a:srgbClr val="1F2933"/>
+                </a:solidFill>
+                <a:latin typeface="Calibri" pitchFamily="34" charset="0"/>
+                <a:ea typeface="Calibri" pitchFamily="34" charset="-122"/>
+                <a:cs typeface="Calibri" pitchFamily="34" charset="-120"/>
+              </a:rPr>
+              <a:t>Set the threshold by eye, with the mask shown before you commit</a:t>
+            </a:r>
+            <a:endParaRPr lang="en-US" sz="1800" dirty="0"/>
+          </a:p>
+          <a:p>
+            <a:pPr marL="342900" indent="-342900">
+              <a:spcAft>
+                <a:spcPts val="1100"/>
+              </a:spcAft>
+              <a:buSzPct val="100000"/>
+              <a:buChar char="•"/>
+            </a:pPr>
+            <a:r>
+              <a:rPr lang="en-US" sz="1800" dirty="0">
+                <a:solidFill>
+                  <a:srgbClr val="1F2933"/>
+                </a:solidFill>
+                <a:latin typeface="Calibri" pitchFamily="34" charset="0"/>
+                <a:ea typeface="Calibri" pitchFamily="34" charset="-122"/>
+                <a:cs typeface="Calibri" pitchFamily="34" charset="-120"/>
+              </a:rPr>
+              <a:t>Trace a few real fibres yourself, and it tunes its own parameters to match</a:t>
+            </a:r>
+            <a:endParaRPr lang="en-US" sz="1800" dirty="0"/>
+          </a:p>
+          <a:p>
+            <a:pPr marL="342900" indent="-342900">
+              <a:spcAft>
+                <a:spcPts val="1100"/>
+              </a:spcAft>
+              <a:buSzPct val="100000"/>
+              <a:buChar char="•"/>
+            </a:pPr>
+            <a:r>
+              <a:rPr lang="en-US" sz="1800" dirty="0">
+                <a:solidFill>
+                  <a:srgbClr val="1F2933"/>
+                </a:solidFill>
+                <a:latin typeface="Calibri" pitchFamily="34" charset="0"/>
+                <a:ea typeface="Calibri" pitchFamily="34" charset="-122"/>
+                <a:cs typeface="Calibri" pitchFamily="34" charset="-120"/>
+              </a:rPr>
+              <a:t>Fibres classified by orientation relative to a tumour boundary</a:t>
+            </a:r>
+            <a:endParaRPr lang="en-US" sz="1800" dirty="0"/>
+          </a:p>
+        </p:txBody>
+      </p:sp>
+      <p:sp>
+        <p:nvSpPr>
+          <p:cNvPr id="10" name="Text 8"/>
           <p:cNvSpPr/>
           <p:nvPr/>
         </p:nvSpPr>
@@ -17331,7 +17483,7 @@
                 <a:ea typeface="Trebuchet MS" pitchFamily="34" charset="-122"/>
                 <a:cs typeface="Trebuchet MS" pitchFamily="34" charset="-120"/>
               </a:rPr>
-              <a:t>Please cite the methods</a:t>
+              <a:t>A dense mat and a sparse clump</a:t>
             </a:r>
             <a:endParaRPr lang="en-US" sz="3000" dirty="0"/>
           </a:p>
@@ -17397,7 +17549,7 @@
                 <a:ea typeface="Calibri" pitchFamily="34" charset="-122"/>
                 <a:cs typeface="Calibri" pitchFamily="34" charset="-120"/>
               </a:rPr>
-              <a:t>Both tools are thin wrappers over other people’s science</a:t>
+              <a:t>Two fields can share the same mean fibre alignment and be completely different tissue</a:t>
             </a:r>
             <a:endParaRPr lang="en-US" sz="2000" dirty="0"/>
           </a:p>
@@ -17421,7 +17573,7 @@
                 <a:ea typeface="Calibri" pitchFamily="34" charset="-122"/>
                 <a:cs typeface="Calibri" pitchFamily="34" charset="-120"/>
               </a:rPr>
-              <a:t>CT-FIRE — Bredfeldt et al. 2014, Journal of Biomedical Optics 19(1):016007</a:t>
+              <a:t>Texture measures the spatial heterogeneity that alignment averages away</a:t>
             </a:r>
             <a:endParaRPr lang="en-US" sz="2000" dirty="0"/>
           </a:p>
@@ -17445,63 +17597,79 @@
                 <a:ea typeface="Calibri" pitchFamily="34" charset="-122"/>
                 <a:cs typeface="Calibri" pitchFamily="34" charset="-120"/>
               </a:rPr>
-              <a:t>CurveAlign — LOCI, University of Wisconsin–Madison</a:t>
+              <a:t>Which is why both tools are worth running, on the same region</a:t>
             </a:r>
             <a:endParaRPr lang="en-US" sz="2000" dirty="0"/>
           </a:p>
-          <a:p>
-            <a:pPr marL="342900" indent="-342900">
-              <a:lnSpc>
-                <a:spcPct val="105000"/>
-              </a:lnSpc>
-              <a:spcAft>
-                <a:spcPts val="1200"/>
-              </a:spcAft>
-              <a:buSzPct val="100000"/>
-              <a:buChar char="•"/>
-            </a:pPr>
-            <a:r>
-              <a:rPr lang="en-US" sz="2000" dirty="0">
-                <a:solidFill>
-                  <a:srgbClr val="1F2933"/>
-                </a:solidFill>
-                <a:latin typeface="Calibri" pitchFamily="34" charset="0"/>
-                <a:ea typeface="Calibri" pitchFamily="34" charset="-122"/>
-                <a:cs typeface="Calibri" pitchFamily="34" charset="-120"/>
-              </a:rPr>
-              <a:t>TACS — Conklin et al. 2011; Provenzano et al. 2008, BMC Medicine 6:11</a:t>
-            </a:r>
-            <a:endParaRPr lang="en-US" sz="2000" dirty="0"/>
-          </a:p>
-          <a:p>
-            <a:pPr marL="342900" indent="-342900">
-              <a:lnSpc>
-                <a:spcPct val="105000"/>
-              </a:lnSpc>
-              <a:spcAft>
-                <a:spcPts val="1200"/>
-              </a:spcAft>
-              <a:buSzPct val="100000"/>
-              <a:buChar char="•"/>
-            </a:pPr>
-            <a:r>
-              <a:rPr lang="en-US" sz="2000" dirty="0">
-                <a:solidFill>
-                  <a:srgbClr val="1F2933"/>
-                </a:solidFill>
-                <a:latin typeface="Calibri" pitchFamily="34" charset="0"/>
-                <a:ea typeface="Calibri" pitchFamily="34" charset="-122"/>
-                <a:cs typeface="Calibri" pitchFamily="34" charset="-120"/>
-              </a:rPr>
-              <a:t>TWOMBLI — Wershof et al. 2021, Life Science Alliance 4(3)</a:t>
-            </a:r>
-            <a:endParaRPr lang="en-US" sz="2000" dirty="0"/>
-          </a:p>
-        </p:txBody>
-      </p:sp>
-      <p:sp>
-        <p:nvSpPr>
-          <p:cNvPr id="5" name="Text 3"/>
+        </p:txBody>
+      </p:sp>
+      <p:sp>
+        <p:nvSpPr>
+          <p:cNvPr id="5" name="Shape 3"/>
+          <p:cNvSpPr/>
+          <p:nvPr/>
+        </p:nvSpPr>
+        <p:spPr>
+          <a:xfrm>
+            <a:off x="566928" y="5650992"/>
+            <a:ext cx="11055096" cy="566928"/>
+          </a:xfrm>
+          <a:prstGeom prst="rect">
+            <a:avLst/>
+          </a:prstGeom>
+          <a:solidFill>
+            <a:srgbClr val="F4F8FD"/>
+          </a:solidFill>
+          <a:ln w="9525">
+            <a:solidFill>
+              <a:srgbClr val="3674C1"/>
+            </a:solidFill>
+            <a:prstDash val="solid"/>
+          </a:ln>
+        </p:spPr>
+      </p:sp>
+      <p:sp>
+        <p:nvSpPr>
+          <p:cNvPr id="6" name="Text 4"/>
+          <p:cNvSpPr/>
+          <p:nvPr/>
+        </p:nvSpPr>
+        <p:spPr>
+          <a:xfrm>
+            <a:off x="768096" y="5650992"/>
+            <a:ext cx="10652760" cy="566928"/>
+          </a:xfrm>
+          <a:prstGeom prst="rect">
+            <a:avLst/>
+          </a:prstGeom>
+          <a:noFill/>
+          <a:ln/>
+        </p:spPr>
+        <p:txBody>
+          <a:bodyPr wrap="square" rtlCol="0" anchor="ctr"/>
+          <a:lstStyle/>
+          <a:p>
+            <a:pPr indent="0" marL="0">
+              <a:buNone/>
+            </a:pPr>
+            <a:r>
+              <a:rPr lang="en-US" sz="1600" b="1" dirty="0">
+                <a:solidFill>
+                  <a:srgbClr val="1F4C86"/>
+                </a:solidFill>
+                <a:latin typeface="Calibri" pitchFamily="34" charset="0"/>
+                <a:ea typeface="Calibri" pitchFamily="34" charset="-122"/>
+                <a:cs typeface="Calibri" pitchFamily="34" charset="-120"/>
+              </a:rPr>
+              <a:t>Demo only today: one needs a long environment build, the other a dedicated analysis server.</a:t>
+            </a:r>
+            <a:endParaRPr lang="en-US" sz="1600" dirty="0"/>
+          </a:p>
+        </p:txBody>
+      </p:sp>
+      <p:sp>
+        <p:nvSpPr>
+          <p:cNvPr id="7" name="Text 5"/>
           <p:cNvSpPr/>
           <p:nvPr/>
         </p:nvSpPr>
@@ -17572,23 +17740,42 @@
       </p:grpSpPr>
       <p:sp>
         <p:nvSpPr>
-          <p:cNvPr id="2" name="Shape 0"/>
-          <p:cNvSpPr/>
-          <p:nvPr/>
-        </p:nvSpPr>
-        <p:spPr>
-          <a:xfrm>
-            <a:off x="0" y="1417320"/>
-            <a:ext cx="12188952" cy="3108960"/>
-          </a:xfrm>
-          <a:prstGeom prst="rect">
-            <a:avLst/>
-          </a:prstGeom>
-          <a:solidFill>
-            <a:srgbClr val="E8F0FA"/>
-          </a:solidFill>
-          <a:ln/>
-        </p:spPr>
+          <p:cNvPr id="2" name="Text 0"/>
+          <p:cNvSpPr/>
+          <p:nvPr/>
+        </p:nvSpPr>
+        <p:spPr>
+          <a:xfrm>
+            <a:off x="566928" y="384048"/>
+            <a:ext cx="11055096" cy="658368"/>
+          </a:xfrm>
+          <a:prstGeom prst="rect">
+            <a:avLst/>
+          </a:prstGeom>
+          <a:noFill/>
+          <a:ln/>
+        </p:spPr>
+        <p:txBody>
+          <a:bodyPr wrap="square" rtlCol="0" anchor="ctr"/>
+          <a:lstStyle/>
+          <a:p>
+            <a:pPr indent="0" marL="0">
+              <a:buNone/>
+            </a:pPr>
+            <a:r>
+              <a:rPr lang="en-US" sz="3000" b="1" dirty="0">
+                <a:solidFill>
+                  <a:srgbClr val="1F4C86"/>
+                </a:solidFill>
+                <a:latin typeface="Trebuchet MS" pitchFamily="34" charset="0"/>
+                <a:ea typeface="Trebuchet MS" pitchFamily="34" charset="-122"/>
+                <a:cs typeface="Trebuchet MS" pitchFamily="34" charset="-120"/>
+              </a:rPr>
+              <a:t>Please cite the methods</a:t>
+            </a:r>
+            <a:endParaRPr lang="en-US" sz="3000" dirty="0"/>
+          </a:p>
+        </p:txBody>
       </p:sp>
       <p:sp>
         <p:nvSpPr>
@@ -17598,8 +17785,8 @@
         </p:nvSpPr>
         <p:spPr>
           <a:xfrm>
-            <a:off x="0" y="1417320"/>
-            <a:ext cx="201168" cy="3108960"/>
+            <a:off x="566928" y="1097280"/>
+            <a:ext cx="1920240" cy="50292"/>
           </a:xfrm>
           <a:prstGeom prst="rect">
             <a:avLst/>
@@ -17618,157 +17805,143 @@
         </p:nvSpPr>
         <p:spPr>
           <a:xfrm>
-            <a:off x="566928" y="1691640"/>
-            <a:ext cx="1828800" cy="914400"/>
-          </a:xfrm>
-          <a:prstGeom prst="rect">
-            <a:avLst/>
-          </a:prstGeom>
-          <a:noFill/>
-          <a:ln/>
-        </p:spPr>
-        <p:txBody>
-          <a:bodyPr wrap="square" rtlCol="0" anchor="ctr"/>
-          <a:lstStyle/>
-          <a:p>
-            <a:pPr indent="0" marL="0">
-              <a:buNone/>
-            </a:pPr>
-            <a:r>
-              <a:rPr lang="en-US" sz="5400" b="1" dirty="0">
-                <a:solidFill>
-                  <a:srgbClr val="3674C1"/>
-                </a:solidFill>
-                <a:latin typeface="Trebuchet MS" pitchFamily="34" charset="0"/>
-                <a:ea typeface="Trebuchet MS" pitchFamily="34" charset="-122"/>
-                <a:cs typeface="Trebuchet MS" pitchFamily="34" charset="-120"/>
-              </a:rPr>
-              <a:t>08</a:t>
-            </a:r>
-            <a:endParaRPr lang="en-US" sz="5400" dirty="0"/>
+            <a:off x="640080" y="1481328"/>
+            <a:ext cx="10963656" cy="4553712"/>
+          </a:xfrm>
+          <a:prstGeom prst="rect">
+            <a:avLst/>
+          </a:prstGeom>
+          <a:noFill/>
+          <a:ln/>
+        </p:spPr>
+        <p:txBody>
+          <a:bodyPr wrap="square" rtlCol="0" anchor="t"/>
+          <a:lstStyle/>
+          <a:p>
+            <a:pPr marL="342900" indent="-342900">
+              <a:lnSpc>
+                <a:spcPct val="105000"/>
+              </a:lnSpc>
+              <a:spcAft>
+                <a:spcPts val="1200"/>
+              </a:spcAft>
+              <a:buSzPct val="100000"/>
+              <a:buChar char="•"/>
+            </a:pPr>
+            <a:r>
+              <a:rPr lang="en-US" sz="2000" dirty="0">
+                <a:solidFill>
+                  <a:srgbClr val="1F2933"/>
+                </a:solidFill>
+                <a:latin typeface="Calibri" pitchFamily="34" charset="0"/>
+                <a:ea typeface="Calibri" pitchFamily="34" charset="-122"/>
+                <a:cs typeface="Calibri" pitchFamily="34" charset="-120"/>
+              </a:rPr>
+              <a:t>Both tools are thin wrappers over other people’s science</a:t>
+            </a:r>
+            <a:endParaRPr lang="en-US" sz="2000" dirty="0"/>
+          </a:p>
+          <a:p>
+            <a:pPr marL="342900" indent="-342900">
+              <a:lnSpc>
+                <a:spcPct val="105000"/>
+              </a:lnSpc>
+              <a:spcAft>
+                <a:spcPts val="1200"/>
+              </a:spcAft>
+              <a:buSzPct val="100000"/>
+              <a:buChar char="•"/>
+            </a:pPr>
+            <a:r>
+              <a:rPr lang="en-US" sz="2000" dirty="0">
+                <a:solidFill>
+                  <a:srgbClr val="1F2933"/>
+                </a:solidFill>
+                <a:latin typeface="Calibri" pitchFamily="34" charset="0"/>
+                <a:ea typeface="Calibri" pitchFamily="34" charset="-122"/>
+                <a:cs typeface="Calibri" pitchFamily="34" charset="-120"/>
+              </a:rPr>
+              <a:t>CT-FIRE — Bredfeldt et al. 2014, Journal of Biomedical Optics 19(1):016007</a:t>
+            </a:r>
+            <a:endParaRPr lang="en-US" sz="2000" dirty="0"/>
+          </a:p>
+          <a:p>
+            <a:pPr marL="342900" indent="-342900">
+              <a:lnSpc>
+                <a:spcPct val="105000"/>
+              </a:lnSpc>
+              <a:spcAft>
+                <a:spcPts val="1200"/>
+              </a:spcAft>
+              <a:buSzPct val="100000"/>
+              <a:buChar char="•"/>
+            </a:pPr>
+            <a:r>
+              <a:rPr lang="en-US" sz="2000" dirty="0">
+                <a:solidFill>
+                  <a:srgbClr val="1F2933"/>
+                </a:solidFill>
+                <a:latin typeface="Calibri" pitchFamily="34" charset="0"/>
+                <a:ea typeface="Calibri" pitchFamily="34" charset="-122"/>
+                <a:cs typeface="Calibri" pitchFamily="34" charset="-120"/>
+              </a:rPr>
+              <a:t>CurveAlign — LOCI, University of Wisconsin–Madison</a:t>
+            </a:r>
+            <a:endParaRPr lang="en-US" sz="2000" dirty="0"/>
+          </a:p>
+          <a:p>
+            <a:pPr marL="342900" indent="-342900">
+              <a:lnSpc>
+                <a:spcPct val="105000"/>
+              </a:lnSpc>
+              <a:spcAft>
+                <a:spcPts val="1200"/>
+              </a:spcAft>
+              <a:buSzPct val="100000"/>
+              <a:buChar char="•"/>
+            </a:pPr>
+            <a:r>
+              <a:rPr lang="en-US" sz="2000" dirty="0">
+                <a:solidFill>
+                  <a:srgbClr val="1F2933"/>
+                </a:solidFill>
+                <a:latin typeface="Calibri" pitchFamily="34" charset="0"/>
+                <a:ea typeface="Calibri" pitchFamily="34" charset="-122"/>
+                <a:cs typeface="Calibri" pitchFamily="34" charset="-120"/>
+              </a:rPr>
+              <a:t>TACS — Conklin et al. 2011; Provenzano et al. 2008, BMC Medicine 6:11</a:t>
+            </a:r>
+            <a:endParaRPr lang="en-US" sz="2000" dirty="0"/>
+          </a:p>
+          <a:p>
+            <a:pPr marL="342900" indent="-342900">
+              <a:lnSpc>
+                <a:spcPct val="105000"/>
+              </a:lnSpc>
+              <a:spcAft>
+                <a:spcPts val="1200"/>
+              </a:spcAft>
+              <a:buSzPct val="100000"/>
+              <a:buChar char="•"/>
+            </a:pPr>
+            <a:r>
+              <a:rPr lang="en-US" sz="2000" dirty="0">
+                <a:solidFill>
+                  <a:srgbClr val="1F2933"/>
+                </a:solidFill>
+                <a:latin typeface="Calibri" pitchFamily="34" charset="0"/>
+                <a:ea typeface="Calibri" pitchFamily="34" charset="-122"/>
+                <a:cs typeface="Calibri" pitchFamily="34" charset="-120"/>
+              </a:rPr>
+              <a:t>TWOMBLI — Wershof et al. 2021, Life Science Alliance 4(3)</a:t>
+            </a:r>
+            <a:endParaRPr lang="en-US" sz="2000" dirty="0"/>
           </a:p>
         </p:txBody>
       </p:sp>
       <p:sp>
         <p:nvSpPr>
           <p:cNvPr id="5" name="Text 3"/>
-          <p:cNvSpPr/>
-          <p:nvPr/>
-        </p:nvSpPr>
-        <p:spPr>
-          <a:xfrm>
-            <a:off x="566928" y="2606040"/>
-            <a:ext cx="11055096" cy="868680"/>
-          </a:xfrm>
-          <a:prstGeom prst="rect">
-            <a:avLst/>
-          </a:prstGeom>
-          <a:noFill/>
-          <a:ln/>
-        </p:spPr>
-        <p:txBody>
-          <a:bodyPr wrap="square" rtlCol="0" anchor="ctr"/>
-          <a:lstStyle/>
-          <a:p>
-            <a:pPr indent="0" marL="0">
-              <a:buNone/>
-            </a:pPr>
-            <a:r>
-              <a:rPr lang="en-US" sz="4000" b="1" dirty="0">
-                <a:solidFill>
-                  <a:srgbClr val="1F4C86"/>
-                </a:solidFill>
-                <a:latin typeface="Trebuchet MS" pitchFamily="34" charset="0"/>
-                <a:ea typeface="Trebuchet MS" pitchFamily="34" charset="-122"/>
-                <a:cs typeface="Trebuchet MS" pitchFamily="34" charset="-120"/>
-              </a:rPr>
-              <a:t>Microscope control</a:t>
-            </a:r>
-            <a:endParaRPr lang="en-US" sz="4000" dirty="0"/>
-          </a:p>
-        </p:txBody>
-      </p:sp>
-      <p:sp>
-        <p:nvSpPr>
-          <p:cNvPr id="6" name="Text 4"/>
-          <p:cNvSpPr/>
-          <p:nvPr/>
-        </p:nvSpPr>
-        <p:spPr>
-          <a:xfrm>
-            <a:off x="566928" y="3456432"/>
-            <a:ext cx="10140696" cy="731520"/>
-          </a:xfrm>
-          <a:prstGeom prst="rect">
-            <a:avLst/>
-          </a:prstGeom>
-          <a:noFill/>
-          <a:ln/>
-        </p:spPr>
-        <p:txBody>
-          <a:bodyPr wrap="square" rtlCol="0" anchor="t"/>
-          <a:lstStyle/>
-          <a:p>
-            <a:pPr indent="0" marL="0">
-              <a:buNone/>
-            </a:pPr>
-            <a:r>
-              <a:rPr lang="en-US" sz="1900" dirty="0">
-                <a:solidFill>
-                  <a:srgbClr val="5A6675"/>
-                </a:solidFill>
-                <a:latin typeface="Calibri" pitchFamily="34" charset="0"/>
-                <a:ea typeface="Calibri" pitchFamily="34" charset="-122"/>
-                <a:cs typeface="Calibri" pitchFamily="34" charset="-120"/>
-              </a:rPr>
-              <a:t>The most complex thing here, and the reason for the rest</a:t>
-            </a:r>
-            <a:endParaRPr lang="en-US" sz="1900" dirty="0"/>
-          </a:p>
-        </p:txBody>
-      </p:sp>
-      <p:sp>
-        <p:nvSpPr>
-          <p:cNvPr id="7" name="Text 5"/>
-          <p:cNvSpPr/>
-          <p:nvPr/>
-        </p:nvSpPr>
-        <p:spPr>
-          <a:xfrm>
-            <a:off x="566928" y="6199632"/>
-            <a:ext cx="8229600" cy="365760"/>
-          </a:xfrm>
-          <a:prstGeom prst="rect">
-            <a:avLst/>
-          </a:prstGeom>
-          <a:noFill/>
-          <a:ln/>
-        </p:spPr>
-        <p:txBody>
-          <a:bodyPr wrap="square" rtlCol="0" anchor="ctr"/>
-          <a:lstStyle/>
-          <a:p>
-            <a:pPr indent="0" marL="0">
-              <a:buNone/>
-            </a:pPr>
-            <a:r>
-              <a:rPr lang="en-US" sz="1400" dirty="0">
-                <a:solidFill>
-                  <a:srgbClr val="A8B2BF"/>
-                </a:solidFill>
-                <a:latin typeface="Calibri" pitchFamily="34" charset="0"/>
-                <a:ea typeface="Calibri" pitchFamily="34" charset="-122"/>
-                <a:cs typeface="Calibri" pitchFamily="34" charset="-120"/>
-              </a:rPr>
-              <a:t>michaelsnelson.github.io/BINA-I2K-2026-QuPath-Extensions</a:t>
-            </a:r>
-            <a:endParaRPr lang="en-US" sz="1400" dirty="0"/>
-          </a:p>
-        </p:txBody>
-      </p:sp>
-      <p:sp>
-        <p:nvSpPr>
-          <p:cNvPr id="8" name="Text 6"/>
           <p:cNvSpPr/>
           <p:nvPr/>
         </p:nvSpPr>
@@ -17839,14 +18012,54 @@
       </p:grpSpPr>
       <p:sp>
         <p:nvSpPr>
-          <p:cNvPr id="2" name="Text 0"/>
-          <p:cNvSpPr/>
-          <p:nvPr/>
-        </p:nvSpPr>
-        <p:spPr>
-          <a:xfrm>
-            <a:off x="566928" y="384048"/>
-            <a:ext cx="11055096" cy="658368"/>
+          <p:cNvPr id="2" name="Shape 0"/>
+          <p:cNvSpPr/>
+          <p:nvPr/>
+        </p:nvSpPr>
+        <p:spPr>
+          <a:xfrm>
+            <a:off x="0" y="1417320"/>
+            <a:ext cx="12188952" cy="3108960"/>
+          </a:xfrm>
+          <a:prstGeom prst="rect">
+            <a:avLst/>
+          </a:prstGeom>
+          <a:solidFill>
+            <a:srgbClr val="E8F0FA"/>
+          </a:solidFill>
+          <a:ln/>
+        </p:spPr>
+      </p:sp>
+      <p:sp>
+        <p:nvSpPr>
+          <p:cNvPr id="3" name="Shape 1"/>
+          <p:cNvSpPr/>
+          <p:nvPr/>
+        </p:nvSpPr>
+        <p:spPr>
+          <a:xfrm>
+            <a:off x="0" y="1417320"/>
+            <a:ext cx="201168" cy="3108960"/>
+          </a:xfrm>
+          <a:prstGeom prst="rect">
+            <a:avLst/>
+          </a:prstGeom>
+          <a:solidFill>
+            <a:srgbClr val="3674C1"/>
+          </a:solidFill>
+          <a:ln/>
+        </p:spPr>
+      </p:sp>
+      <p:sp>
+        <p:nvSpPr>
+          <p:cNvPr id="4" name="Text 2"/>
+          <p:cNvSpPr/>
+          <p:nvPr/>
+        </p:nvSpPr>
+        <p:spPr>
+          <a:xfrm>
+            <a:off x="566928" y="1691640"/>
+            <a:ext cx="1828800" cy="914400"/>
           </a:xfrm>
           <a:prstGeom prst="rect">
             <a:avLst/>
@@ -17862,50 +18075,69 @@
               <a:buNone/>
             </a:pPr>
             <a:r>
-              <a:rPr lang="en-US" sz="3000" b="1" dirty="0">
-                <a:solidFill>
-                  <a:srgbClr val="1F4C86"/>
+              <a:rPr lang="en-US" sz="5400" b="1" dirty="0">
+                <a:solidFill>
+                  <a:srgbClr val="3674C1"/>
                 </a:solidFill>
                 <a:latin typeface="Trebuchet MS" pitchFamily="34" charset="0"/>
                 <a:ea typeface="Trebuchet MS" pitchFamily="34" charset="-122"/>
                 <a:cs typeface="Trebuchet MS" pitchFamily="34" charset="-120"/>
               </a:rPr>
-              <a:t>QPSC — QuPath Scope Control</a:t>
-            </a:r>
-            <a:endParaRPr lang="en-US" sz="3000" dirty="0"/>
-          </a:p>
-        </p:txBody>
-      </p:sp>
-      <p:sp>
-        <p:nvSpPr>
-          <p:cNvPr id="3" name="Shape 1"/>
-          <p:cNvSpPr/>
-          <p:nvPr/>
-        </p:nvSpPr>
-        <p:spPr>
-          <a:xfrm>
-            <a:off x="566928" y="1097280"/>
-            <a:ext cx="1920240" cy="50292"/>
-          </a:xfrm>
-          <a:prstGeom prst="rect">
-            <a:avLst/>
-          </a:prstGeom>
-          <a:solidFill>
-            <a:srgbClr val="3674C1"/>
-          </a:solidFill>
-          <a:ln/>
-        </p:spPr>
-      </p:sp>
-      <p:sp>
-        <p:nvSpPr>
-          <p:cNvPr id="4" name="Text 2"/>
-          <p:cNvSpPr/>
-          <p:nvPr/>
-        </p:nvSpPr>
-        <p:spPr>
-          <a:xfrm>
-            <a:off x="640080" y="1481328"/>
-            <a:ext cx="10963656" cy="4553712"/>
+              <a:t>08</a:t>
+            </a:r>
+            <a:endParaRPr lang="en-US" sz="5400" dirty="0"/>
+          </a:p>
+        </p:txBody>
+      </p:sp>
+      <p:sp>
+        <p:nvSpPr>
+          <p:cNvPr id="5" name="Text 3"/>
+          <p:cNvSpPr/>
+          <p:nvPr/>
+        </p:nvSpPr>
+        <p:spPr>
+          <a:xfrm>
+            <a:off x="566928" y="2606040"/>
+            <a:ext cx="11055096" cy="868680"/>
+          </a:xfrm>
+          <a:prstGeom prst="rect">
+            <a:avLst/>
+          </a:prstGeom>
+          <a:noFill/>
+          <a:ln/>
+        </p:spPr>
+        <p:txBody>
+          <a:bodyPr wrap="square" rtlCol="0" anchor="ctr"/>
+          <a:lstStyle/>
+          <a:p>
+            <a:pPr indent="0" marL="0">
+              <a:buNone/>
+            </a:pPr>
+            <a:r>
+              <a:rPr lang="en-US" sz="4000" b="1" dirty="0">
+                <a:solidFill>
+                  <a:srgbClr val="1F4C86"/>
+                </a:solidFill>
+                <a:latin typeface="Trebuchet MS" pitchFamily="34" charset="0"/>
+                <a:ea typeface="Trebuchet MS" pitchFamily="34" charset="-122"/>
+                <a:cs typeface="Trebuchet MS" pitchFamily="34" charset="-120"/>
+              </a:rPr>
+              <a:t>Microscope control</a:t>
+            </a:r>
+            <a:endParaRPr lang="en-US" sz="4000" dirty="0"/>
+          </a:p>
+        </p:txBody>
+      </p:sp>
+      <p:sp>
+        <p:nvSpPr>
+          <p:cNvPr id="6" name="Text 4"/>
+          <p:cNvSpPr/>
+          <p:nvPr/>
+        </p:nvSpPr>
+        <p:spPr>
+          <a:xfrm>
+            <a:off x="566928" y="3456432"/>
+            <a:ext cx="10140696" cy="731520"/>
           </a:xfrm>
           <a:prstGeom prst="rect">
             <a:avLst/>
@@ -17917,106 +18149,66 @@
           <a:bodyPr wrap="square" rtlCol="0" anchor="t"/>
           <a:lstStyle/>
           <a:p>
-            <a:pPr marL="342900" indent="-342900">
-              <a:lnSpc>
-                <a:spcPct val="105000"/>
-              </a:lnSpc>
-              <a:spcAft>
-                <a:spcPts val="1200"/>
-              </a:spcAft>
-              <a:buSzPct val="100000"/>
-              <a:buChar char="•"/>
-            </a:pPr>
-            <a:r>
-              <a:rPr lang="en-US" sz="2000" dirty="0">
-                <a:solidFill>
-                  <a:srgbClr val="1F2933"/>
-                </a:solidFill>
-                <a:latin typeface="Calibri" pitchFamily="34" charset="0"/>
-                <a:ea typeface="Calibri" pitchFamily="34" charset="-122"/>
-                <a:cs typeface="Calibri" pitchFamily="34" charset="-120"/>
-              </a:rPr>
-              <a:t>Draw a box around a region in QuPath. The stage moves, the tiles are captured and stitched, and the image appears back in your project</a:t>
-            </a:r>
-            <a:endParaRPr lang="en-US" sz="2000" dirty="0"/>
-          </a:p>
-          <a:p>
-            <a:pPr marL="342900" indent="-342900">
-              <a:lnSpc>
-                <a:spcPct val="105000"/>
-              </a:lnSpc>
-              <a:spcAft>
-                <a:spcPts val="1200"/>
-              </a:spcAft>
-              <a:buSzPct val="100000"/>
-              <a:buChar char="•"/>
-            </a:pPr>
-            <a:r>
-              <a:rPr lang="en-US" sz="2000" dirty="0">
-                <a:solidFill>
-                  <a:srgbClr val="1F2933"/>
-                </a:solidFill>
-                <a:latin typeface="Calibri" pitchFamily="34" charset="0"/>
-                <a:ea typeface="Calibri" pitchFamily="34" charset="-122"/>
-                <a:cs typeface="Calibri" pitchFamily="34" charset="-120"/>
-              </a:rPr>
-              <a:t>Target specific annotations on a slide you already scanned</a:t>
-            </a:r>
-            <a:endParaRPr lang="en-US" sz="2000" dirty="0"/>
-          </a:p>
-          <a:p>
-            <a:pPr marL="342900" indent="-342900">
-              <a:lnSpc>
-                <a:spcPct val="105000"/>
-              </a:lnSpc>
-              <a:spcAft>
-                <a:spcPts val="1200"/>
-              </a:spcAft>
-              <a:buSzPct val="100000"/>
-              <a:buChar char="•"/>
-            </a:pPr>
-            <a:r>
-              <a:rPr lang="en-US" sz="2000" dirty="0">
-                <a:solidFill>
-                  <a:srgbClr val="1F2933"/>
-                </a:solidFill>
-                <a:latin typeface="Calibri" pitchFamily="34" charset="0"/>
-                <a:ea typeface="Calibri" pitchFamily="34" charset="-122"/>
-                <a:cs typeface="Calibri" pitchFamily="34" charset="-120"/>
-              </a:rPr>
-              <a:t>Live camera view, stage map, saved positions, and a virtual joystick</a:t>
-            </a:r>
-            <a:endParaRPr lang="en-US" sz="2000" dirty="0"/>
-          </a:p>
-          <a:p>
-            <a:pPr marL="342900" indent="-342900">
-              <a:lnSpc>
-                <a:spcPct val="105000"/>
-              </a:lnSpc>
-              <a:spcAft>
-                <a:spcPts val="1200"/>
-              </a:spcAft>
-              <a:buSzPct val="100000"/>
-              <a:buChar char="•"/>
-            </a:pPr>
-            <a:r>
-              <a:rPr lang="en-US" sz="2000" dirty="0">
-                <a:solidFill>
-                  <a:srgbClr val="1F2933"/>
-                </a:solidFill>
-                <a:latin typeface="Calibri" pitchFamily="34" charset="0"/>
-                <a:ea typeface="Calibri" pitchFamily="34" charset="-122"/>
-                <a:cs typeface="Calibri" pitchFamily="34" charset="-120"/>
-              </a:rPr>
-              <a:t>Brightfield, multi-channel fluorescence, and combined passes on a single-camera scope</a:t>
-            </a:r>
-            <a:endParaRPr lang="en-US" sz="2000" dirty="0"/>
-          </a:p>
-        </p:txBody>
-      </p:sp>
-      <p:sp>
-        <p:nvSpPr>
-          <p:cNvPr id="5" name="Text 3"/>
+            <a:pPr indent="0" marL="0">
+              <a:buNone/>
+            </a:pPr>
+            <a:r>
+              <a:rPr lang="en-US" sz="1900" dirty="0">
+                <a:solidFill>
+                  <a:srgbClr val="5A6675"/>
+                </a:solidFill>
+                <a:latin typeface="Calibri" pitchFamily="34" charset="0"/>
+                <a:ea typeface="Calibri" pitchFamily="34" charset="-122"/>
+                <a:cs typeface="Calibri" pitchFamily="34" charset="-120"/>
+              </a:rPr>
+              <a:t>The most complex thing here, and the reason for the rest</a:t>
+            </a:r>
+            <a:endParaRPr lang="en-US" sz="1900" dirty="0"/>
+          </a:p>
+        </p:txBody>
+      </p:sp>
+      <p:sp>
+        <p:nvSpPr>
+          <p:cNvPr id="7" name="Text 5"/>
+          <p:cNvSpPr/>
+          <p:nvPr/>
+        </p:nvSpPr>
+        <p:spPr>
+          <a:xfrm>
+            <a:off x="566928" y="6199632"/>
+            <a:ext cx="8229600" cy="365760"/>
+          </a:xfrm>
+          <a:prstGeom prst="rect">
+            <a:avLst/>
+          </a:prstGeom>
+          <a:noFill/>
+          <a:ln/>
+        </p:spPr>
+        <p:txBody>
+          <a:bodyPr wrap="square" rtlCol="0" anchor="ctr"/>
+          <a:lstStyle/>
+          <a:p>
+            <a:pPr indent="0" marL="0">
+              <a:buNone/>
+            </a:pPr>
+            <a:r>
+              <a:rPr lang="en-US" sz="1400" dirty="0">
+                <a:solidFill>
+                  <a:srgbClr val="A8B2BF"/>
+                </a:solidFill>
+                <a:latin typeface="Calibri" pitchFamily="34" charset="0"/>
+                <a:ea typeface="Calibri" pitchFamily="34" charset="-122"/>
+                <a:cs typeface="Calibri" pitchFamily="34" charset="-120"/>
+              </a:rPr>
+              <a:t>michaelsnelson.github.io/BINA-I2K-2026-QuPath-Extensions</a:t>
+            </a:r>
+            <a:endParaRPr lang="en-US" sz="1400" dirty="0"/>
+          </a:p>
+        </p:txBody>
+      </p:sp>
+      <p:sp>
+        <p:nvSpPr>
+          <p:cNvPr id="8" name="Text 6"/>
           <p:cNvSpPr/>
           <p:nvPr/>
         </p:nvSpPr>
@@ -18118,7 +18310,7 @@
                 <a:ea typeface="Trebuchet MS" pitchFamily="34" charset="-122"/>
                 <a:cs typeface="Trebuchet MS" pitchFamily="34" charset="-120"/>
               </a:rPr>
-              <a:t>Why this changes the rest</a:t>
+              <a:t>QPSC — QuPath Scope Control</a:t>
             </a:r>
             <a:endParaRPr lang="en-US" sz="3000" dirty="0"/>
           </a:p>
@@ -18184,7 +18376,7 @@
                 <a:ea typeface="Calibri" pitchFamily="34" charset="-122"/>
                 <a:cs typeface="Calibri" pitchFamily="34" charset="-120"/>
               </a:rPr>
-              <a:t>The region you analysed is the region you acquire at high resolution</a:t>
+              <a:t>Draw a box around a region in QuPath. The stage moves, the tiles are captured and stitched, and the image appears back in your project</a:t>
             </a:r>
             <a:endParaRPr lang="en-US" sz="2000" dirty="0"/>
           </a:p>
@@ -18208,7 +18400,7 @@
                 <a:ea typeface="Calibri" pitchFamily="34" charset="-122"/>
                 <a:cs typeface="Calibri" pitchFamily="34" charset="-120"/>
               </a:rPr>
-              <a:t>Acquisition metadata arrives in the project, not in a folder that gets separated from the images</a:t>
+              <a:t>Target specific annotations on a slide you already scanned</a:t>
             </a:r>
             <a:endParaRPr lang="en-US" sz="2000" dirty="0"/>
           </a:p>
@@ -18232,79 +18424,39 @@
                 <a:ea typeface="Calibri" pitchFamily="34" charset="-122"/>
                 <a:cs typeface="Calibri" pitchFamily="34" charset="-120"/>
               </a:rPr>
-              <a:t>Stitching is a step in this pipeline — and it works perfectly well on its own, which is why it is in your hands-on hour</a:t>
+              <a:t>Live camera view, stage map, saved positions, and a virtual joystick</a:t>
             </a:r>
             <a:endParaRPr lang="en-US" sz="2000" dirty="0"/>
           </a:p>
-        </p:txBody>
-      </p:sp>
-      <p:sp>
-        <p:nvSpPr>
-          <p:cNvPr id="5" name="Shape 3"/>
-          <p:cNvSpPr/>
-          <p:nvPr/>
-        </p:nvSpPr>
-        <p:spPr>
-          <a:xfrm>
-            <a:off x="566928" y="5650992"/>
-            <a:ext cx="11055096" cy="566928"/>
-          </a:xfrm>
-          <a:prstGeom prst="rect">
-            <a:avLst/>
-          </a:prstGeom>
-          <a:solidFill>
-            <a:srgbClr val="F4F8FD"/>
-          </a:solidFill>
-          <a:ln w="9525">
-            <a:solidFill>
-              <a:srgbClr val="3674C1"/>
-            </a:solidFill>
-            <a:prstDash val="solid"/>
-          </a:ln>
-        </p:spPr>
-      </p:sp>
-      <p:sp>
-        <p:nvSpPr>
-          <p:cNvPr id="6" name="Text 4"/>
-          <p:cNvSpPr/>
-          <p:nvPr/>
-        </p:nvSpPr>
-        <p:spPr>
-          <a:xfrm>
-            <a:off x="768096" y="5650992"/>
-            <a:ext cx="10652760" cy="566928"/>
-          </a:xfrm>
-          <a:prstGeom prst="rect">
-            <a:avLst/>
-          </a:prstGeom>
-          <a:noFill/>
-          <a:ln/>
-        </p:spPr>
-        <p:txBody>
-          <a:bodyPr wrap="square" rtlCol="0" anchor="ctr"/>
-          <a:lstStyle/>
-          <a:p>
-            <a:pPr indent="0" marL="0">
-              <a:buNone/>
-            </a:pPr>
-            <a:r>
-              <a:rPr lang="en-US" sz="1600" b="1" dirty="0">
-                <a:solidFill>
-                  <a:srgbClr val="1F4C86"/>
-                </a:solidFill>
-                <a:latin typeface="Calibri" pitchFamily="34" charset="0"/>
-                <a:ea typeface="Calibri" pitchFamily="34" charset="-122"/>
-                <a:cs typeface="Calibri" pitchFamily="34" charset="-120"/>
-              </a:rPr>
-              <a:t>Once acquisition is driven from QuPath, "acquisition software" and "analysis software" stop being separate places your data lives.</a:t>
-            </a:r>
-            <a:endParaRPr lang="en-US" sz="1600" dirty="0"/>
-          </a:p>
-        </p:txBody>
-      </p:sp>
-      <p:sp>
-        <p:nvSpPr>
-          <p:cNvPr id="7" name="Text 5"/>
+          <a:p>
+            <a:pPr marL="342900" indent="-342900">
+              <a:lnSpc>
+                <a:spcPct val="105000"/>
+              </a:lnSpc>
+              <a:spcAft>
+                <a:spcPts val="1200"/>
+              </a:spcAft>
+              <a:buSzPct val="100000"/>
+              <a:buChar char="•"/>
+            </a:pPr>
+            <a:r>
+              <a:rPr lang="en-US" sz="2000" dirty="0">
+                <a:solidFill>
+                  <a:srgbClr val="1F2933"/>
+                </a:solidFill>
+                <a:latin typeface="Calibri" pitchFamily="34" charset="0"/>
+                <a:ea typeface="Calibri" pitchFamily="34" charset="-122"/>
+                <a:cs typeface="Calibri" pitchFamily="34" charset="-120"/>
+              </a:rPr>
+              <a:t>Brightfield, multi-channel fluorescence, and combined passes on a single-camera scope</a:t>
+            </a:r>
+            <a:endParaRPr lang="en-US" sz="2000" dirty="0"/>
+          </a:p>
+        </p:txBody>
+      </p:sp>
+      <p:sp>
+        <p:nvSpPr>
+          <p:cNvPr id="5" name="Text 3"/>
           <p:cNvSpPr/>
           <p:nvPr/>
         </p:nvSpPr>
@@ -18406,7 +18558,7 @@
                 <a:ea typeface="Trebuchet MS" pitchFamily="34" charset="-122"/>
                 <a:cs typeface="Trebuchet MS" pitchFamily="34" charset="-120"/>
               </a:rPr>
-              <a:t>How it is put together</a:t>
+              <a:t>Why this changes the rest</a:t>
             </a:r>
             <a:endParaRPr lang="en-US" sz="3000" dirty="0"/>
           </a:p>
@@ -18440,47 +18592,8 @@
         </p:nvSpPr>
         <p:spPr>
           <a:xfrm>
-            <a:off x="566928" y="1243584"/>
-            <a:ext cx="11055096" cy="384048"/>
-          </a:xfrm>
-          <a:prstGeom prst="rect">
-            <a:avLst/>
-          </a:prstGeom>
-          <a:noFill/>
-          <a:ln/>
-        </p:spPr>
-        <p:txBody>
-          <a:bodyPr wrap="square" rtlCol="0" anchor="ctr"/>
-          <a:lstStyle/>
-          <a:p>
-            <a:pPr indent="0" marL="0">
-              <a:buNone/>
-            </a:pPr>
-            <a:r>
-              <a:rPr lang="en-US" sz="1700" i="1" dirty="0">
-                <a:solidFill>
-                  <a:srgbClr val="5A6675"/>
-                </a:solidFill>
-                <a:latin typeface="Calibri" pitchFamily="34" charset="0"/>
-                <a:ea typeface="Calibri" pitchFamily="34" charset="-122"/>
-                <a:cs typeface="Calibri" pitchFamily="34" charset="-120"/>
-              </a:rPr>
-              <a:t>The easy part is the QuPath extension. Budget your time for the microscope side.</a:t>
-            </a:r>
-            <a:endParaRPr lang="en-US" sz="1700" dirty="0"/>
-          </a:p>
-        </p:txBody>
-      </p:sp>
-      <p:sp>
-        <p:nvSpPr>
-          <p:cNvPr id="5" name="Text 3"/>
-          <p:cNvSpPr/>
-          <p:nvPr/>
-        </p:nvSpPr>
-        <p:spPr>
-          <a:xfrm>
-            <a:off x="640080" y="1755648"/>
-            <a:ext cx="10963656" cy="4279392"/>
+            <a:off x="640080" y="1481328"/>
+            <a:ext cx="10963656" cy="4553712"/>
           </a:xfrm>
           <a:prstGeom prst="rect">
             <a:avLst/>
@@ -18511,7 +18624,7 @@
                 <a:ea typeface="Calibri" pitchFamily="34" charset="-122"/>
                 <a:cs typeface="Calibri" pitchFamily="34" charset="-120"/>
               </a:rPr>
-              <a:t>QuPath talks to a small command server, which drives Micro-Manager, which drives the hardware</a:t>
+              <a:t>The region you analysed is the region you acquire at high resolution</a:t>
             </a:r>
             <a:endParaRPr lang="en-US" sz="2000" dirty="0"/>
           </a:p>
@@ -18535,7 +18648,7 @@
                 <a:ea typeface="Calibri" pitchFamily="34" charset="-122"/>
                 <a:cs typeface="Calibri" pitchFamily="34" charset="-120"/>
               </a:rPr>
-              <a:t>Each instrument is described by its own configuration — the QuPath side does not know what kind of microscope it is</a:t>
+              <a:t>Acquisition metadata arrives in the project, not in a folder that gets separated from the images</a:t>
             </a:r>
             <a:endParaRPr lang="en-US" sz="2000" dirty="0"/>
           </a:p>
@@ -18559,7 +18672,7 @@
                 <a:ea typeface="Calibri" pitchFamily="34" charset="-122"/>
                 <a:cs typeface="Calibri" pitchFamily="34" charset="-120"/>
               </a:rPr>
-              <a:t>Micro-Manager remains the device layer. We did not reinvent it</a:t>
+              <a:t>Stitching is a step in this pipeline — and it works perfectly well on its own, which is why it is in your hands-on hour</a:t>
             </a:r>
             <a:endParaRPr lang="en-US" sz="2000" dirty="0"/>
           </a:p>
@@ -18567,7 +18680,71 @@
       </p:sp>
       <p:sp>
         <p:nvSpPr>
+          <p:cNvPr id="5" name="Shape 3"/>
+          <p:cNvSpPr/>
+          <p:nvPr/>
+        </p:nvSpPr>
+        <p:spPr>
+          <a:xfrm>
+            <a:off x="566928" y="5650992"/>
+            <a:ext cx="11055096" cy="566928"/>
+          </a:xfrm>
+          <a:prstGeom prst="rect">
+            <a:avLst/>
+          </a:prstGeom>
+          <a:solidFill>
+            <a:srgbClr val="F4F8FD"/>
+          </a:solidFill>
+          <a:ln w="9525">
+            <a:solidFill>
+              <a:srgbClr val="3674C1"/>
+            </a:solidFill>
+            <a:prstDash val="solid"/>
+          </a:ln>
+        </p:spPr>
+      </p:sp>
+      <p:sp>
+        <p:nvSpPr>
           <p:cNvPr id="6" name="Text 4"/>
+          <p:cNvSpPr/>
+          <p:nvPr/>
+        </p:nvSpPr>
+        <p:spPr>
+          <a:xfrm>
+            <a:off x="768096" y="5650992"/>
+            <a:ext cx="10652760" cy="566928"/>
+          </a:xfrm>
+          <a:prstGeom prst="rect">
+            <a:avLst/>
+          </a:prstGeom>
+          <a:noFill/>
+          <a:ln/>
+        </p:spPr>
+        <p:txBody>
+          <a:bodyPr wrap="square" rtlCol="0" anchor="ctr"/>
+          <a:lstStyle/>
+          <a:p>
+            <a:pPr indent="0" marL="0">
+              <a:buNone/>
+            </a:pPr>
+            <a:r>
+              <a:rPr lang="en-US" sz="1600" b="1" dirty="0">
+                <a:solidFill>
+                  <a:srgbClr val="1F4C86"/>
+                </a:solidFill>
+                <a:latin typeface="Calibri" pitchFamily="34" charset="0"/>
+                <a:ea typeface="Calibri" pitchFamily="34" charset="-122"/>
+                <a:cs typeface="Calibri" pitchFamily="34" charset="-120"/>
+              </a:rPr>
+              <a:t>Once acquisition is driven from QuPath, "acquisition software" and "analysis software" stop being separate places your data lives.</a:t>
+            </a:r>
+            <a:endParaRPr lang="en-US" sz="1600" dirty="0"/>
+          </a:p>
+        </p:txBody>
+      </p:sp>
+      <p:sp>
+        <p:nvSpPr>
+          <p:cNvPr id="7" name="Text 5"/>
           <p:cNvSpPr/>
           <p:nvPr/>
         </p:nvSpPr>
@@ -18638,41 +18815,14 @@
       </p:grpSpPr>
       <p:sp>
         <p:nvSpPr>
-          <p:cNvPr id="2" name="Shape 0"/>
-          <p:cNvSpPr/>
-          <p:nvPr/>
-        </p:nvSpPr>
-        <p:spPr>
-          <a:xfrm>
-            <a:off x="566928" y="411480"/>
-            <a:ext cx="2331720" cy="457200"/>
-          </a:xfrm>
-          <a:prstGeom prst="roundRect">
-            <a:avLst>
-              <a:gd name="adj" fmla="val 20000"/>
-            </a:avLst>
-          </a:prstGeom>
-          <a:solidFill>
-            <a:srgbClr val="FBF1E0"/>
-          </a:solidFill>
-          <a:ln w="12700">
-            <a:solidFill>
-              <a:srgbClr val="B26A00"/>
-            </a:solidFill>
-            <a:prstDash val="solid"/>
-          </a:ln>
-        </p:spPr>
-      </p:sp>
-      <p:sp>
-        <p:nvSpPr>
-          <p:cNvPr id="3" name="Text 1"/>
-          <p:cNvSpPr/>
-          <p:nvPr/>
-        </p:nvSpPr>
-        <p:spPr>
-          <a:xfrm>
-            <a:off x="566928" y="411480"/>
-            <a:ext cx="2331720" cy="457200"/>
+          <p:cNvPr id="2" name="Text 0"/>
+          <p:cNvSpPr/>
+          <p:nvPr/>
+        </p:nvSpPr>
+        <p:spPr>
+          <a:xfrm>
+            <a:off x="566928" y="384048"/>
+            <a:ext cx="11055096" cy="658368"/>
           </a:xfrm>
           <a:prstGeom prst="rect">
             <a:avLst/>
@@ -18684,72 +18834,33 @@
           <a:bodyPr wrap="square" rtlCol="0" anchor="ctr"/>
           <a:lstStyle/>
           <a:p>
-            <a:pPr algn="ctr" indent="0" marL="0">
+            <a:pPr indent="0" marL="0">
               <a:buNone/>
             </a:pPr>
             <a:r>
-              <a:rPr lang="en-US" sz="1600" b="1" dirty="0">
-                <a:solidFill>
-                  <a:srgbClr val="B26A00"/>
+              <a:rPr lang="en-US" sz="3000" b="1" dirty="0">
+                <a:solidFill>
+                  <a:srgbClr val="1F4C86"/>
                 </a:solidFill>
                 <a:latin typeface="Trebuchet MS" pitchFamily="34" charset="0"/>
                 <a:ea typeface="Trebuchet MS" pitchFamily="34" charset="-122"/>
                 <a:cs typeface="Trebuchet MS" pitchFamily="34" charset="-120"/>
               </a:rPr>
-              <a:t>▶  SHOWN  ·  NOT YOURS TO RUN</a:t>
-            </a:r>
-            <a:endParaRPr lang="en-US" sz="1600" dirty="0"/>
-          </a:p>
-        </p:txBody>
-      </p:sp>
-      <p:sp>
-        <p:nvSpPr>
-          <p:cNvPr id="4" name="Text 2"/>
-          <p:cNvSpPr/>
-          <p:nvPr/>
-        </p:nvSpPr>
-        <p:spPr>
-          <a:xfrm>
-            <a:off x="566928" y="1024128"/>
-            <a:ext cx="11055096" cy="685800"/>
-          </a:xfrm>
-          <a:prstGeom prst="rect">
-            <a:avLst/>
-          </a:prstGeom>
-          <a:noFill/>
-          <a:ln/>
-        </p:spPr>
-        <p:txBody>
-          <a:bodyPr wrap="square" rtlCol="0" anchor="ctr"/>
-          <a:lstStyle/>
-          <a:p>
-            <a:pPr indent="0" marL="0">
-              <a:buNone/>
-            </a:pPr>
-            <a:r>
-              <a:rPr lang="en-US" sz="3200" b="1" dirty="0">
-                <a:solidFill>
-                  <a:srgbClr val="1F4C86"/>
-                </a:solidFill>
-                <a:latin typeface="Trebuchet MS" pitchFamily="34" charset="0"/>
-                <a:ea typeface="Trebuchet MS" pitchFamily="34" charset="-122"/>
-                <a:cs typeface="Trebuchet MS" pitchFamily="34" charset="-120"/>
-              </a:rPr>
-              <a:t>Acquisition, live</a:t>
-            </a:r>
-            <a:endParaRPr lang="en-US" sz="3200" dirty="0"/>
-          </a:p>
-        </p:txBody>
-      </p:sp>
-      <p:sp>
-        <p:nvSpPr>
-          <p:cNvPr id="5" name="Shape 3"/>
-          <p:cNvSpPr/>
-          <p:nvPr/>
-        </p:nvSpPr>
-        <p:spPr>
-          <a:xfrm>
-            <a:off x="566928" y="1783080"/>
+              <a:t>How it is put together</a:t>
+            </a:r>
+            <a:endParaRPr lang="en-US" sz="3000" dirty="0"/>
+          </a:p>
+        </p:txBody>
+      </p:sp>
+      <p:sp>
+        <p:nvSpPr>
+          <p:cNvPr id="3" name="Shape 1"/>
+          <p:cNvSpPr/>
+          <p:nvPr/>
+        </p:nvSpPr>
+        <p:spPr>
+          <a:xfrm>
+            <a:off x="566928" y="1097280"/>
             <a:ext cx="1920240" cy="50292"/>
           </a:xfrm>
           <a:prstGeom prst="rect">
@@ -18763,14 +18874,53 @@
       </p:sp>
       <p:sp>
         <p:nvSpPr>
-          <p:cNvPr id="6" name="Text 4"/>
-          <p:cNvSpPr/>
-          <p:nvPr/>
-        </p:nvSpPr>
-        <p:spPr>
-          <a:xfrm>
-            <a:off x="640080" y="2103120"/>
-            <a:ext cx="10963656" cy="3017520"/>
+          <p:cNvPr id="4" name="Text 2"/>
+          <p:cNvSpPr/>
+          <p:nvPr/>
+        </p:nvSpPr>
+        <p:spPr>
+          <a:xfrm>
+            <a:off x="566928" y="1243584"/>
+            <a:ext cx="11055096" cy="384048"/>
+          </a:xfrm>
+          <a:prstGeom prst="rect">
+            <a:avLst/>
+          </a:prstGeom>
+          <a:noFill/>
+          <a:ln/>
+        </p:spPr>
+        <p:txBody>
+          <a:bodyPr wrap="square" rtlCol="0" anchor="ctr"/>
+          <a:lstStyle/>
+          <a:p>
+            <a:pPr indent="0" marL="0">
+              <a:buNone/>
+            </a:pPr>
+            <a:r>
+              <a:rPr lang="en-US" sz="1700" i="1" dirty="0">
+                <a:solidFill>
+                  <a:srgbClr val="5A6675"/>
+                </a:solidFill>
+                <a:latin typeface="Calibri" pitchFamily="34" charset="0"/>
+                <a:ea typeface="Calibri" pitchFamily="34" charset="-122"/>
+                <a:cs typeface="Calibri" pitchFamily="34" charset="-120"/>
+              </a:rPr>
+              <a:t>The easy part is the QuPath extension. Budget your time for the microscope side.</a:t>
+            </a:r>
+            <a:endParaRPr lang="en-US" sz="1700" dirty="0"/>
+          </a:p>
+        </p:txBody>
+      </p:sp>
+      <p:sp>
+        <p:nvSpPr>
+          <p:cNvPr id="5" name="Text 3"/>
+          <p:cNvSpPr/>
+          <p:nvPr/>
+        </p:nvSpPr>
+        <p:spPr>
+          <a:xfrm>
+            <a:off x="640080" y="1755648"/>
+            <a:ext cx="10963656" cy="4279392"/>
           </a:xfrm>
           <a:prstGeom prst="rect">
             <a:avLst/>
@@ -18783,8 +18933,11 @@
           <a:lstStyle/>
           <a:p>
             <a:pPr marL="342900" indent="-342900">
+              <a:lnSpc>
+                <a:spcPct val="105000"/>
+              </a:lnSpc>
               <a:spcAft>
-                <a:spcPts val="1400"/>
+                <a:spcPts val="1200"/>
               </a:spcAft>
               <a:buSzPct val="100000"/>
               <a:buChar char="•"/>
@@ -18798,14 +18951,17 @@
                 <a:ea typeface="Calibri" pitchFamily="34" charset="-122"/>
                 <a:cs typeface="Calibri" pitchFamily="34" charset="-120"/>
               </a:rPr>
-              <a:t>Draw a bounding box on a slide overview</a:t>
+              <a:t>QuPath talks to a small command server, which drives Micro-Manager, which drives the hardware</a:t>
             </a:r>
             <a:endParaRPr lang="en-US" sz="2000" dirty="0"/>
           </a:p>
           <a:p>
             <a:pPr marL="342900" indent="-342900">
+              <a:lnSpc>
+                <a:spcPct val="105000"/>
+              </a:lnSpc>
               <a:spcAft>
-                <a:spcPts val="1400"/>
+                <a:spcPts val="1200"/>
               </a:spcAft>
               <a:buSzPct val="100000"/>
               <a:buChar char="•"/>
@@ -18819,14 +18975,17 @@
                 <a:ea typeface="Calibri" pitchFamily="34" charset="-122"/>
                 <a:cs typeface="Calibri" pitchFamily="34" charset="-120"/>
               </a:rPr>
-              <a:t>Watch the stage move and the tiles come in</a:t>
+              <a:t>Each instrument is described by its own configuration — the QuPath side does not know what kind of microscope it is</a:t>
             </a:r>
             <a:endParaRPr lang="en-US" sz="2000" dirty="0"/>
           </a:p>
           <a:p>
             <a:pPr marL="342900" indent="-342900">
+              <a:lnSpc>
+                <a:spcPct val="105000"/>
+              </a:lnSpc>
               <a:spcAft>
-                <a:spcPts val="1400"/>
+                <a:spcPts val="1200"/>
               </a:spcAft>
               <a:buSzPct val="100000"/>
               <a:buChar char="•"/>
@@ -18840,121 +18999,15 @@
                 <a:ea typeface="Calibri" pitchFamily="34" charset="-122"/>
                 <a:cs typeface="Calibri" pitchFamily="34" charset="-120"/>
               </a:rPr>
-              <a:t>Stitched pyramidal image lands back in the project, with its metadata</a:t>
+              <a:t>Micro-Manager remains the device layer. We did not reinvent it</a:t>
             </a:r>
             <a:endParaRPr lang="en-US" sz="2000" dirty="0"/>
           </a:p>
-          <a:p>
-            <a:pPr marL="342900" indent="-342900">
-              <a:spcAft>
-                <a:spcPts val="1400"/>
-              </a:spcAft>
-              <a:buSzPct val="100000"/>
-              <a:buChar char="•"/>
-            </a:pPr>
-            <a:r>
-              <a:rPr lang="en-US" sz="2000" dirty="0">
-                <a:solidFill>
-                  <a:srgbClr val="1F2933"/>
-                </a:solidFill>
-                <a:latin typeface="Calibri" pitchFamily="34" charset="0"/>
-                <a:ea typeface="Calibri" pitchFamily="34" charset="-122"/>
-                <a:cs typeface="Calibri" pitchFamily="34" charset="-120"/>
-              </a:rPr>
-              <a:t>Then open it and annotate it — the loop closes</a:t>
-            </a:r>
-            <a:endParaRPr lang="en-US" sz="2000" dirty="0"/>
-          </a:p>
-          <a:p>
-            <a:pPr marL="342900" indent="-342900">
-              <a:spcAft>
-                <a:spcPts val="1400"/>
-              </a:spcAft>
-              <a:buSzPct val="100000"/>
-              <a:buChar char="•"/>
-            </a:pPr>
-            <a:r>
-              <a:rPr lang="en-US" sz="2000" dirty="0">
-                <a:solidFill>
-                  <a:srgbClr val="1F2933"/>
-                </a:solidFill>
-                <a:latin typeface="Calibri" pitchFamily="34" charset="0"/>
-                <a:ea typeface="Calibri" pitchFamily="34" charset="-122"/>
-                <a:cs typeface="Calibri" pitchFamily="34" charset="-120"/>
-              </a:rPr>
-              <a:t>The stitching half — Tiles to Pyramid — you can install and use today, no microscope needed</a:t>
-            </a:r>
-            <a:endParaRPr lang="en-US" sz="2000" dirty="0"/>
-          </a:p>
-        </p:txBody>
-      </p:sp>
-      <p:sp>
-        <p:nvSpPr>
-          <p:cNvPr id="7" name="Shape 5"/>
-          <p:cNvSpPr/>
-          <p:nvPr/>
-        </p:nvSpPr>
-        <p:spPr>
-          <a:xfrm>
-            <a:off x="566928" y="5650992"/>
-            <a:ext cx="11055096" cy="566928"/>
-          </a:xfrm>
-          <a:prstGeom prst="rect">
-            <a:avLst/>
-          </a:prstGeom>
-          <a:solidFill>
-            <a:srgbClr val="F4F8FD"/>
-          </a:solidFill>
-          <a:ln w="9525">
-            <a:solidFill>
-              <a:srgbClr val="3674C1"/>
-            </a:solidFill>
-            <a:prstDash val="solid"/>
-          </a:ln>
-        </p:spPr>
-      </p:sp>
-      <p:sp>
-        <p:nvSpPr>
-          <p:cNvPr id="8" name="Text 6"/>
-          <p:cNvSpPr/>
-          <p:nvPr/>
-        </p:nvSpPr>
-        <p:spPr>
-          <a:xfrm>
-            <a:off x="768096" y="5650992"/>
-            <a:ext cx="10652760" cy="566928"/>
-          </a:xfrm>
-          <a:prstGeom prst="rect">
-            <a:avLst/>
-          </a:prstGeom>
-          <a:noFill/>
-          <a:ln/>
-        </p:spPr>
-        <p:txBody>
-          <a:bodyPr wrap="square" rtlCol="0" anchor="ctr"/>
-          <a:lstStyle/>
-          <a:p>
-            <a:pPr indent="0" marL="0">
-              <a:buNone/>
-            </a:pPr>
-            <a:r>
-              <a:rPr lang="en-US" sz="1600" b="1" dirty="0">
-                <a:solidFill>
-                  <a:srgbClr val="1F4C86"/>
-                </a:solidFill>
-                <a:latin typeface="Calibri" pitchFamily="34" charset="0"/>
-                <a:ea typeface="Calibri" pitchFamily="34" charset="-122"/>
-                <a:cs typeface="Calibri" pitchFamily="34" charset="-120"/>
-              </a:rPr>
-              <a:t>You watch this one: it needs a microscope, so nobody in the room runs it. About five minutes, with a recorded fallback if the network or the hardware disagrees.</a:t>
-            </a:r>
-            <a:endParaRPr lang="en-US" sz="1600" dirty="0"/>
-          </a:p>
-        </p:txBody>
-      </p:sp>
-      <p:sp>
-        <p:nvSpPr>
-          <p:cNvPr id="9" name="Text 7"/>
+        </p:txBody>
+      </p:sp>
+      <p:sp>
+        <p:nvSpPr>
+          <p:cNvPr id="6" name="Text 4"/>
           <p:cNvSpPr/>
           <p:nvPr/>
         </p:nvSpPr>
@@ -19025,14 +19078,41 @@
       </p:grpSpPr>
       <p:sp>
         <p:nvSpPr>
-          <p:cNvPr id="2" name="Text 0"/>
+          <p:cNvPr id="2" name="Shape 0"/>
           <p:cNvSpPr/>
           <p:nvPr/>
         </p:nvSpPr>
         <p:spPr>
           <a:xfrm>
             <a:off x="566928" y="411480"/>
-            <a:ext cx="11055096" cy="685800"/>
+            <a:ext cx="2331720" cy="457200"/>
+          </a:xfrm>
+          <a:prstGeom prst="roundRect">
+            <a:avLst>
+              <a:gd name="adj" fmla="val 20000"/>
+            </a:avLst>
+          </a:prstGeom>
+          <a:solidFill>
+            <a:srgbClr val="FBF1E0"/>
+          </a:solidFill>
+          <a:ln w="12700">
+            <a:solidFill>
+              <a:srgbClr val="B26A00"/>
+            </a:solidFill>
+            <a:prstDash val="solid"/>
+          </a:ln>
+        </p:spPr>
+      </p:sp>
+      <p:sp>
+        <p:nvSpPr>
+          <p:cNvPr id="3" name="Text 1"/>
+          <p:cNvSpPr/>
+          <p:nvPr/>
+        </p:nvSpPr>
+        <p:spPr>
+          <a:xfrm>
+            <a:off x="566928" y="411480"/>
+            <a:ext cx="2331720" cy="457200"/>
           </a:xfrm>
           <a:prstGeom prst="rect">
             <a:avLst/>
@@ -19044,19 +19124,58 @@
           <a:bodyPr wrap="square" rtlCol="0" anchor="ctr"/>
           <a:lstStyle/>
           <a:p>
-            <a:pPr indent="0" marL="0">
+            <a:pPr algn="ctr" indent="0" marL="0">
               <a:buNone/>
             </a:pPr>
             <a:r>
-              <a:rPr lang="en-US" sz="3200" b="1" dirty="0">
-                <a:solidFill>
-                  <a:srgbClr val="1F4C86"/>
+              <a:rPr lang="en-US" sz="1600" b="1" dirty="0">
+                <a:solidFill>
+                  <a:srgbClr val="B26A00"/>
                 </a:solidFill>
                 <a:latin typeface="Trebuchet MS" pitchFamily="34" charset="0"/>
                 <a:ea typeface="Trebuchet MS" pitchFamily="34" charset="-122"/>
                 <a:cs typeface="Trebuchet MS" pitchFamily="34" charset="-120"/>
               </a:rPr>
-              <a:t>Acknowledgements</a:t>
+              <a:t>▶  SHOWN  ·  NOT YOURS TO RUN</a:t>
+            </a:r>
+            <a:endParaRPr lang="en-US" sz="1600" dirty="0"/>
+          </a:p>
+        </p:txBody>
+      </p:sp>
+      <p:sp>
+        <p:nvSpPr>
+          <p:cNvPr id="4" name="Text 2"/>
+          <p:cNvSpPr/>
+          <p:nvPr/>
+        </p:nvSpPr>
+        <p:spPr>
+          <a:xfrm>
+            <a:off x="566928" y="1024128"/>
+            <a:ext cx="11055096" cy="685800"/>
+          </a:xfrm>
+          <a:prstGeom prst="rect">
+            <a:avLst/>
+          </a:prstGeom>
+          <a:noFill/>
+          <a:ln/>
+        </p:spPr>
+        <p:txBody>
+          <a:bodyPr wrap="square" rtlCol="0" anchor="ctr"/>
+          <a:lstStyle/>
+          <a:p>
+            <a:pPr indent="0" marL="0">
+              <a:buNone/>
+            </a:pPr>
+            <a:r>
+              <a:rPr lang="en-US" sz="3200" b="1" dirty="0">
+                <a:solidFill>
+                  <a:srgbClr val="1F4C86"/>
+                </a:solidFill>
+                <a:latin typeface="Trebuchet MS" pitchFamily="34" charset="0"/>
+                <a:ea typeface="Trebuchet MS" pitchFamily="34" charset="-122"/>
+                <a:cs typeface="Trebuchet MS" pitchFamily="34" charset="-120"/>
+              </a:rPr>
+              <a:t>Acquisition, live</a:t>
             </a:r>
             <a:endParaRPr lang="en-US" sz="3200" dirty="0"/>
           </a:p>
@@ -19064,13 +19183,13 @@
       </p:sp>
       <p:sp>
         <p:nvSpPr>
-          <p:cNvPr id="3" name="Shape 1"/>
-          <p:cNvSpPr/>
-          <p:nvPr/>
-        </p:nvSpPr>
-        <p:spPr>
-          <a:xfrm>
-            <a:off x="566928" y="1152144"/>
+          <p:cNvPr id="5" name="Shape 3"/>
+          <p:cNvSpPr/>
+          <p:nvPr/>
+        </p:nvSpPr>
+        <p:spPr>
+          <a:xfrm>
+            <a:off x="566928" y="1783080"/>
             <a:ext cx="1920240" cy="50292"/>
           </a:xfrm>
           <a:prstGeom prst="rect">
@@ -19084,54 +19203,166 @@
       </p:sp>
       <p:sp>
         <p:nvSpPr>
-          <p:cNvPr id="4" name="Shape 2"/>
-          <p:cNvSpPr/>
-          <p:nvPr/>
-        </p:nvSpPr>
-        <p:spPr>
-          <a:xfrm>
-            <a:off x="566928" y="1572768"/>
-            <a:ext cx="11055096" cy="2240280"/>
+          <p:cNvPr id="6" name="Text 4"/>
+          <p:cNvSpPr/>
+          <p:nvPr/>
+        </p:nvSpPr>
+        <p:spPr>
+          <a:xfrm>
+            <a:off x="640080" y="2103120"/>
+            <a:ext cx="10963656" cy="3017520"/>
+          </a:xfrm>
+          <a:prstGeom prst="rect">
+            <a:avLst/>
+          </a:prstGeom>
+          <a:noFill/>
+          <a:ln/>
+        </p:spPr>
+        <p:txBody>
+          <a:bodyPr wrap="square" rtlCol="0" anchor="t"/>
+          <a:lstStyle/>
+          <a:p>
+            <a:pPr marL="342900" indent="-342900">
+              <a:spcAft>
+                <a:spcPts val="1400"/>
+              </a:spcAft>
+              <a:buSzPct val="100000"/>
+              <a:buChar char="•"/>
+            </a:pPr>
+            <a:r>
+              <a:rPr lang="en-US" sz="2000" dirty="0">
+                <a:solidFill>
+                  <a:srgbClr val="1F2933"/>
+                </a:solidFill>
+                <a:latin typeface="Calibri" pitchFamily="34" charset="0"/>
+                <a:ea typeface="Calibri" pitchFamily="34" charset="-122"/>
+                <a:cs typeface="Calibri" pitchFamily="34" charset="-120"/>
+              </a:rPr>
+              <a:t>Draw a bounding box on a slide overview</a:t>
+            </a:r>
+            <a:endParaRPr lang="en-US" sz="2000" dirty="0"/>
+          </a:p>
+          <a:p>
+            <a:pPr marL="342900" indent="-342900">
+              <a:spcAft>
+                <a:spcPts val="1400"/>
+              </a:spcAft>
+              <a:buSzPct val="100000"/>
+              <a:buChar char="•"/>
+            </a:pPr>
+            <a:r>
+              <a:rPr lang="en-US" sz="2000" dirty="0">
+                <a:solidFill>
+                  <a:srgbClr val="1F2933"/>
+                </a:solidFill>
+                <a:latin typeface="Calibri" pitchFamily="34" charset="0"/>
+                <a:ea typeface="Calibri" pitchFamily="34" charset="-122"/>
+                <a:cs typeface="Calibri" pitchFamily="34" charset="-120"/>
+              </a:rPr>
+              <a:t>Watch the stage move and the tiles come in</a:t>
+            </a:r>
+            <a:endParaRPr lang="en-US" sz="2000" dirty="0"/>
+          </a:p>
+          <a:p>
+            <a:pPr marL="342900" indent="-342900">
+              <a:spcAft>
+                <a:spcPts val="1400"/>
+              </a:spcAft>
+              <a:buSzPct val="100000"/>
+              <a:buChar char="•"/>
+            </a:pPr>
+            <a:r>
+              <a:rPr lang="en-US" sz="2000" dirty="0">
+                <a:solidFill>
+                  <a:srgbClr val="1F2933"/>
+                </a:solidFill>
+                <a:latin typeface="Calibri" pitchFamily="34" charset="0"/>
+                <a:ea typeface="Calibri" pitchFamily="34" charset="-122"/>
+                <a:cs typeface="Calibri" pitchFamily="34" charset="-120"/>
+              </a:rPr>
+              <a:t>Stitched pyramidal image lands back in the project, with its metadata</a:t>
+            </a:r>
+            <a:endParaRPr lang="en-US" sz="2000" dirty="0"/>
+          </a:p>
+          <a:p>
+            <a:pPr marL="342900" indent="-342900">
+              <a:spcAft>
+                <a:spcPts val="1400"/>
+              </a:spcAft>
+              <a:buSzPct val="100000"/>
+              <a:buChar char="•"/>
+            </a:pPr>
+            <a:r>
+              <a:rPr lang="en-US" sz="2000" dirty="0">
+                <a:solidFill>
+                  <a:srgbClr val="1F2933"/>
+                </a:solidFill>
+                <a:latin typeface="Calibri" pitchFamily="34" charset="0"/>
+                <a:ea typeface="Calibri" pitchFamily="34" charset="-122"/>
+                <a:cs typeface="Calibri" pitchFamily="34" charset="-120"/>
+              </a:rPr>
+              <a:t>Then open it and annotate it — the loop closes</a:t>
+            </a:r>
+            <a:endParaRPr lang="en-US" sz="2000" dirty="0"/>
+          </a:p>
+          <a:p>
+            <a:pPr marL="342900" indent="-342900">
+              <a:spcAft>
+                <a:spcPts val="1400"/>
+              </a:spcAft>
+              <a:buSzPct val="100000"/>
+              <a:buChar char="•"/>
+            </a:pPr>
+            <a:r>
+              <a:rPr lang="en-US" sz="2000" dirty="0">
+                <a:solidFill>
+                  <a:srgbClr val="1F2933"/>
+                </a:solidFill>
+                <a:latin typeface="Calibri" pitchFamily="34" charset="0"/>
+                <a:ea typeface="Calibri" pitchFamily="34" charset="-122"/>
+                <a:cs typeface="Calibri" pitchFamily="34" charset="-120"/>
+              </a:rPr>
+              <a:t>The stitching half — Tiles to Pyramid — you can install and use today, no microscope needed</a:t>
+            </a:r>
+            <a:endParaRPr lang="en-US" sz="2000" dirty="0"/>
+          </a:p>
+        </p:txBody>
+      </p:sp>
+      <p:sp>
+        <p:nvSpPr>
+          <p:cNvPr id="7" name="Shape 5"/>
+          <p:cNvSpPr/>
+          <p:nvPr/>
+        </p:nvSpPr>
+        <p:spPr>
+          <a:xfrm>
+            <a:off x="566928" y="5650992"/>
+            <a:ext cx="11055096" cy="566928"/>
           </a:xfrm>
           <a:prstGeom prst="rect">
             <a:avLst/>
           </a:prstGeom>
           <a:solidFill>
-            <a:srgbClr val="E8F0FA"/>
+            <a:srgbClr val="F4F8FD"/>
           </a:solidFill>
-          <a:ln/>
-        </p:spPr>
-      </p:sp>
-      <p:sp>
-        <p:nvSpPr>
-          <p:cNvPr id="5" name="Shape 3"/>
-          <p:cNvSpPr/>
-          <p:nvPr/>
-        </p:nvSpPr>
-        <p:spPr>
-          <a:xfrm>
-            <a:off x="566928" y="1572768"/>
-            <a:ext cx="146304" cy="2240280"/>
-          </a:xfrm>
-          <a:prstGeom prst="rect">
-            <a:avLst/>
-          </a:prstGeom>
-          <a:solidFill>
-            <a:srgbClr val="3674C1"/>
-          </a:solidFill>
-          <a:ln/>
-        </p:spPr>
-      </p:sp>
-      <p:sp>
-        <p:nvSpPr>
-          <p:cNvPr id="6" name="Text 4"/>
-          <p:cNvSpPr/>
-          <p:nvPr/>
-        </p:nvSpPr>
-        <p:spPr>
-          <a:xfrm>
-            <a:off x="978408" y="1737360"/>
-            <a:ext cx="10232136" cy="365760"/>
+          <a:ln w="9525">
+            <a:solidFill>
+              <a:srgbClr val="3674C1"/>
+            </a:solidFill>
+            <a:prstDash val="solid"/>
+          </a:ln>
+        </p:spPr>
+      </p:sp>
+      <p:sp>
+        <p:nvSpPr>
+          <p:cNvPr id="8" name="Text 6"/>
+          <p:cNvSpPr/>
+          <p:nvPr/>
+        </p:nvSpPr>
+        <p:spPr>
+          <a:xfrm>
+            <a:off x="768096" y="5650992"/>
+            <a:ext cx="10652760" cy="566928"/>
           </a:xfrm>
           <a:prstGeom prst="rect">
             <a:avLst/>
@@ -19147,15 +19378,15 @@
               <a:buNone/>
             </a:pPr>
             <a:r>
-              <a:rPr lang="en-US" sz="1600" b="1" spc="150" kern="0" dirty="0">
-                <a:solidFill>
-                  <a:srgbClr val="3674C1"/>
-                </a:solidFill>
-                <a:latin typeface="Calibri" pitchFamily="34" charset="0"/>
-                <a:ea typeface="Calibri" pitchFamily="34" charset="-122"/>
-                <a:cs typeface="Calibri" pitchFamily="34" charset="-120"/>
-              </a:rPr>
-              <a:t>Sample data</a:t>
+              <a:rPr lang="en-US" sz="1600" b="1" dirty="0">
+                <a:solidFill>
+                  <a:srgbClr val="1F4C86"/>
+                </a:solidFill>
+                <a:latin typeface="Calibri" pitchFamily="34" charset="0"/>
+                <a:ea typeface="Calibri" pitchFamily="34" charset="-122"/>
+                <a:cs typeface="Calibri" pitchFamily="34" charset="-120"/>
+              </a:rPr>
+              <a:t>You watch this one: it needs a microscope, so nobody in the room runs it. About five minutes, with a recorded fallback if the network or the hardware disagrees.</a:t>
             </a:r>
             <a:endParaRPr lang="en-US" sz="1600" dirty="0"/>
           </a:p>
@@ -19163,222 +19394,7 @@
       </p:sp>
       <p:sp>
         <p:nvSpPr>
-          <p:cNvPr id="7" name="Text 5"/>
-          <p:cNvSpPr/>
-          <p:nvPr/>
-        </p:nvSpPr>
-        <p:spPr>
-          <a:xfrm>
-            <a:off x="978408" y="2103120"/>
-            <a:ext cx="10232136" cy="566928"/>
-          </a:xfrm>
-          <a:prstGeom prst="rect">
-            <a:avLst/>
-          </a:prstGeom>
-          <a:noFill/>
-          <a:ln/>
-        </p:spPr>
-        <p:txBody>
-          <a:bodyPr wrap="square" rtlCol="0" anchor="ctr"/>
-          <a:lstStyle/>
-          <a:p>
-            <a:pPr indent="0" marL="0">
-              <a:buNone/>
-            </a:pPr>
-            <a:r>
-              <a:rPr lang="en-US" sz="3200" b="1" dirty="0">
-                <a:solidFill>
-                  <a:srgbClr val="1F4C86"/>
-                </a:solidFill>
-                <a:latin typeface="Trebuchet MS" pitchFamily="34" charset="0"/>
-                <a:ea typeface="Trebuchet MS" pitchFamily="34" charset="-122"/>
-                <a:cs typeface="Trebuchet MS" pitchFamily="34" charset="-120"/>
-              </a:rPr>
-              <a:t>Sara McArdle  ·  Zbigniew Mikulski</a:t>
-            </a:r>
-            <a:endParaRPr lang="en-US" sz="3200" dirty="0"/>
-          </a:p>
-        </p:txBody>
-      </p:sp>
-      <p:sp>
-        <p:nvSpPr>
-          <p:cNvPr id="8" name="Text 6"/>
-          <p:cNvSpPr/>
-          <p:nvPr/>
-        </p:nvSpPr>
-        <p:spPr>
-          <a:xfrm>
-            <a:off x="978408" y="2670048"/>
-            <a:ext cx="10232136" cy="384048"/>
-          </a:xfrm>
-          <a:prstGeom prst="rect">
-            <a:avLst/>
-          </a:prstGeom>
-          <a:noFill/>
-          <a:ln/>
-        </p:spPr>
-        <p:txBody>
-          <a:bodyPr wrap="square" rtlCol="0" anchor="ctr"/>
-          <a:lstStyle/>
-          <a:p>
-            <a:pPr indent="0" marL="0">
-              <a:buNone/>
-            </a:pPr>
-            <a:r>
-              <a:rPr lang="en-US" sz="2100" dirty="0">
-                <a:solidFill>
-                  <a:srgbClr val="1F2933"/>
-                </a:solidFill>
-                <a:latin typeface="Calibri" pitchFamily="34" charset="0"/>
-                <a:ea typeface="Calibri" pitchFamily="34" charset="-122"/>
-                <a:cs typeface="Calibri" pitchFamily="34" charset="-120"/>
-              </a:rPr>
-              <a:t>La Jolla Institute for Immunology</a:t>
-            </a:r>
-            <a:endParaRPr lang="en-US" sz="2100" dirty="0"/>
-          </a:p>
-        </p:txBody>
-      </p:sp>
-      <p:sp>
-        <p:nvSpPr>
           <p:cNvPr id="9" name="Text 7"/>
-          <p:cNvSpPr/>
-          <p:nvPr/>
-        </p:nvSpPr>
-        <p:spPr>
-          <a:xfrm>
-            <a:off x="978408" y="3054096"/>
-            <a:ext cx="10232136" cy="731520"/>
-          </a:xfrm>
-          <a:prstGeom prst="rect">
-            <a:avLst/>
-          </a:prstGeom>
-          <a:noFill/>
-          <a:ln/>
-        </p:spPr>
-        <p:txBody>
-          <a:bodyPr wrap="square" rtlCol="0" anchor="ctr"/>
-          <a:lstStyle/>
-          <a:p>
-            <a:pPr indent="0" marL="0">
-              <a:lnSpc>
-                <a:spcPct val="110000"/>
-              </a:lnSpc>
-              <a:buNone/>
-            </a:pPr>
-            <a:r>
-              <a:rPr lang="en-US" sz="1700" i="1" dirty="0">
-                <a:solidFill>
-                  <a:srgbClr val="5A6675"/>
-                </a:solidFill>
-                <a:latin typeface="Calibri" pitchFamily="34" charset="0"/>
-                <a:ea typeface="Calibri" pitchFamily="34" charset="-122"/>
-                <a:cs typeface="Calibri" pitchFamily="34" charset="-120"/>
-              </a:rPr>
-              <a:t>They provided the majority of the test and demonstration data behind almost every exercise you will see today.</a:t>
-            </a:r>
-            <a:endParaRPr lang="en-US" sz="1700" dirty="0"/>
-          </a:p>
-          <a:p>
-            <a:pPr indent="0" marL="0">
-              <a:lnSpc>
-                <a:spcPct val="110000"/>
-              </a:lnSpc>
-              <a:buNone/>
-            </a:pPr>
-            <a:r>
-              <a:rPr lang="en-US" sz="1700" i="1" dirty="0">
-                <a:solidFill>
-                  <a:srgbClr val="5A6675"/>
-                </a:solidFill>
-                <a:latin typeface="Calibri" pitchFamily="34" charset="0"/>
-                <a:ea typeface="Calibri" pitchFamily="34" charset="-122"/>
-                <a:cs typeface="Calibri" pitchFamily="34" charset="-120"/>
-              </a:rPr>
-              <a:t>These tools could not have been built, tested, or taught without it.</a:t>
-            </a:r>
-            <a:endParaRPr lang="en-US" sz="1700" dirty="0"/>
-          </a:p>
-        </p:txBody>
-      </p:sp>
-      <p:sp>
-        <p:nvSpPr>
-          <p:cNvPr id="10" name="Text 8"/>
-          <p:cNvSpPr/>
-          <p:nvPr/>
-        </p:nvSpPr>
-        <p:spPr>
-          <a:xfrm>
-            <a:off x="566928" y="3977640"/>
-            <a:ext cx="11055096" cy="2103120"/>
-          </a:xfrm>
-          <a:prstGeom prst="rect">
-            <a:avLst/>
-          </a:prstGeom>
-          <a:noFill/>
-          <a:ln/>
-        </p:spPr>
-        <p:txBody>
-          <a:bodyPr wrap="square" rtlCol="0" anchor="t"/>
-          <a:lstStyle/>
-          <a:p>
-            <a:pPr indent="0" marL="0">
-              <a:spcAft>
-                <a:spcPts val="1000"/>
-              </a:spcAft>
-              <a:buNone/>
-            </a:pPr>
-            <a:r>
-              <a:rPr lang="en-US" sz="1700" dirty="0">
-                <a:solidFill>
-                  <a:srgbClr val="1F2933"/>
-                </a:solidFill>
-                <a:latin typeface="Calibri" pitchFamily="34" charset="0"/>
-                <a:ea typeface="Calibri" pitchFamily="34" charset="-122"/>
-                <a:cs typeface="Calibri" pitchFamily="34" charset="-120"/>
-              </a:rPr>
-              <a:t>Sara McArdle also shaped the software directly — two of these extensions began as her Groovy scripts, and her FS2K course was the model for how the workshop pages are written.
-</a:t>
-            </a:r>
-            <a:pPr indent="0" marL="0">
-              <a:spcAft>
-                <a:spcPts val="1000"/>
-              </a:spcAft>
-              <a:buNone/>
-            </a:pPr>
-            <a:r>
-              <a:rPr lang="en-US" sz="1700" dirty="0">
-                <a:solidFill>
-                  <a:srgbClr val="1F2933"/>
-                </a:solidFill>
-                <a:latin typeface="Calibri" pitchFamily="34" charset="0"/>
-                <a:ea typeface="Calibri" pitchFamily="34" charset="-122"/>
-                <a:cs typeface="Calibri" pitchFamily="34" charset="-120"/>
-              </a:rPr>
-              <a:t>Kristin Gallick, whose concept and scripts the Confusion Matrix grew from.  ·  Pete Bankhead and the QuPath team.  ·  CT-FIRE, CurveAlign, TACS and TWOMBLI for the fibre work.  ·  CytoMAP and QuBaLab for bringing clustering into QuPath.  ·  QUAREP-LiMi for the reporting standards.  ·  The image.sc community, where several of these features were first requested.
-</a:t>
-            </a:r>
-            <a:pPr indent="0" marL="0">
-              <a:buNone/>
-            </a:pPr>
-            <a:r>
-              <a:rPr lang="en-US" sz="1700" b="1" dirty="0">
-                <a:solidFill>
-                  <a:srgbClr val="1F4C86"/>
-                </a:solidFill>
-                <a:latin typeface="Calibri" pitchFamily="34" charset="0"/>
-                <a:ea typeface="Calibri" pitchFamily="34" charset="-122"/>
-                <a:cs typeface="Calibri" pitchFamily="34" charset="-120"/>
-              </a:rPr>
-              <a:t>Full credits: michaelsnelson.github.io/BINA-I2K-2026-QuPath-Extensions/docs/acknowledgements.html</a:t>
-            </a:r>
-            <a:endParaRPr lang="en-US" sz="1700" dirty="0"/>
-          </a:p>
-        </p:txBody>
-      </p:sp>
-      <p:sp>
-        <p:nvSpPr>
-          <p:cNvPr id="11" name="Text 9"/>
           <p:cNvSpPr/>
           <p:nvPr/>
         </p:nvSpPr>
@@ -19657,7 +19673,7 @@
                 <a:ea typeface="Calibri" pitchFamily="34" charset="-122"/>
                 <a:cs typeface="Calibri" pitchFamily="34" charset="-120"/>
               </a:rPr>
-              <a:t>A few slots are fixed; Sara McArdle presents two of them in her session</a:t>
+              <a:t>A few slots are fixed; two more were covered in Sara McArdle’s session this morning</a:t>
             </a:r>
             <a:endParaRPr lang="en-US" sz="2000" dirty="0"/>
           </a:p>
@@ -19824,14 +19840,53 @@
       </p:grpSpPr>
       <p:sp>
         <p:nvSpPr>
-          <p:cNvPr id="2" name="Shape 0"/>
-          <p:cNvSpPr/>
-          <p:nvPr/>
-        </p:nvSpPr>
-        <p:spPr>
-          <a:xfrm>
-            <a:off x="0" y="0"/>
-            <a:ext cx="274320" cy="6858000"/>
+          <p:cNvPr id="2" name="Text 0"/>
+          <p:cNvSpPr/>
+          <p:nvPr/>
+        </p:nvSpPr>
+        <p:spPr>
+          <a:xfrm>
+            <a:off x="566928" y="411480"/>
+            <a:ext cx="11055096" cy="685800"/>
+          </a:xfrm>
+          <a:prstGeom prst="rect">
+            <a:avLst/>
+          </a:prstGeom>
+          <a:noFill/>
+          <a:ln/>
+        </p:spPr>
+        <p:txBody>
+          <a:bodyPr wrap="square" rtlCol="0" anchor="ctr"/>
+          <a:lstStyle/>
+          <a:p>
+            <a:pPr indent="0" marL="0">
+              <a:buNone/>
+            </a:pPr>
+            <a:r>
+              <a:rPr lang="en-US" sz="3200" b="1" dirty="0">
+                <a:solidFill>
+                  <a:srgbClr val="1F4C86"/>
+                </a:solidFill>
+                <a:latin typeface="Trebuchet MS" pitchFamily="34" charset="0"/>
+                <a:ea typeface="Trebuchet MS" pitchFamily="34" charset="-122"/>
+                <a:cs typeface="Trebuchet MS" pitchFamily="34" charset="-120"/>
+              </a:rPr>
+              <a:t>Acknowledgements</a:t>
+            </a:r>
+            <a:endParaRPr lang="en-US" sz="3200" dirty="0"/>
+          </a:p>
+        </p:txBody>
+      </p:sp>
+      <p:sp>
+        <p:nvSpPr>
+          <p:cNvPr id="3" name="Shape 1"/>
+          <p:cNvSpPr/>
+          <p:nvPr/>
+        </p:nvSpPr>
+        <p:spPr>
+          <a:xfrm>
+            <a:off x="566928" y="1152144"/>
+            <a:ext cx="1920240" cy="50292"/>
           </a:xfrm>
           <a:prstGeom prst="rect">
             <a:avLst/>
@@ -19844,14 +19899,54 @@
       </p:sp>
       <p:sp>
         <p:nvSpPr>
-          <p:cNvPr id="3" name="Text 1"/>
-          <p:cNvSpPr/>
-          <p:nvPr/>
-        </p:nvSpPr>
-        <p:spPr>
-          <a:xfrm>
-            <a:off x="960120" y="777240"/>
-            <a:ext cx="10268712" cy="822960"/>
+          <p:cNvPr id="4" name="Shape 2"/>
+          <p:cNvSpPr/>
+          <p:nvPr/>
+        </p:nvSpPr>
+        <p:spPr>
+          <a:xfrm>
+            <a:off x="566928" y="1572768"/>
+            <a:ext cx="11055096" cy="2240280"/>
+          </a:xfrm>
+          <a:prstGeom prst="rect">
+            <a:avLst/>
+          </a:prstGeom>
+          <a:solidFill>
+            <a:srgbClr val="E8F0FA"/>
+          </a:solidFill>
+          <a:ln/>
+        </p:spPr>
+      </p:sp>
+      <p:sp>
+        <p:nvSpPr>
+          <p:cNvPr id="5" name="Shape 3"/>
+          <p:cNvSpPr/>
+          <p:nvPr/>
+        </p:nvSpPr>
+        <p:spPr>
+          <a:xfrm>
+            <a:off x="566928" y="1572768"/>
+            <a:ext cx="146304" cy="2240280"/>
+          </a:xfrm>
+          <a:prstGeom prst="rect">
+            <a:avLst/>
+          </a:prstGeom>
+          <a:solidFill>
+            <a:srgbClr val="3674C1"/>
+          </a:solidFill>
+          <a:ln/>
+        </p:spPr>
+      </p:sp>
+      <p:sp>
+        <p:nvSpPr>
+          <p:cNvPr id="6" name="Text 4"/>
+          <p:cNvSpPr/>
+          <p:nvPr/>
+        </p:nvSpPr>
+        <p:spPr>
+          <a:xfrm>
+            <a:off x="978408" y="1737360"/>
+            <a:ext cx="10232136" cy="365760"/>
           </a:xfrm>
           <a:prstGeom prst="rect">
             <a:avLst/>
@@ -19867,7 +19962,46 @@
               <a:buNone/>
             </a:pPr>
             <a:r>
-              <a:rPr lang="en-US" sz="4000" b="1" dirty="0">
+              <a:rPr lang="en-US" sz="1600" b="1" spc="150" kern="0" dirty="0">
+                <a:solidFill>
+                  <a:srgbClr val="3674C1"/>
+                </a:solidFill>
+                <a:latin typeface="Calibri" pitchFamily="34" charset="0"/>
+                <a:ea typeface="Calibri" pitchFamily="34" charset="-122"/>
+                <a:cs typeface="Calibri" pitchFamily="34" charset="-120"/>
+              </a:rPr>
+              <a:t>Sample data</a:t>
+            </a:r>
+            <a:endParaRPr lang="en-US" sz="1600" dirty="0"/>
+          </a:p>
+        </p:txBody>
+      </p:sp>
+      <p:sp>
+        <p:nvSpPr>
+          <p:cNvPr id="7" name="Text 5"/>
+          <p:cNvSpPr/>
+          <p:nvPr/>
+        </p:nvSpPr>
+        <p:spPr>
+          <a:xfrm>
+            <a:off x="978408" y="2103120"/>
+            <a:ext cx="10232136" cy="566928"/>
+          </a:xfrm>
+          <a:prstGeom prst="rect">
+            <a:avLst/>
+          </a:prstGeom>
+          <a:noFill/>
+          <a:ln/>
+        </p:spPr>
+        <p:txBody>
+          <a:bodyPr wrap="square" rtlCol="0" anchor="ctr"/>
+          <a:lstStyle/>
+          <a:p>
+            <a:pPr indent="0" marL="0">
+              <a:buNone/>
+            </a:pPr>
+            <a:r>
+              <a:rPr lang="en-US" sz="3200" b="1" dirty="0">
                 <a:solidFill>
                   <a:srgbClr val="1F4C86"/>
                 </a:solidFill>
@@ -19875,42 +20009,22 @@
                 <a:ea typeface="Trebuchet MS" pitchFamily="34" charset="-122"/>
                 <a:cs typeface="Trebuchet MS" pitchFamily="34" charset="-120"/>
               </a:rPr>
-              <a:t>Everything is here</a:t>
-            </a:r>
-            <a:endParaRPr lang="en-US" sz="4000" dirty="0"/>
-          </a:p>
-        </p:txBody>
-      </p:sp>
-      <p:sp>
-        <p:nvSpPr>
-          <p:cNvPr id="4" name="Shape 2"/>
-          <p:cNvSpPr/>
-          <p:nvPr/>
-        </p:nvSpPr>
-        <p:spPr>
-          <a:xfrm>
-            <a:off x="960120" y="1691640"/>
-            <a:ext cx="8686800" cy="713232"/>
-          </a:xfrm>
-          <a:prstGeom prst="rect">
-            <a:avLst/>
-          </a:prstGeom>
-          <a:solidFill>
-            <a:srgbClr val="E8F0FA"/>
-          </a:solidFill>
-          <a:ln/>
-        </p:spPr>
-      </p:sp>
-      <p:sp>
-        <p:nvSpPr>
-          <p:cNvPr id="5" name="Text 3"/>
-          <p:cNvSpPr/>
-          <p:nvPr/>
-        </p:nvSpPr>
-        <p:spPr>
-          <a:xfrm>
-            <a:off x="1188720" y="1691640"/>
-            <a:ext cx="8412480" cy="713232"/>
+              <a:t>Sara McArdle  ·  Zbigniew Mikulski</a:t>
+            </a:r>
+            <a:endParaRPr lang="en-US" sz="3200" dirty="0"/>
+          </a:p>
+        </p:txBody>
+      </p:sp>
+      <p:sp>
+        <p:nvSpPr>
+          <p:cNvPr id="8" name="Text 6"/>
+          <p:cNvSpPr/>
+          <p:nvPr/>
+        </p:nvSpPr>
+        <p:spPr>
+          <a:xfrm>
+            <a:off x="978408" y="2670048"/>
+            <a:ext cx="10232136" cy="384048"/>
           </a:xfrm>
           <a:prstGeom prst="rect">
             <a:avLst/>
@@ -19926,30 +20040,92 @@
               <a:buNone/>
             </a:pPr>
             <a:r>
-              <a:rPr lang="en-US" sz="2200" b="1" dirty="0">
-                <a:solidFill>
-                  <a:srgbClr val="1F4C86"/>
-                </a:solidFill>
-                <a:latin typeface="Calibri" pitchFamily="34" charset="0"/>
-                <a:ea typeface="Calibri" pitchFamily="34" charset="-122"/>
-                <a:cs typeface="Calibri" pitchFamily="34" charset="-120"/>
-              </a:rPr>
-              <a:t>michaelsnelson.github.io/BINA-I2K-2026-QuPath-Extensions</a:t>
-            </a:r>
-            <a:endParaRPr lang="en-US" sz="2200" dirty="0"/>
-          </a:p>
-        </p:txBody>
-      </p:sp>
-      <p:sp>
-        <p:nvSpPr>
-          <p:cNvPr id="6" name="Text 4"/>
-          <p:cNvSpPr/>
-          <p:nvPr/>
-        </p:nvSpPr>
-        <p:spPr>
-          <a:xfrm>
-            <a:off x="960120" y="2697480"/>
-            <a:ext cx="9811512" cy="2560320"/>
+              <a:rPr lang="en-US" sz="2100" dirty="0">
+                <a:solidFill>
+                  <a:srgbClr val="1F2933"/>
+                </a:solidFill>
+                <a:latin typeface="Calibri" pitchFamily="34" charset="0"/>
+                <a:ea typeface="Calibri" pitchFamily="34" charset="-122"/>
+                <a:cs typeface="Calibri" pitchFamily="34" charset="-120"/>
+              </a:rPr>
+              <a:t>La Jolla Institute for Immunology</a:t>
+            </a:r>
+            <a:endParaRPr lang="en-US" sz="2100" dirty="0"/>
+          </a:p>
+        </p:txBody>
+      </p:sp>
+      <p:sp>
+        <p:nvSpPr>
+          <p:cNvPr id="9" name="Text 7"/>
+          <p:cNvSpPr/>
+          <p:nvPr/>
+        </p:nvSpPr>
+        <p:spPr>
+          <a:xfrm>
+            <a:off x="978408" y="3054096"/>
+            <a:ext cx="10232136" cy="731520"/>
+          </a:xfrm>
+          <a:prstGeom prst="rect">
+            <a:avLst/>
+          </a:prstGeom>
+          <a:noFill/>
+          <a:ln/>
+        </p:spPr>
+        <p:txBody>
+          <a:bodyPr wrap="square" rtlCol="0" anchor="ctr"/>
+          <a:lstStyle/>
+          <a:p>
+            <a:pPr indent="0" marL="0">
+              <a:lnSpc>
+                <a:spcPct val="110000"/>
+              </a:lnSpc>
+              <a:buNone/>
+            </a:pPr>
+            <a:r>
+              <a:rPr lang="en-US" sz="1700" i="1" dirty="0">
+                <a:solidFill>
+                  <a:srgbClr val="5A6675"/>
+                </a:solidFill>
+                <a:latin typeface="Calibri" pitchFamily="34" charset="0"/>
+                <a:ea typeface="Calibri" pitchFamily="34" charset="-122"/>
+                <a:cs typeface="Calibri" pitchFamily="34" charset="-120"/>
+              </a:rPr>
+              <a:t>They provided the majority of the test and demonstration data behind almost every exercise you will see today.</a:t>
+            </a:r>
+            <a:endParaRPr lang="en-US" sz="1700" dirty="0"/>
+          </a:p>
+          <a:p>
+            <a:pPr indent="0" marL="0">
+              <a:lnSpc>
+                <a:spcPct val="110000"/>
+              </a:lnSpc>
+              <a:buNone/>
+            </a:pPr>
+            <a:r>
+              <a:rPr lang="en-US" sz="1700" i="1" dirty="0">
+                <a:solidFill>
+                  <a:srgbClr val="5A6675"/>
+                </a:solidFill>
+                <a:latin typeface="Calibri" pitchFamily="34" charset="0"/>
+                <a:ea typeface="Calibri" pitchFamily="34" charset="-122"/>
+                <a:cs typeface="Calibri" pitchFamily="34" charset="-120"/>
+              </a:rPr>
+              <a:t>These tools could not have been built, tested, or taught without it.</a:t>
+            </a:r>
+            <a:endParaRPr lang="en-US" sz="1700" dirty="0"/>
+          </a:p>
+        </p:txBody>
+      </p:sp>
+      <p:sp>
+        <p:nvSpPr>
+          <p:cNvPr id="10" name="Text 8"/>
+          <p:cNvSpPr/>
+          <p:nvPr/>
+        </p:nvSpPr>
+        <p:spPr>
+          <a:xfrm>
+            <a:off x="566928" y="3977640"/>
+            <a:ext cx="11055096" cy="2103120"/>
           </a:xfrm>
           <a:prstGeom prst="rect">
             <a:avLst/>
@@ -19968,6 +20144,270 @@
               <a:buNone/>
             </a:pPr>
             <a:r>
+              <a:rPr lang="en-US" sz="1700" dirty="0">
+                <a:solidFill>
+                  <a:srgbClr val="1F2933"/>
+                </a:solidFill>
+                <a:latin typeface="Calibri" pitchFamily="34" charset="0"/>
+                <a:ea typeface="Calibri" pitchFamily="34" charset="-122"/>
+                <a:cs typeface="Calibri" pitchFamily="34" charset="-120"/>
+              </a:rPr>
+              <a:t>Sara McArdle also shaped the software directly — two of these extensions began as her Groovy scripts, and her FS2K course was the model for how the workshop pages are written.
+</a:t>
+            </a:r>
+            <a:pPr indent="0" marL="0">
+              <a:spcAft>
+                <a:spcPts val="1000"/>
+              </a:spcAft>
+              <a:buNone/>
+            </a:pPr>
+            <a:r>
+              <a:rPr lang="en-US" sz="1700" dirty="0">
+                <a:solidFill>
+                  <a:srgbClr val="1F2933"/>
+                </a:solidFill>
+                <a:latin typeface="Calibri" pitchFamily="34" charset="0"/>
+                <a:ea typeface="Calibri" pitchFamily="34" charset="-122"/>
+                <a:cs typeface="Calibri" pitchFamily="34" charset="-120"/>
+              </a:rPr>
+              <a:t>Kristin Gallick, whose concept and scripts the Confusion Matrix grew from.  ·  Pete Bankhead and the QuPath team.  ·  CT-FIRE, CurveAlign, TACS and TWOMBLI for the fibre work.  ·  CytoMAP and QuBaLab for bringing clustering into QuPath.  ·  QUAREP-LiMi for the reporting standards.  ·  The image.sc community, where several of these features were first requested.
+</a:t>
+            </a:r>
+            <a:pPr indent="0" marL="0">
+              <a:buNone/>
+            </a:pPr>
+            <a:r>
+              <a:rPr lang="en-US" sz="1700" b="1" dirty="0">
+                <a:solidFill>
+                  <a:srgbClr val="1F4C86"/>
+                </a:solidFill>
+                <a:latin typeface="Calibri" pitchFamily="34" charset="0"/>
+                <a:ea typeface="Calibri" pitchFamily="34" charset="-122"/>
+                <a:cs typeface="Calibri" pitchFamily="34" charset="-120"/>
+              </a:rPr>
+              <a:t>Full credits: michaelsnelson.github.io/BINA-I2K-2026-QuPath-Extensions/docs/acknowledgements.html</a:t>
+            </a:r>
+            <a:endParaRPr lang="en-US" sz="1700" dirty="0"/>
+          </a:p>
+        </p:txBody>
+      </p:sp>
+      <p:sp>
+        <p:nvSpPr>
+          <p:cNvPr id="11" name="Text 9"/>
+          <p:cNvSpPr/>
+          <p:nvPr/>
+        </p:nvSpPr>
+        <p:spPr>
+          <a:xfrm>
+            <a:off x="11274552" y="6291072"/>
+            <a:ext cx="457200" cy="310896"/>
+          </a:xfrm>
+          <a:prstGeom prst="rect">
+            <a:avLst/>
+          </a:prstGeom>
+          <a:noFill/>
+          <a:ln/>
+        </p:spPr>
+        <p:txBody>
+          <a:bodyPr wrap="square" rtlCol="0" anchor="ctr"/>
+          <a:lstStyle/>
+          <a:p>
+            <a:pPr algn="r" indent="0" marL="0">
+              <a:buNone/>
+            </a:pPr>
+            <a:r>
+              <a:rPr lang="en-US" sz="1400" dirty="0">
+                <a:solidFill>
+                  <a:srgbClr val="A8B2BF"/>
+                </a:solidFill>
+                <a:latin typeface="Calibri" pitchFamily="34" charset="0"/>
+                <a:ea typeface="Calibri" pitchFamily="34" charset="-122"/>
+                <a:cs typeface="Calibri" pitchFamily="34" charset="-120"/>
+              </a:rPr>
+              <a:t>50</a:t>
+            </a:r>
+            <a:endParaRPr lang="en-US" sz="1400" dirty="0"/>
+          </a:p>
+        </p:txBody>
+      </p:sp>
+    </p:spTree>
+  </p:cSld>
+  <p:clrMapOvr>
+    <a:masterClrMapping/>
+  </p:clrMapOvr>
+</p:sld>
+</file>
+
+<file path=ppt/slides/slide51.xml><?xml version="1.0" encoding="utf-8"?>
+<p:sld xmlns:a="http://schemas.openxmlformats.org/drawingml/2006/main" xmlns:r="http://schemas.openxmlformats.org/officeDocument/2006/relationships" xmlns:p="http://schemas.openxmlformats.org/presentationml/2006/main">
+  <p:cSld name="Slide 51">
+    <p:bg>
+      <p:bgPr>
+        <a:solidFill>
+          <a:srgbClr val="FFFFFF"/>
+        </a:solidFill>
+      </p:bgPr>
+    </p:bg>
+    <p:spTree>
+      <p:nvGrpSpPr>
+        <p:cNvPr id="1" name=""/>
+        <p:cNvGrpSpPr/>
+        <p:nvPr/>
+      </p:nvGrpSpPr>
+      <p:grpSpPr>
+        <a:xfrm>
+          <a:off x="0" y="0"/>
+          <a:ext cx="0" cy="0"/>
+          <a:chOff x="0" y="0"/>
+          <a:chExt cx="0" cy="0"/>
+        </a:xfrm>
+      </p:grpSpPr>
+      <p:sp>
+        <p:nvSpPr>
+          <p:cNvPr id="2" name="Shape 0"/>
+          <p:cNvSpPr/>
+          <p:nvPr/>
+        </p:nvSpPr>
+        <p:spPr>
+          <a:xfrm>
+            <a:off x="0" y="0"/>
+            <a:ext cx="274320" cy="6858000"/>
+          </a:xfrm>
+          <a:prstGeom prst="rect">
+            <a:avLst/>
+          </a:prstGeom>
+          <a:solidFill>
+            <a:srgbClr val="3674C1"/>
+          </a:solidFill>
+          <a:ln/>
+        </p:spPr>
+      </p:sp>
+      <p:sp>
+        <p:nvSpPr>
+          <p:cNvPr id="3" name="Text 1"/>
+          <p:cNvSpPr/>
+          <p:nvPr/>
+        </p:nvSpPr>
+        <p:spPr>
+          <a:xfrm>
+            <a:off x="960120" y="777240"/>
+            <a:ext cx="10268712" cy="822960"/>
+          </a:xfrm>
+          <a:prstGeom prst="rect">
+            <a:avLst/>
+          </a:prstGeom>
+          <a:noFill/>
+          <a:ln/>
+        </p:spPr>
+        <p:txBody>
+          <a:bodyPr wrap="square" rtlCol="0" anchor="ctr"/>
+          <a:lstStyle/>
+          <a:p>
+            <a:pPr indent="0" marL="0">
+              <a:buNone/>
+            </a:pPr>
+            <a:r>
+              <a:rPr lang="en-US" sz="4000" b="1" dirty="0">
+                <a:solidFill>
+                  <a:srgbClr val="1F4C86"/>
+                </a:solidFill>
+                <a:latin typeface="Trebuchet MS" pitchFamily="34" charset="0"/>
+                <a:ea typeface="Trebuchet MS" pitchFamily="34" charset="-122"/>
+                <a:cs typeface="Trebuchet MS" pitchFamily="34" charset="-120"/>
+              </a:rPr>
+              <a:t>Everything is here</a:t>
+            </a:r>
+            <a:endParaRPr lang="en-US" sz="4000" dirty="0"/>
+          </a:p>
+        </p:txBody>
+      </p:sp>
+      <p:sp>
+        <p:nvSpPr>
+          <p:cNvPr id="4" name="Shape 2"/>
+          <p:cNvSpPr/>
+          <p:nvPr/>
+        </p:nvSpPr>
+        <p:spPr>
+          <a:xfrm>
+            <a:off x="960120" y="1691640"/>
+            <a:ext cx="8686800" cy="713232"/>
+          </a:xfrm>
+          <a:prstGeom prst="rect">
+            <a:avLst/>
+          </a:prstGeom>
+          <a:solidFill>
+            <a:srgbClr val="E8F0FA"/>
+          </a:solidFill>
+          <a:ln/>
+        </p:spPr>
+      </p:sp>
+      <p:sp>
+        <p:nvSpPr>
+          <p:cNvPr id="5" name="Text 3"/>
+          <p:cNvSpPr/>
+          <p:nvPr/>
+        </p:nvSpPr>
+        <p:spPr>
+          <a:xfrm>
+            <a:off x="1188720" y="1691640"/>
+            <a:ext cx="8412480" cy="713232"/>
+          </a:xfrm>
+          <a:prstGeom prst="rect">
+            <a:avLst/>
+          </a:prstGeom>
+          <a:noFill/>
+          <a:ln/>
+        </p:spPr>
+        <p:txBody>
+          <a:bodyPr wrap="square" rtlCol="0" anchor="ctr"/>
+          <a:lstStyle/>
+          <a:p>
+            <a:pPr indent="0" marL="0">
+              <a:buNone/>
+            </a:pPr>
+            <a:r>
+              <a:rPr lang="en-US" sz="2200" b="1" dirty="0">
+                <a:solidFill>
+                  <a:srgbClr val="1F4C86"/>
+                </a:solidFill>
+                <a:latin typeface="Calibri" pitchFamily="34" charset="0"/>
+                <a:ea typeface="Calibri" pitchFamily="34" charset="-122"/>
+                <a:cs typeface="Calibri" pitchFamily="34" charset="-120"/>
+              </a:rPr>
+              <a:t>michaelsnelson.github.io/BINA-I2K-2026-QuPath-Extensions</a:t>
+            </a:r>
+            <a:endParaRPr lang="en-US" sz="2200" dirty="0"/>
+          </a:p>
+        </p:txBody>
+      </p:sp>
+      <p:sp>
+        <p:nvSpPr>
+          <p:cNvPr id="6" name="Text 4"/>
+          <p:cNvSpPr/>
+          <p:nvPr/>
+        </p:nvSpPr>
+        <p:spPr>
+          <a:xfrm>
+            <a:off x="960120" y="2697480"/>
+            <a:ext cx="9811512" cy="2560320"/>
+          </a:xfrm>
+          <a:prstGeom prst="rect">
+            <a:avLst/>
+          </a:prstGeom>
+          <a:noFill/>
+          <a:ln/>
+        </p:spPr>
+        <p:txBody>
+          <a:bodyPr wrap="square" rtlCol="0" anchor="t"/>
+          <a:lstStyle/>
+          <a:p>
+            <a:pPr indent="0" marL="0">
+              <a:spcAft>
+                <a:spcPts val="1000"/>
+              </a:spcAft>
+              <a:buNone/>
+            </a:pPr>
+            <a:r>
               <a:rPr lang="en-US" sz="1900" dirty="0">
                 <a:solidFill>
                   <a:srgbClr val="1F2933"/>
@@ -20162,7 +20602,7 @@
                 <a:ea typeface="Calibri" pitchFamily="34" charset="-122"/>
                 <a:cs typeface="Calibri" pitchFamily="34" charset="-120"/>
               </a:rPr>
-              <a:t>50</a:t>
+              <a:t>51</a:t>
             </a:r>
             <a:endParaRPr lang="en-US" sz="1400" dirty="0"/>
           </a:p>
@@ -20372,7 +20812,7 @@
                 <a:ea typeface="Calibri" pitchFamily="34" charset="-122"/>
                 <a:cs typeface="Calibri" pitchFamily="34" charset="-120"/>
               </a:rPr>
-              <a:t>Already fixed: QPSC, the Confusion Matrix and the fibre tools are shown regardless — and Channel Names Viewer and Classify Object Subset belong to Sara McArdle’s session.
+              <a:t>Already fixed: QPSC, the Confusion Matrix and the fibre tools are shown regardless — and Channel Names Viewer and Classify Object Subset were covered in Sara McArdle’s session this morning.
 </a:t>
             </a:r>
             <a:pPr indent="0" marL="0">

</xml_diff>